<commit_message>
Implement Phase 6 controlled evaluation
</commit_message>
<xml_diff>
--- a/docs/Mukota_Implementation_Progress_Presentation.pptx
+++ b/docs/Mukota_Implementation_Progress_Presentation.pptx
@@ -2,24 +2,28 @@
 <file path=ppt/presentation.xml><?xml version="1.0" encoding="utf-8"?>
 <p:presentation xmlns:p="http://schemas.openxmlformats.org/presentationml/2006/main">
   <p:sldMasterIdLst>
-    <p:sldMasterId xmlns:r="http://schemas.openxmlformats.org/officeDocument/2006/relationships" id="2147483648" r:id="Rcc8fb2d71d3e4d9e"/>
+    <p:sldMasterId xmlns:r="http://schemas.openxmlformats.org/officeDocument/2006/relationships" id="2147483648" r:id="Rf4eb288985c44174"/>
   </p:sldMasterIdLst>
   <p:notesMasterIdLst>
-    <p:notesMasterId xmlns:r="http://schemas.openxmlformats.org/officeDocument/2006/relationships" r:id="R9b25193321994cb2"/>
+    <p:notesMasterId xmlns:r="http://schemas.openxmlformats.org/officeDocument/2006/relationships" r:id="Rdfbadb9e242d455a"/>
   </p:notesMasterIdLst>
   <p:sldIdLst>
-    <p:sldId xmlns:r="http://schemas.openxmlformats.org/officeDocument/2006/relationships" id="256" r:id="Rd94fcf15271b4937"/>
-    <p:sldId xmlns:r="http://schemas.openxmlformats.org/officeDocument/2006/relationships" id="257" r:id="R9cba240dde0d449d"/>
-    <p:sldId xmlns:r="http://schemas.openxmlformats.org/officeDocument/2006/relationships" id="258" r:id="Rc348f6c2c0b44825"/>
-    <p:sldId xmlns:r="http://schemas.openxmlformats.org/officeDocument/2006/relationships" id="259" r:id="Ree684c8a95924792"/>
-    <p:sldId xmlns:r="http://schemas.openxmlformats.org/officeDocument/2006/relationships" id="260" r:id="R918eaa9353ac4d04"/>
-    <p:sldId xmlns:r="http://schemas.openxmlformats.org/officeDocument/2006/relationships" id="261" r:id="Ra502e29102d94533"/>
-    <p:sldId xmlns:r="http://schemas.openxmlformats.org/officeDocument/2006/relationships" id="262" r:id="Rfca3231c71024e7b"/>
-    <p:sldId xmlns:r="http://schemas.openxmlformats.org/officeDocument/2006/relationships" id="263" r:id="Re114fb8109d347b0"/>
-    <p:sldId xmlns:r="http://schemas.openxmlformats.org/officeDocument/2006/relationships" id="264" r:id="Rbf10f8f4b903470e"/>
-    <p:sldId xmlns:r="http://schemas.openxmlformats.org/officeDocument/2006/relationships" id="265" r:id="Rc99428ce96a54a24"/>
-    <p:sldId xmlns:r="http://schemas.openxmlformats.org/officeDocument/2006/relationships" id="266" r:id="R52d8cbe632e14950"/>
-    <p:sldId xmlns:r="http://schemas.openxmlformats.org/officeDocument/2006/relationships" id="267" r:id="Rd970a748270a4ce3"/>
+    <p:sldId xmlns:r="http://schemas.openxmlformats.org/officeDocument/2006/relationships" id="256" r:id="R1ea093c315c54292"/>
+    <p:sldId xmlns:r="http://schemas.openxmlformats.org/officeDocument/2006/relationships" id="257" r:id="Raa69c6770e0f4338"/>
+    <p:sldId xmlns:r="http://schemas.openxmlformats.org/officeDocument/2006/relationships" id="258" r:id="Re1189123feb44c94"/>
+    <p:sldId xmlns:r="http://schemas.openxmlformats.org/officeDocument/2006/relationships" id="259" r:id="R6d6f83788bf24561"/>
+    <p:sldId xmlns:r="http://schemas.openxmlformats.org/officeDocument/2006/relationships" id="260" r:id="Re78b588c9e3f4770"/>
+    <p:sldId xmlns:r="http://schemas.openxmlformats.org/officeDocument/2006/relationships" id="261" r:id="R18516f0858db4c7d"/>
+    <p:sldId xmlns:r="http://schemas.openxmlformats.org/officeDocument/2006/relationships" id="262" r:id="Rca560b9ffa8d499d"/>
+    <p:sldId xmlns:r="http://schemas.openxmlformats.org/officeDocument/2006/relationships" id="263" r:id="R2b7905a249164e46"/>
+    <p:sldId xmlns:r="http://schemas.openxmlformats.org/officeDocument/2006/relationships" id="264" r:id="Ra584821974f7435f"/>
+    <p:sldId xmlns:r="http://schemas.openxmlformats.org/officeDocument/2006/relationships" id="265" r:id="Re7ca938ee1144e01"/>
+    <p:sldId xmlns:r="http://schemas.openxmlformats.org/officeDocument/2006/relationships" id="266" r:id="Rfb8d51d0a0874f29"/>
+    <p:sldId xmlns:r="http://schemas.openxmlformats.org/officeDocument/2006/relationships" id="267" r:id="R46df0c78ff194cfd"/>
+    <p:sldId xmlns:r="http://schemas.openxmlformats.org/officeDocument/2006/relationships" id="268" r:id="R593315c4a0e245b5"/>
+    <p:sldId xmlns:r="http://schemas.openxmlformats.org/officeDocument/2006/relationships" id="269" r:id="R3072c60003e74240"/>
+    <p:sldId xmlns:r="http://schemas.openxmlformats.org/officeDocument/2006/relationships" id="270" r:id="Rba3cdce7dda443f6"/>
+    <p:sldId xmlns:r="http://schemas.openxmlformats.org/officeDocument/2006/relationships" id="271" r:id="Rde706d7a04234b1b"/>
   </p:sldIdLst>
   <p:sldSz cx="12192000" cy="6858000"/>
   <p:notesSz cx="6858000" cy="9144000"/>
@@ -458,10 +462,13 @@
           </a:p>
           <a:p xmlns:a="http://schemas.openxmlformats.org/drawingml/2006/main">
             <a:r>
-              <a:t>Open by saying this is a progress update, not a claim that the entire research framework is finished. The first three planned development stages are complete and working.</a:t>
-            </a:r>
-          </a:p>
-          <a:p xmlns:a="http://schemas.openxmlformats.org/drawingml/2006/main">
+              <a:t>This update shows the completed six-step proof of concept. I will demonstrate the live controlled laboratory, then the evaluation result and the retained evidence that supports it.</a:t>
+            </a:r>
+          </a:p>
+          <a:p xmlns:a="http://schemas.openxmlformats.org/drawingml/2006/main">
+            <a:r>
+              <a:t/>
+            </a:r>
             <a:endParaRPr/>
           </a:p>
           <a:p xmlns:a="http://schemas.openxmlformats.org/drawingml/2006/main">
@@ -471,21 +478,13 @@
           </a:p>
           <a:p xmlns:a="http://schemas.openxmlformats.org/drawingml/2006/main">
             <a:r>
-              <a:t>- Proposal: Mukota LG_Makura SM.pdf.</a:t>
-            </a:r>
-          </a:p>
-          <a:p xmlns:a="http://schemas.openxmlformats.org/drawingml/2006/main">
-            <a:r>
-              <a:t>- Implementation Action Plan: Mukota_Implementation_Action_Plan.docx.</a:t>
-            </a:r>
-          </a:p>
-          <a:p xmlns:a="http://schemas.openxmlformats.org/drawingml/2006/main">
-            <a:r>
-              <a:t>Diagram hand-out:
-The revised Word document contains three diagrams only: the framework architecture, the working two-slice laboratory prototype, and the current-versus-next activity model.
-Use the diagrams as visual evidence rather than reading them line by line.</a:t>
-            </a:r>
-            <a:endParaRPr/>
+              <a:t>- Research proposal and implementation action plan.</a:t>
+            </a:r>
+          </a:p>
+          <a:p xmlns:a="http://schemas.openxmlformats.org/drawingml/2006/main">
+            <a:r>
+              <a:t>- Current Phase 6 evaluation run: artifacts/runs/phase6-20260904-184135.</a:t>
+            </a:r>
           </a:p>
         </p:txBody>
       </p:sp>
@@ -559,7 +558,7 @@
           </a:p>
           <a:p xmlns:a="http://schemas.openxmlformats.org/drawingml/2006/main">
             <a:r>
-              <a:t>Say: Phase 4 is now complete. The work that remains is intentionally separated: Phase 5 will apply an approved collection rule safely; Phase 6 will protect the history of the record and measure the result under controlled scenarios. I will not describe those later steps as complete until they have been implemented and tested.</a:t>
+              <a:t>The earlier planned steps are now complete. This table is not a future plan: it is a short evidence trail showing the outcome available for each of the final three steps. I will now demonstrate this chain from the running laboratory to the Phase 6 measures.</a:t>
             </a:r>
           </a:p>
           <a:p xmlns:a="http://schemas.openxmlformats.org/drawingml/2006/main">
@@ -575,20 +574,8 @@
           </a:p>
           <a:p xmlns:a="http://schemas.openxmlformats.org/drawingml/2006/main">
             <a:r>
-              <a:t>- Implementation Action Plan: Steps 5 and 6.</a:t>
-            </a:r>
-          </a:p>
-          <a:p xmlns:a="http://schemas.openxmlformats.org/drawingml/2006/main">
-            <a:r>
-              <a:t>- Proposal: adaptive forensic framework, integrity and evaluation components.</a:t>
-            </a:r>
-            <a:endParaRPr/>
-          </a:p>
-          <a:p xmlns:a="http://schemas.openxmlformats.org/drawingml/2006/main">
-            <a:r>
-              <a:t>- Phase 4 summary: artifacts/runs/phase4-20260816-123422/phase4-summary.json.</a:t>
-            </a:r>
-            <a:endParaRPr/>
+              <a:t>- Current Phase 4, 5 and 6 retained reports.</a:t>
+            </a:r>
           </a:p>
         </p:txBody>
       </p:sp>
@@ -768,7 +755,7 @@
           </a:p>
           <a:p xmlns:a="http://schemas.openxmlformats.org/drawingml/2006/main">
             <a:r>
-              <a:t>Say: The first five planned steps are now implemented and tested in the controlled laboratory. Phase 6 is the evaluation stage: I will run the planned scenarios and report completeness, integrity, adaptation timing, custody completeness and operational overhead.</a:t>
+              <a:t>Phase 5 is complete and Phase 6 now completes the prototype evaluation. I will use the remaining slides to show the measured result, the current running laboratory and the program that writes the evaluation report.</a:t>
             </a:r>
           </a:p>
           <a:p xmlns:a="http://schemas.openxmlformats.org/drawingml/2006/main">
@@ -784,26 +771,397 @@
           </a:p>
           <a:p xmlns:a="http://schemas.openxmlformats.org/drawingml/2006/main">
             <a:r>
-              <a:t>- Implementation Action Plan: Steps 5 and 6.</a:t>
-            </a:r>
-          </a:p>
-          <a:p xmlns:a="http://schemas.openxmlformats.org/drawingml/2006/main">
-            <a:r>
-              <a:t>- Phase 5 summary: artifacts/runs/phase5-20260822-170606/phase5-summary.json.</a:t>
+              <a:t>- Current Phase 6 summary and metrics report.</a:t>
+            </a:r>
+          </a:p>
+        </p:txBody>
+      </p:sp>
+      <p:sp>
+        <p:nvSpPr>
+          <p:cNvPr id="4" name="Slide Number Placeholder 3"/>
+          <p:cNvSpPr>
+            <a:spLocks xmlns:a="http://schemas.openxmlformats.org/drawingml/2006/main" noGrp="1"/>
+          </p:cNvSpPr>
+          <p:nvPr>
+            <p:ph type="sldNum" idx="5"/>
+          </p:nvPr>
+        </p:nvSpPr>
+        <p:spPr/>
+        <p:txBody>
+          <a:bodyPr xmlns:a="http://schemas.openxmlformats.org/drawingml/2006/main"/>
+          <a:lstStyle xmlns:a="http://schemas.openxmlformats.org/drawingml/2006/main"/>
+          <a:p xmlns:a="http://schemas.openxmlformats.org/drawingml/2006/main"/>
+        </p:txBody>
+      </p:sp>
+    </p:spTree>
+  </p:cSld>
+  <p:clrMapOvr>
+    <a:masterClrMapping xmlns:a="http://schemas.openxmlformats.org/drawingml/2006/main"/>
+  </p:clrMapOvr>
+</p:notes>
+</file>
+
+<file path=ppt/notesSlides/notesSlide13.xml><?xml version="1.0" encoding="utf-8"?>
+<p:notes xmlns:p="http://schemas.openxmlformats.org/presentationml/2006/main">
+  <p:cSld>
+    <p:spTree>
+      <p:nvGrpSpPr>
+        <p:cNvPr id="1" name=""/>
+        <p:cNvGrpSpPr/>
+        <p:nvPr/>
+      </p:nvGrpSpPr>
+      <p:grpSpPr>
+        <a:xfrm xmlns:a="http://schemas.openxmlformats.org/drawingml/2006/main"/>
+      </p:grpSpPr>
+      <p:sp>
+        <p:nvSpPr>
+          <p:cNvPr id="2" name="Slide Image Placeholder 1"/>
+          <p:cNvSpPr>
+            <a:spLocks xmlns:a="http://schemas.openxmlformats.org/drawingml/2006/main" noGrp="1"/>
+          </p:cNvSpPr>
+          <p:nvPr>
+            <p:ph type="sldImg" idx="0"/>
+          </p:nvPr>
+        </p:nvSpPr>
+        <p:spPr/>
+      </p:sp>
+      <p:sp>
+        <p:nvSpPr>
+          <p:cNvPr id="3" name="Notes Placeholder 2"/>
+          <p:cNvSpPr>
+            <a:spLocks xmlns:a="http://schemas.openxmlformats.org/drawingml/2006/main" noGrp="1"/>
+          </p:cNvSpPr>
+          <p:nvPr>
+            <p:ph type="body" idx="1"/>
+          </p:nvPr>
+        </p:nvSpPr>
+        <p:spPr/>
+        <p:txBody>
+          <a:bodyPr xmlns:a="http://schemas.openxmlformats.org/drawingml/2006/main"/>
+          <a:lstStyle xmlns:a="http://schemas.openxmlformats.org/drawingml/2006/main"/>
+          <a:p xmlns:a="http://schemas.openxmlformats.org/drawingml/2006/main">
+            <a:r>
+              <a:t>Talk track:</a:t>
+            </a:r>
+          </a:p>
+          <a:p xmlns:a="http://schemas.openxmlformats.org/drawingml/2006/main">
+            <a:r>
+              <a:t>Phase 6 is the evaluation step. I did not simply show that the program runs. I ran five controlled scenarios and checked six measurable outcomes against the retained evidence. All five scenarios and all six measures passed in the current run.</a:t>
+            </a:r>
+          </a:p>
+          <a:p xmlns:a="http://schemas.openxmlformats.org/drawingml/2006/main">
+            <a:r>
+              <a:t/>
             </a:r>
             <a:endParaRPr/>
           </a:p>
           <a:p xmlns:a="http://schemas.openxmlformats.org/drawingml/2006/main">
             <a:r>
-              <a:t>- Proposal: controlled evaluation metrics and scenarios.</a:t>
+              <a:t>[Sources]</a:t>
+            </a:r>
+          </a:p>
+          <a:p xmlns:a="http://schemas.openxmlformats.org/drawingml/2006/main">
+            <a:r>
+              <a:t>- artifacts/runs/phase6-20260904-184135/phase6-summary.json</a:t>
+            </a:r>
+          </a:p>
+          <a:p xmlns:a="http://schemas.openxmlformats.org/drawingml/2006/main">
+            <a:r>
+              <a:t>- artifacts/runs/phase6-20260904-184135/metrics.json</a:t>
+            </a:r>
+          </a:p>
+        </p:txBody>
+      </p:sp>
+      <p:sp>
+        <p:nvSpPr>
+          <p:cNvPr id="4" name="Slide Number Placeholder 3"/>
+          <p:cNvSpPr>
+            <a:spLocks xmlns:a="http://schemas.openxmlformats.org/drawingml/2006/main" noGrp="1"/>
+          </p:cNvSpPr>
+          <p:nvPr>
+            <p:ph type="sldNum" idx="5"/>
+          </p:nvPr>
+        </p:nvSpPr>
+        <p:spPr/>
+        <p:txBody>
+          <a:bodyPr xmlns:a="http://schemas.openxmlformats.org/drawingml/2006/main"/>
+          <a:lstStyle xmlns:a="http://schemas.openxmlformats.org/drawingml/2006/main"/>
+          <a:p xmlns:a="http://schemas.openxmlformats.org/drawingml/2006/main"/>
+        </p:txBody>
+      </p:sp>
+    </p:spTree>
+  </p:cSld>
+  <p:clrMapOvr>
+    <a:masterClrMapping xmlns:a="http://schemas.openxmlformats.org/drawingml/2006/main"/>
+  </p:clrMapOvr>
+</p:notes>
+</file>
+
+<file path=ppt/notesSlides/notesSlide14.xml><?xml version="1.0" encoding="utf-8"?>
+<p:notes xmlns:p="http://schemas.openxmlformats.org/presentationml/2006/main">
+  <p:cSld>
+    <p:spTree>
+      <p:nvGrpSpPr>
+        <p:cNvPr id="1" name=""/>
+        <p:cNvGrpSpPr/>
+        <p:nvPr/>
+      </p:nvGrpSpPr>
+      <p:grpSpPr>
+        <a:xfrm xmlns:a="http://schemas.openxmlformats.org/drawingml/2006/main"/>
+      </p:grpSpPr>
+      <p:sp>
+        <p:nvSpPr>
+          <p:cNvPr id="2" name="Slide Image Placeholder 1"/>
+          <p:cNvSpPr>
+            <a:spLocks xmlns:a="http://schemas.openxmlformats.org/drawingml/2006/main" noGrp="1"/>
+          </p:cNvSpPr>
+          <p:nvPr>
+            <p:ph type="sldImg" idx="0"/>
+          </p:nvPr>
+        </p:nvSpPr>
+        <p:spPr/>
+      </p:sp>
+      <p:sp>
+        <p:nvSpPr>
+          <p:cNvPr id="3" name="Notes Placeholder 2"/>
+          <p:cNvSpPr>
+            <a:spLocks xmlns:a="http://schemas.openxmlformats.org/drawingml/2006/main" noGrp="1"/>
+          </p:cNvSpPr>
+          <p:nvPr>
+            <p:ph type="body" idx="1"/>
+          </p:nvPr>
+        </p:nvSpPr>
+        <p:spPr/>
+        <p:txBody>
+          <a:bodyPr xmlns:a="http://schemas.openxmlformats.org/drawingml/2006/main"/>
+          <a:lstStyle xmlns:a="http://schemas.openxmlformats.org/drawingml/2006/main"/>
+          <a:p xmlns:a="http://schemas.openxmlformats.org/drawingml/2006/main">
+            <a:r>
+              <a:t>Talk track:</a:t>
+            </a:r>
+          </a:p>
+          <a:p xmlns:a="http://schemas.openxmlformats.org/drawingml/2006/main">
+            <a:r>
+              <a:t>This is the running laboratory that underpins the evaluation. The green healthy statuses show that the required core, virtual base station and virtual device containers are available before I run the evidence pipeline.</a:t>
+            </a:r>
+          </a:p>
+          <a:p xmlns:a="http://schemas.openxmlformats.org/drawingml/2006/main">
+            <a:r>
+              <a:t/>
             </a:r>
             <a:endParaRPr/>
           </a:p>
           <a:p xmlns:a="http://schemas.openxmlformats.org/drawingml/2006/main">
             <a:r>
-              <a:t>[/Sources]</a:t>
+              <a:t>[Sources]</a:t>
+            </a:r>
+          </a:p>
+          <a:p xmlns:a="http://schemas.openxmlformats.org/drawingml/2006/main">
+            <a:r>
+              <a:t>- Current Docker Desktop capture, 4 September 2026.</a:t>
+            </a:r>
+          </a:p>
+          <a:p xmlns:a="http://schemas.openxmlformats.org/drawingml/2006/main">
+            <a:r>
+              <a:t>- Current docker ps validation.</a:t>
+            </a:r>
+          </a:p>
+        </p:txBody>
+      </p:sp>
+      <p:sp>
+        <p:nvSpPr>
+          <p:cNvPr id="4" name="Slide Number Placeholder 3"/>
+          <p:cNvSpPr>
+            <a:spLocks xmlns:a="http://schemas.openxmlformats.org/drawingml/2006/main" noGrp="1"/>
+          </p:cNvSpPr>
+          <p:nvPr>
+            <p:ph type="sldNum" idx="5"/>
+          </p:nvPr>
+        </p:nvSpPr>
+        <p:spPr/>
+        <p:txBody>
+          <a:bodyPr xmlns:a="http://schemas.openxmlformats.org/drawingml/2006/main"/>
+          <a:lstStyle xmlns:a="http://schemas.openxmlformats.org/drawingml/2006/main"/>
+          <a:p xmlns:a="http://schemas.openxmlformats.org/drawingml/2006/main"/>
+        </p:txBody>
+      </p:sp>
+    </p:spTree>
+  </p:cSld>
+  <p:clrMapOvr>
+    <a:masterClrMapping xmlns:a="http://schemas.openxmlformats.org/drawingml/2006/main"/>
+  </p:clrMapOvr>
+</p:notes>
+</file>
+
+<file path=ppt/notesSlides/notesSlide15.xml><?xml version="1.0" encoding="utf-8"?>
+<p:notes xmlns:p="http://schemas.openxmlformats.org/presentationml/2006/main">
+  <p:cSld>
+    <p:spTree>
+      <p:nvGrpSpPr>
+        <p:cNvPr id="1" name=""/>
+        <p:cNvGrpSpPr/>
+        <p:nvPr/>
+      </p:nvGrpSpPr>
+      <p:grpSpPr>
+        <a:xfrm xmlns:a="http://schemas.openxmlformats.org/drawingml/2006/main"/>
+      </p:grpSpPr>
+      <p:sp>
+        <p:nvSpPr>
+          <p:cNvPr id="2" name="Slide Image Placeholder 1"/>
+          <p:cNvSpPr>
+            <a:spLocks xmlns:a="http://schemas.openxmlformats.org/drawingml/2006/main" noGrp="1"/>
+          </p:cNvSpPr>
+          <p:nvPr>
+            <p:ph type="sldImg" idx="0"/>
+          </p:nvPr>
+        </p:nvSpPr>
+        <p:spPr/>
+      </p:sp>
+      <p:sp>
+        <p:nvSpPr>
+          <p:cNvPr id="3" name="Notes Placeholder 2"/>
+          <p:cNvSpPr>
+            <a:spLocks xmlns:a="http://schemas.openxmlformats.org/drawingml/2006/main" noGrp="1"/>
+          </p:cNvSpPr>
+          <p:nvPr>
+            <p:ph type="body" idx="1"/>
+          </p:nvPr>
+        </p:nvSpPr>
+        <p:spPr/>
+        <p:txBody>
+          <a:bodyPr xmlns:a="http://schemas.openxmlformats.org/drawingml/2006/main"/>
+          <a:lstStyle xmlns:a="http://schemas.openxmlformats.org/drawingml/2006/main"/>
+          <a:p xmlns:a="http://schemas.openxmlformats.org/drawingml/2006/main">
+            <a:r>
+              <a:t>Talk track:</a:t>
+            </a:r>
+          </a:p>
+          <a:p xmlns:a="http://schemas.openxmlformats.org/drawingml/2006/main">
+            <a:r>
+              <a:t>This screen shows the source project in Visual Studio. The program reads the Phase 1 to Phase 5 reports, checks that they link together, runs the five defined Phase 6 scenarios and writes the evaluation evidence.</a:t>
+            </a:r>
+          </a:p>
+          <a:p xmlns:a="http://schemas.openxmlformats.org/drawingml/2006/main">
+            <a:r>
+              <a:t/>
             </a:r>
             <a:endParaRPr/>
+          </a:p>
+          <a:p xmlns:a="http://schemas.openxmlformats.org/drawingml/2006/main">
+            <a:r>
+              <a:t>[Sources]</a:t>
+            </a:r>
+          </a:p>
+          <a:p xmlns:a="http://schemas.openxmlformats.org/drawingml/2006/main">
+            <a:r>
+              <a:t>- Current Visual Studio capture, 4 September 2026.</a:t>
+            </a:r>
+          </a:p>
+          <a:p xmlns:a="http://schemas.openxmlformats.org/drawingml/2006/main">
+            <a:r>
+              <a:t>- src/ForensicFramework.LabBootstrap/Program.cs.</a:t>
+            </a:r>
+          </a:p>
+          <a:p xmlns:a="http://schemas.openxmlformats.org/drawingml/2006/main">
+            <a:r>
+              <a:t>- scripts/Run-Phase6Evaluation.ps1.</a:t>
+            </a:r>
+          </a:p>
+        </p:txBody>
+      </p:sp>
+      <p:sp>
+        <p:nvSpPr>
+          <p:cNvPr id="4" name="Slide Number Placeholder 3"/>
+          <p:cNvSpPr>
+            <a:spLocks xmlns:a="http://schemas.openxmlformats.org/drawingml/2006/main" noGrp="1"/>
+          </p:cNvSpPr>
+          <p:nvPr>
+            <p:ph type="sldNum" idx="5"/>
+          </p:nvPr>
+        </p:nvSpPr>
+        <p:spPr/>
+        <p:txBody>
+          <a:bodyPr xmlns:a="http://schemas.openxmlformats.org/drawingml/2006/main"/>
+          <a:lstStyle xmlns:a="http://schemas.openxmlformats.org/drawingml/2006/main"/>
+          <a:p xmlns:a="http://schemas.openxmlformats.org/drawingml/2006/main"/>
+        </p:txBody>
+      </p:sp>
+    </p:spTree>
+  </p:cSld>
+  <p:clrMapOvr>
+    <a:masterClrMapping xmlns:a="http://schemas.openxmlformats.org/drawingml/2006/main"/>
+  </p:clrMapOvr>
+</p:notes>
+</file>
+
+<file path=ppt/notesSlides/notesSlide16.xml><?xml version="1.0" encoding="utf-8"?>
+<p:notes xmlns:p="http://schemas.openxmlformats.org/presentationml/2006/main">
+  <p:cSld>
+    <p:spTree>
+      <p:nvGrpSpPr>
+        <p:cNvPr id="1" name=""/>
+        <p:cNvGrpSpPr/>
+        <p:nvPr/>
+      </p:nvGrpSpPr>
+      <p:grpSpPr>
+        <a:xfrm xmlns:a="http://schemas.openxmlformats.org/drawingml/2006/main"/>
+      </p:grpSpPr>
+      <p:sp>
+        <p:nvSpPr>
+          <p:cNvPr id="2" name="Slide Image Placeholder 1"/>
+          <p:cNvSpPr>
+            <a:spLocks xmlns:a="http://schemas.openxmlformats.org/drawingml/2006/main" noGrp="1"/>
+          </p:cNvSpPr>
+          <p:nvPr>
+            <p:ph type="sldImg" idx="0"/>
+          </p:nvPr>
+        </p:nvSpPr>
+        <p:spPr/>
+      </p:sp>
+      <p:sp>
+        <p:nvSpPr>
+          <p:cNvPr id="3" name="Notes Placeholder 2"/>
+          <p:cNvSpPr>
+            <a:spLocks xmlns:a="http://schemas.openxmlformats.org/drawingml/2006/main" noGrp="1"/>
+          </p:cNvSpPr>
+          <p:nvPr>
+            <p:ph type="body" idx="1"/>
+          </p:nvPr>
+        </p:nvSpPr>
+        <p:spPr/>
+        <p:txBody>
+          <a:bodyPr xmlns:a="http://schemas.openxmlformats.org/drawingml/2006/main"/>
+          <a:lstStyle xmlns:a="http://schemas.openxmlformats.org/drawingml/2006/main"/>
+          <a:p xmlns:a="http://schemas.openxmlformats.org/drawingml/2006/main">
+            <a:r>
+              <a:t>Talk track:</a:t>
+            </a:r>
+          </a:p>
+          <a:p xmlns:a="http://schemas.openxmlformats.org/drawingml/2006/main">
+            <a:r>
+              <a:t>These are the final three steps from the implementation plan. Together with the first three steps, they complete the intended proof of concept: a working laboratory, structured evidence, explainable attribution, safe collection adaptation, integrity and custody controls, then controlled evaluation.</a:t>
+            </a:r>
+          </a:p>
+          <a:p xmlns:a="http://schemas.openxmlformats.org/drawingml/2006/main">
+            <a:r>
+              <a:t/>
+            </a:r>
+            <a:endParaRPr/>
+          </a:p>
+          <a:p xmlns:a="http://schemas.openxmlformats.org/drawingml/2006/main">
+            <a:r>
+              <a:t>[Sources]</a:t>
+            </a:r>
+          </a:p>
+          <a:p xmlns:a="http://schemas.openxmlformats.org/drawingml/2006/main">
+            <a:r>
+              <a:t>- Implementation Action Plan: Steps 4 to 6.</a:t>
+            </a:r>
+          </a:p>
+          <a:p xmlns:a="http://schemas.openxmlformats.org/drawingml/2006/main">
+            <a:r>
+              <a:t>- Current Phase 4, 5 and 6 retained reports.</a:t>
+            </a:r>
           </a:p>
         </p:txBody>
       </p:sp>
@@ -1693,7 +2051,7 @@
   </p:cSld>
   <p:clrMap bg1="lt1" tx1="dk1" bg2="lt2" tx2="dk2" accent1="accent1" accent2="accent2" accent3="accent3" accent4="accent4" accent5="accent5" accent6="accent6" hlink="hlink" folHlink="folHlink"/>
   <p:sldLayoutIdLst>
-    <p:sldLayoutId xmlns:r="http://schemas.openxmlformats.org/officeDocument/2006/relationships" id="2147483649" r:id="Rfbd656869a614a35"/>
+    <p:sldLayoutId xmlns:r="http://schemas.openxmlformats.org/officeDocument/2006/relationships" id="2147483649" r:id="Rc7064db49ad84db9"/>
   </p:sldLayoutIdLst>
   <p:txStyles>
     <p:titleStyle>
@@ -2354,7 +2712,7 @@
                   <a:srgbClr val="111827"/>
                 </a:solidFill>
               </a:rPr>
-              <a:t>progress so far</a:t>
+              <a:t>progress through Phase 6</a:t>
             </a:r>
           </a:p>
         </p:txBody>
@@ -2496,7 +2854,7 @@
                   <a:srgbClr val="556070"/>
                 </a:solidFill>
               </a:rPr>
-              <a:t>Glen Mukota  |  4 August 2026</a:t>
+              <a:t>Glen Mukota  |  4 September 2026</a:t>
             </a:r>
           </a:p>
         </p:txBody>
@@ -2624,7 +2982,7 @@
                   <a:srgbClr val="1E62D0"/>
                 </a:solidFill>
               </a:rPr>
-              <a:t>CURRENT POSITION AND NEXT WORK</a:t>
+              <a:t>COMPLETED IMPLEMENTATION PATH</a:t>
             </a:r>
           </a:p>
         </p:txBody>
@@ -2675,7 +3033,7 @@
                   <a:srgbClr val="111827"/>
                 </a:solidFill>
               </a:rPr>
-              <a:t>Phase 4 is complete; the next work is clearly defined</a:t>
+              <a:t>The final three planned steps are complete</a:t>
             </a:r>
           </a:p>
         </p:txBody>
@@ -2766,7 +3124,7 @@
                   <a:srgbClr val="556070"/>
                 </a:solidFill>
               </a:rPr>
-              <a:t>16 AUGUST 2026  |  10</a:t>
+              <a:t>4 SEPTEMBER 2026  |  10</a:t>
             </a:r>
           </a:p>
         </p:txBody>
@@ -2817,7 +3175,7 @@
                   <a:srgbClr val="556070"/>
                 </a:solidFill>
               </a:rPr>
-              <a:t>Phase 4 connects records to slice context using transparent rules. Phases 5 and 6 remain the approved next steps.</a:t>
+              <a:t>The prototype now connects its live laboratory, retained evidence, approved adaptation and controlled evaluation into one reproducible path.</a:t>
             </a:r>
           </a:p>
         </p:txBody>
@@ -2853,7 +3211,7 @@
                             <a:srgbClr val="FFFFFF"/>
                           </a:solidFill>
                         </a:rPr>
-                        <a:t>Planned step</a:t>
+                        <a:t>Phase</a:t>
                       </a:r>
                     </a:p>
                   </a:txBody>
@@ -2874,23 +3232,7 @@
                             <a:srgbClr val="FFFFFF"/>
                           </a:solidFill>
                         </a:rPr>
-                        <a:t> </a:t>
-                      </a:r>
-                      <a:r>
-                        <a:rPr sz="1650" b="1">
-                          <a:solidFill>
-                            <a:srgbClr val="FFFFFF"/>
-                          </a:solidFill>
-                        </a:rPr>
-                        <a:t>M</a:t>
-                      </a:r>
-                      <a:r>
-                        <a:rPr sz="1650" b="1">
-                          <a:solidFill>
-                            <a:srgbClr val="FFFFFF"/>
-                          </a:solidFill>
-                        </a:rPr>
-                        <a:t>eaning</a:t>
+                        <a:t>Meaning</a:t>
                       </a:r>
                     </a:p>
                   </a:txBody>
@@ -2911,7 +3253,7 @@
                             <a:srgbClr val="FFFFFF"/>
                           </a:solidFill>
                         </a:rPr>
-                        <a:t>What I will show</a:t>
+                        <a:t>Evidence available</a:t>
                       </a:r>
                     </a:p>
                   </a:txBody>
@@ -2934,7 +3276,7 @@
                             <a:srgbClr val="111827"/>
                           </a:solidFill>
                         </a:rPr>
-                        <a:t>Phase 4 - complete</a:t>
+                        <a:t>Phase 4</a:t>
                       </a:r>
                     </a:p>
                   </a:txBody>
@@ -2951,7 +3293,7 @@
                             <a:srgbClr val="111827"/>
                           </a:solidFill>
                         </a:rPr>
-                        <a:t>Assign a slice with a recorded rule and reason</a:t>
+                        <a:t>Explain each slice decision</a:t>
                       </a:r>
                     </a:p>
                   </a:txBody>
@@ -2968,7 +3310,7 @@
                             <a:srgbClr val="111827"/>
                           </a:solidFill>
                         </a:rPr>
-                        <a:t>27 decisions; 8/8 known correct</a:t>
+                        <a:t>27 records; 8/8 labelled cases correct</a:t>
                       </a:r>
                     </a:p>
                   </a:txBody>
@@ -2987,7 +3329,7 @@
                             <a:srgbClr val="111827"/>
                           </a:solidFill>
                         </a:rPr>
-                        <a:t>Phase 5 - next</a:t>
+                        <a:t>Phase 5</a:t>
                       </a:r>
                     </a:p>
                   </a:txBody>
@@ -3004,7 +3346,7 @@
                             <a:srgbClr val="111827"/>
                           </a:solidFill>
                         </a:rPr>
-                        <a:t>Adapt collection using an approved rule</a:t>
+                        <a:t>Protect and adapt evidence</a:t>
                       </a:r>
                     </a:p>
                   </a:txBody>
@@ -3021,7 +3363,7 @@
                             <a:srgbClr val="111827"/>
                           </a:solidFill>
                         </a:rPr>
-                        <a:t>Show the control decision</a:t>
+                        <a:t>2 approved updates; 27/27 hashes verified</a:t>
                       </a:r>
                     </a:p>
                   </a:txBody>
@@ -3040,7 +3382,7 @@
                             <a:srgbClr val="111827"/>
                           </a:solidFill>
                         </a:rPr>
-                        <a:t>Phase 6 - next</a:t>
+                        <a:t>Phase 6</a:t>
                       </a:r>
                     </a:p>
                   </a:txBody>
@@ -3057,7 +3399,7 @@
                             <a:srgbClr val="111827"/>
                           </a:solidFill>
                         </a:rPr>
-                        <a:t>Protect history and measure results</a:t>
+                        <a:t>Evaluate known scenarios</a:t>
                       </a:r>
                     </a:p>
                   </a:txBody>
@@ -3074,7 +3416,7 @@
                             <a:srgbClr val="111827"/>
                           </a:solidFill>
                         </a:rPr>
-                        <a:t>Show integrity and evaluation</a:t>
+                        <a:t>5/5 scenarios; 6/6 measures passed</a:t>
                       </a:r>
                     </a:p>
                   </a:txBody>
@@ -3173,7 +3515,7 @@
                   <a:srgbClr val="1E62D0"/>
                 </a:solidFill>
               </a:rPr>
-              <a:t>Next meeting focus: Phase 5 - adapt collection safely and protect the evidence history.</a:t>
+              <a:t>Demonstration focus: start the laboratory, run the six steps, then inspect the retained evaluation evidence.</a:t>
             </a:r>
           </a:p>
         </p:txBody>
@@ -4162,7 +4504,7 @@
                   <a:srgbClr val="1E62D0"/>
                 </a:solidFill>
               </a:rPr>
-              <a:t>CURRENT POSITION AND NEXT WORK</a:t>
+              <a:t>CURRENT POSITION</a:t>
             </a:r>
           </a:p>
         </p:txBody>
@@ -4213,7 +4555,7 @@
                   <a:srgbClr val="111827"/>
                 </a:solidFill>
               </a:rPr>
-              <a:t>Phase 5 complete. Phase 6 is next.</a:t>
+              <a:t>The six planned prototype steps are complete</a:t>
             </a:r>
           </a:p>
         </p:txBody>
@@ -4304,7 +4646,7 @@
                   <a:srgbClr val="556070"/>
                 </a:solidFill>
               </a:rPr>
-              <a:t>22 AUGUST 2026  |  12</a:t>
+              <a:t>4 SEPTEMBER 2026  |  13</a:t>
             </a:r>
           </a:p>
         </p:txBody>
@@ -4355,7 +4697,7 @@
                   <a:srgbClr val="556070"/>
                 </a:solidFill>
               </a:rPr>
-              <a:t>Phase 5 applied an approved rule, verified each hash and preserved the custody history. Phase 6 will evaluate the results.</a:t>
+              <a:t>The controlled evaluation passed all five scenarios and six measures. The next meeting can demonstrate the working prototype.</a:t>
             </a:r>
           </a:p>
         </p:txBody>
@@ -4456,7 +4798,7 @@
                             <a:srgbClr val="111827"/>
                           </a:solidFill>
                         </a:rPr>
-                        <a:t>Phase 4 - complete</a:t>
+                        <a:t>Phase 4</a:t>
                       </a:r>
                     </a:p>
                   </a:txBody>
@@ -4473,7 +4815,7 @@
                             <a:srgbClr val="111827"/>
                           </a:solidFill>
                         </a:rPr>
-                        <a:t>Assign a slice with a recorded rule and reason</a:t>
+                        <a:t>Explain a slice decision</a:t>
                       </a:r>
                     </a:p>
                   </a:txBody>
@@ -4490,7 +4832,7 @@
                             <a:srgbClr val="111827"/>
                           </a:solidFill>
                         </a:rPr>
-                        <a:t>27 decisions; 8/8 known correct</a:t>
+                        <a:t>27 records; 8/8 labelled cases correct</a:t>
                       </a:r>
                     </a:p>
                   </a:txBody>
@@ -4509,7 +4851,7 @@
                             <a:srgbClr val="111827"/>
                           </a:solidFill>
                         </a:rPr>
-                        <a:t>Phase 5 - complete</a:t>
+                        <a:t>Phase 5</a:t>
                       </a:r>
                     </a:p>
                   </a:txBody>
@@ -4526,7 +4868,7 @@
                             <a:srgbClr val="111827"/>
                           </a:solidFill>
                         </a:rPr>
-                        <a:t>Approved collection, hash and custody</a:t>
+                        <a:t>Protect and adapt collection</a:t>
                       </a:r>
                     </a:p>
                   </a:txBody>
@@ -4543,7 +4885,7 @@
                             <a:srgbClr val="111827"/>
                           </a:solidFill>
                         </a:rPr>
-                        <a:t>2 updates; 27/27 verified</a:t>
+                        <a:t>2 approved changes; 27/27 hashes verified</a:t>
                       </a:r>
                     </a:p>
                   </a:txBody>
@@ -4562,7 +4904,7 @@
                             <a:srgbClr val="111827"/>
                           </a:solidFill>
                         </a:rPr>
-                        <a:t>Phase 6 - next</a:t>
+                        <a:t>Phase 6</a:t>
                       </a:r>
                     </a:p>
                   </a:txBody>
@@ -4579,7 +4921,7 @@
                             <a:srgbClr val="111827"/>
                           </a:solidFill>
                         </a:rPr>
-                        <a:t>Evaluate scenarios and measure results</a:t>
+                        <a:t>Evaluate the framework</a:t>
                       </a:r>
                     </a:p>
                   </a:txBody>
@@ -4596,7 +4938,7 @@
                             <a:srgbClr val="111827"/>
                           </a:solidFill>
                         </a:rPr>
-                        <a:t>Show completeness and overhead</a:t>
+                        <a:t>5/5 scenarios; 6/6 measures passed</a:t>
                       </a:r>
                     </a:p>
                   </a:txBody>
@@ -4695,7 +5037,7 @@
                   <a:srgbClr val="1E62D0"/>
                 </a:solidFill>
               </a:rPr>
-              <a:t>Next meeting focus: Phase 6 - evaluate the framework with planned scenarios.</a:t>
+              <a:t>Next meeting focus: demonstrate the six-step prototype and review the retained evaluation evidence.</a:t>
             </a:r>
           </a:p>
         </p:txBody>
@@ -4704,6 +5046,3878 @@
     <p:extLst>
       <p:ext uri="{BB962C8B-B14F-4D97-AF65-F5344CB8AC3E}">
         <p14:creationId xmlns:p14="http://schemas.microsoft.com/office/powerpoint/2010/main" val="2137065952"/>
+      </p:ext>
+    </p:extLst>
+  </p:cSld>
+</p:sld>
+</file>
+
+<file path=ppt/slides/slide13.xml><?xml version="1.0" encoding="utf-8"?>
+<p:sld xmlns:p="http://schemas.openxmlformats.org/presentationml/2006/main">
+  <p:cSld>
+    <p:bg>
+      <p:bgPr>
+        <a:solidFill xmlns:a="http://schemas.openxmlformats.org/drawingml/2006/main">
+          <a:srgbClr val="FFFFFF"/>
+        </a:solidFill>
+      </p:bgPr>
+    </p:bg>
+    <p:spTree>
+      <p:nvGrpSpPr>
+        <p:cNvPr id="1" name=""/>
+        <p:cNvGrpSpPr/>
+        <p:nvPr/>
+      </p:nvGrpSpPr>
+      <p:grpSpPr>
+        <a:xfrm xmlns:a="http://schemas.openxmlformats.org/drawingml/2006/main"/>
+      </p:grpSpPr>
+      <p:sp>
+        <p:nvSpPr>
+          <p:cNvPr id="19" name="Rectangle 18">
+            <a:extLst xmlns:a="http://schemas.openxmlformats.org/drawingml/2006/main">
+              <a:ext uri="{FF2B5EF4-FFF2-40B4-BE49-F238E27FC236}">
+                <a16:creationId xmlns:a16="http://schemas.microsoft.com/office/drawing/2014/main" id="{093AC282-58D5-40B7-8E7D-710A25B67C6B}"/>
+              </a:ext>
+            </a:extLst>
+          </p:cNvPr>
+          <p:cNvSpPr>
+            <a:spLocks xmlns:a="http://schemas.openxmlformats.org/drawingml/2006/main" noGrp="1"/>
+          </p:cNvSpPr>
+          <p:nvPr/>
+        </p:nvSpPr>
+        <p:spPr>
+          <a:xfrm xmlns:a="http://schemas.openxmlformats.org/drawingml/2006/main">
+            <a:off x="400050" y="323850"/>
+            <a:ext cx="2476500" cy="228600"/>
+          </a:xfrm>
+          <a:prstGeom xmlns:a="http://schemas.openxmlformats.org/drawingml/2006/main" prst="rect">
+            <a:avLst/>
+          </a:prstGeom>
+          <a:noFill xmlns:a="http://schemas.openxmlformats.org/drawingml/2006/main"/>
+          <a:ln xmlns:a="http://schemas.openxmlformats.org/drawingml/2006/main" w="0">
+            <a:noFill/>
+            <a:prstDash val="solid"/>
+          </a:ln>
+        </p:spPr>
+        <p:txBody>
+          <a:bodyPr xmlns:a="http://schemas.openxmlformats.org/drawingml/2006/main"/>
+          <a:lstStyle xmlns:a="http://schemas.openxmlformats.org/drawingml/2006/main"/>
+          <a:p xmlns:a="http://schemas.openxmlformats.org/drawingml/2006/main">
+            <a:pPr algn="l">
+              <a:buNone/>
+              <a:defRPr sz="1125" b="1" i="0">
+                <a:solidFill>
+                  <a:srgbClr val="1E62D0"/>
+                </a:solidFill>
+              </a:defRPr>
+            </a:pPr>
+            <a:r>
+              <a:rPr sz="1125" b="1" i="0">
+                <a:solidFill>
+                  <a:srgbClr val="1E62D0"/>
+                </a:solidFill>
+              </a:rPr>
+              <a:t>PHASE 6 EVALUATION</a:t>
+            </a:r>
+          </a:p>
+        </p:txBody>
+      </p:sp>
+      <p:sp>
+        <p:nvSpPr>
+          <p:cNvPr id="2" name="Rectangle 1">
+            <a:extLst xmlns:a="http://schemas.openxmlformats.org/drawingml/2006/main">
+              <a:ext uri="{FF2B5EF4-FFF2-40B4-BE49-F238E27FC236}">
+                <a16:creationId xmlns:a16="http://schemas.microsoft.com/office/drawing/2014/main" id="{2FC15BA6-BC82-4981-99C4-CE80F366B9DE}"/>
+              </a:ext>
+            </a:extLst>
+          </p:cNvPr>
+          <p:cNvSpPr>
+            <a:spLocks xmlns:a="http://schemas.openxmlformats.org/drawingml/2006/main" noGrp="1"/>
+          </p:cNvSpPr>
+          <p:nvPr/>
+        </p:nvSpPr>
+        <p:spPr>
+          <a:xfrm xmlns:a="http://schemas.openxmlformats.org/drawingml/2006/main">
+            <a:off x="400050" y="628650"/>
+            <a:ext cx="10668000" cy="523875"/>
+          </a:xfrm>
+          <a:prstGeom xmlns:a="http://schemas.openxmlformats.org/drawingml/2006/main" prst="rect">
+            <a:avLst/>
+          </a:prstGeom>
+          <a:noFill xmlns:a="http://schemas.openxmlformats.org/drawingml/2006/main"/>
+          <a:ln xmlns:a="http://schemas.openxmlformats.org/drawingml/2006/main" w="0">
+            <a:noFill/>
+            <a:prstDash val="solid"/>
+          </a:ln>
+        </p:spPr>
+        <p:txBody>
+          <a:bodyPr xmlns:a="http://schemas.openxmlformats.org/drawingml/2006/main"/>
+          <a:lstStyle xmlns:a="http://schemas.openxmlformats.org/drawingml/2006/main"/>
+          <a:p xmlns:a="http://schemas.openxmlformats.org/drawingml/2006/main">
+            <a:pPr algn="l">
+              <a:buNone/>
+              <a:defRPr sz="2925" b="1" i="0">
+                <a:solidFill>
+                  <a:srgbClr val="111827"/>
+                </a:solidFill>
+              </a:defRPr>
+            </a:pPr>
+            <a:r>
+              <a:rPr sz="2925" b="1" i="0">
+                <a:solidFill>
+                  <a:srgbClr val="111827"/>
+                </a:solidFill>
+              </a:rPr>
+              <a:t>The completed prototype passed every planned check</a:t>
+            </a:r>
+          </a:p>
+        </p:txBody>
+      </p:sp>
+      <p:sp>
+        <p:nvSpPr>
+          <p:cNvPr id="3" name="Rectangle 2">
+            <a:extLst xmlns:a="http://schemas.openxmlformats.org/drawingml/2006/main">
+              <a:ext uri="{FF2B5EF4-FFF2-40B4-BE49-F238E27FC236}">
+                <a16:creationId xmlns:a16="http://schemas.microsoft.com/office/drawing/2014/main" id="{AE21976C-8499-45AA-98A4-1EE1CB3569F0}"/>
+              </a:ext>
+            </a:extLst>
+          </p:cNvPr>
+          <p:cNvSpPr>
+            <a:spLocks xmlns:a="http://schemas.openxmlformats.org/drawingml/2006/main" noGrp="1"/>
+          </p:cNvSpPr>
+          <p:nvPr/>
+        </p:nvSpPr>
+        <p:spPr>
+          <a:xfrm xmlns:a="http://schemas.openxmlformats.org/drawingml/2006/main">
+            <a:off x="400050" y="1276350"/>
+            <a:ext cx="11391900" cy="9525"/>
+          </a:xfrm>
+          <a:prstGeom xmlns:a="http://schemas.openxmlformats.org/drawingml/2006/main" prst="rect">
+            <a:avLst/>
+          </a:prstGeom>
+          <a:solidFill xmlns:a="http://schemas.openxmlformats.org/drawingml/2006/main">
+            <a:srgbClr val="C8CED6"/>
+          </a:solidFill>
+          <a:ln xmlns:a="http://schemas.openxmlformats.org/drawingml/2006/main" w="0">
+            <a:solidFill>
+              <a:srgbClr val="C8CED6"/>
+            </a:solidFill>
+            <a:prstDash val="solid"/>
+          </a:ln>
+        </p:spPr>
+        <p:txBody>
+          <a:bodyPr xmlns:a="http://schemas.openxmlformats.org/drawingml/2006/main"/>
+          <a:lstStyle xmlns:a="http://schemas.openxmlformats.org/drawingml/2006/main"/>
+          <a:p xmlns:a="http://schemas.openxmlformats.org/drawingml/2006/main">
+            <a:endParaRPr/>
+          </a:p>
+        </p:txBody>
+      </p:sp>
+      <p:sp>
+        <p:nvSpPr>
+          <p:cNvPr id="4" name="Rectangle 3">
+            <a:extLst xmlns:a="http://schemas.openxmlformats.org/drawingml/2006/main">
+              <a:ext uri="{FF2B5EF4-FFF2-40B4-BE49-F238E27FC236}">
+                <a16:creationId xmlns:a16="http://schemas.microsoft.com/office/drawing/2014/main" id="{EBE2EAAD-04A1-4C85-B928-3FDC4F59785E}"/>
+              </a:ext>
+            </a:extLst>
+          </p:cNvPr>
+          <p:cNvSpPr>
+            <a:spLocks xmlns:a="http://schemas.openxmlformats.org/drawingml/2006/main" noGrp="1"/>
+          </p:cNvSpPr>
+          <p:nvPr/>
+        </p:nvSpPr>
+        <p:spPr>
+          <a:xfrm xmlns:a="http://schemas.openxmlformats.org/drawingml/2006/main">
+            <a:off x="9715500" y="6286500"/>
+            <a:ext cx="2076450" cy="190500"/>
+          </a:xfrm>
+          <a:prstGeom xmlns:a="http://schemas.openxmlformats.org/drawingml/2006/main" prst="rect">
+            <a:avLst/>
+          </a:prstGeom>
+          <a:noFill xmlns:a="http://schemas.openxmlformats.org/drawingml/2006/main"/>
+          <a:ln xmlns:a="http://schemas.openxmlformats.org/drawingml/2006/main" w="0">
+            <a:noFill/>
+            <a:prstDash val="solid"/>
+          </a:ln>
+        </p:spPr>
+        <p:txBody>
+          <a:bodyPr xmlns:a="http://schemas.openxmlformats.org/drawingml/2006/main"/>
+          <a:lstStyle xmlns:a="http://schemas.openxmlformats.org/drawingml/2006/main"/>
+          <a:p xmlns:a="http://schemas.openxmlformats.org/drawingml/2006/main">
+            <a:pPr algn="r">
+              <a:buNone/>
+              <a:defRPr sz="975" b="0" i="0">
+                <a:solidFill>
+                  <a:srgbClr val="556070"/>
+                </a:solidFill>
+              </a:defRPr>
+            </a:pPr>
+            <a:r>
+              <a:rPr sz="975" b="0" i="0">
+                <a:solidFill>
+                  <a:srgbClr val="556070"/>
+                </a:solidFill>
+              </a:rPr>
+              <a:t>4 SEPTEMBER 2026  |  13</a:t>
+            </a:r>
+          </a:p>
+        </p:txBody>
+      </p:sp>
+      <p:sp>
+        <p:nvSpPr>
+          <p:cNvPr id="5" name="Rectangle 4">
+            <a:extLst xmlns:a="http://schemas.openxmlformats.org/drawingml/2006/main">
+              <a:ext uri="{FF2B5EF4-FFF2-40B4-BE49-F238E27FC236}">
+                <a16:creationId xmlns:a16="http://schemas.microsoft.com/office/drawing/2014/main" id="{062A7E23-5AF0-44AC-A21E-B9CC4008E3B8}"/>
+              </a:ext>
+            </a:extLst>
+          </p:cNvPr>
+          <p:cNvSpPr>
+            <a:spLocks xmlns:a="http://schemas.openxmlformats.org/drawingml/2006/main" noGrp="1"/>
+          </p:cNvSpPr>
+          <p:nvPr/>
+        </p:nvSpPr>
+        <p:spPr>
+          <a:xfrm xmlns:a="http://schemas.openxmlformats.org/drawingml/2006/main">
+            <a:off x="400050" y="1543050"/>
+            <a:ext cx="10287000" cy="419100"/>
+          </a:xfrm>
+          <a:prstGeom xmlns:a="http://schemas.openxmlformats.org/drawingml/2006/main" prst="rect">
+            <a:avLst/>
+          </a:prstGeom>
+          <a:noFill xmlns:a="http://schemas.openxmlformats.org/drawingml/2006/main"/>
+          <a:ln xmlns:a="http://schemas.openxmlformats.org/drawingml/2006/main" w="0">
+            <a:noFill/>
+            <a:prstDash val="solid"/>
+          </a:ln>
+        </p:spPr>
+        <p:txBody>
+          <a:bodyPr xmlns:a="http://schemas.openxmlformats.org/drawingml/2006/main"/>
+          <a:lstStyle xmlns:a="http://schemas.openxmlformats.org/drawingml/2006/main"/>
+          <a:p xmlns:a="http://schemas.openxmlformats.org/drawingml/2006/main">
+            <a:pPr algn="l">
+              <a:buNone/>
+              <a:defRPr sz="1800" b="0" i="0">
+                <a:solidFill>
+                  <a:srgbClr val="556070"/>
+                </a:solidFill>
+              </a:defRPr>
+            </a:pPr>
+            <a:r>
+              <a:rPr sz="1800" b="0" i="0">
+                <a:solidFill>
+                  <a:srgbClr val="556070"/>
+                </a:solidFill>
+              </a:rPr>
+              <a:t>Five controlled scenarios were compared with known inputs. Each scenario passed, and every defined measure passed.</a:t>
+            </a:r>
+          </a:p>
+        </p:txBody>
+      </p:sp>
+      <p:sp>
+        <p:nvSpPr>
+          <p:cNvPr id="6" name="Rectangle: Rounded Corners 5">
+            <a:extLst xmlns:a="http://schemas.openxmlformats.org/drawingml/2006/main">
+              <a:ext uri="{FF2B5EF4-FFF2-40B4-BE49-F238E27FC236}">
+                <a16:creationId xmlns:a16="http://schemas.microsoft.com/office/drawing/2014/main" id="{3E169C23-5DD8-4164-AFE6-7FC645EA7C75}"/>
+              </a:ext>
+            </a:extLst>
+          </p:cNvPr>
+          <p:cNvSpPr>
+            <a:spLocks xmlns:a="http://schemas.openxmlformats.org/drawingml/2006/main" noGrp="1"/>
+          </p:cNvSpPr>
+          <p:nvPr/>
+        </p:nvSpPr>
+        <p:spPr>
+          <a:xfrm xmlns:a="http://schemas.openxmlformats.org/drawingml/2006/main">
+            <a:off x="400050" y="3028950"/>
+            <a:ext cx="3562350" cy="2476500"/>
+          </a:xfrm>
+          <a:prstGeom xmlns:a="http://schemas.openxmlformats.org/drawingml/2006/main" prst="roundRect">
+            <a:avLst>
+              <a:gd name="adj" fmla="val 4615"/>
+            </a:avLst>
+          </a:prstGeom>
+          <a:solidFill xmlns:a="http://schemas.openxmlformats.org/drawingml/2006/main">
+            <a:srgbClr val="F2F4F7"/>
+          </a:solidFill>
+          <a:ln xmlns:a="http://schemas.openxmlformats.org/drawingml/2006/main" w="0">
+            <a:solidFill>
+              <a:srgbClr val="F2F4F7"/>
+            </a:solidFill>
+            <a:prstDash val="solid"/>
+          </a:ln>
+        </p:spPr>
+        <p:txBody>
+          <a:bodyPr xmlns:a="http://schemas.openxmlformats.org/drawingml/2006/main"/>
+          <a:lstStyle xmlns:a="http://schemas.openxmlformats.org/drawingml/2006/main"/>
+          <a:p xmlns:a="http://schemas.openxmlformats.org/drawingml/2006/main">
+            <a:endParaRPr/>
+          </a:p>
+        </p:txBody>
+      </p:sp>
+      <p:sp>
+        <p:nvSpPr>
+          <p:cNvPr id="7" name="Rectangle 6">
+            <a:extLst xmlns:a="http://schemas.openxmlformats.org/drawingml/2006/main">
+              <a:ext uri="{FF2B5EF4-FFF2-40B4-BE49-F238E27FC236}">
+                <a16:creationId xmlns:a16="http://schemas.microsoft.com/office/drawing/2014/main" id="{794368B1-6FEC-4354-8646-E97880C06729}"/>
+              </a:ext>
+            </a:extLst>
+          </p:cNvPr>
+          <p:cNvSpPr>
+            <a:spLocks xmlns:a="http://schemas.openxmlformats.org/drawingml/2006/main" noGrp="1"/>
+          </p:cNvSpPr>
+          <p:nvPr/>
+        </p:nvSpPr>
+        <p:spPr>
+          <a:xfrm xmlns:a="http://schemas.openxmlformats.org/drawingml/2006/main">
+            <a:off x="685800" y="3333750"/>
+            <a:ext cx="2990850" cy="819150"/>
+          </a:xfrm>
+          <a:prstGeom xmlns:a="http://schemas.openxmlformats.org/drawingml/2006/main" prst="rect">
+            <a:avLst/>
+          </a:prstGeom>
+          <a:noFill xmlns:a="http://schemas.openxmlformats.org/drawingml/2006/main"/>
+          <a:ln xmlns:a="http://schemas.openxmlformats.org/drawingml/2006/main" w="0">
+            <a:noFill/>
+            <a:prstDash val="solid"/>
+          </a:ln>
+        </p:spPr>
+        <p:txBody>
+          <a:bodyPr xmlns:a="http://schemas.openxmlformats.org/drawingml/2006/main"/>
+          <a:lstStyle xmlns:a="http://schemas.openxmlformats.org/drawingml/2006/main"/>
+          <a:p xmlns:a="http://schemas.openxmlformats.org/drawingml/2006/main">
+            <a:pPr algn="l">
+              <a:buNone/>
+              <a:defRPr sz="4125" b="1" i="0">
+                <a:solidFill>
+                  <a:srgbClr val="1E62D0"/>
+                </a:solidFill>
+              </a:defRPr>
+            </a:pPr>
+            <a:r>
+              <a:rPr sz="4125" b="1" i="0">
+                <a:solidFill>
+                  <a:srgbClr val="1E62D0"/>
+                </a:solidFill>
+              </a:rPr>
+              <a:t>5/5</a:t>
+            </a:r>
+          </a:p>
+        </p:txBody>
+      </p:sp>
+      <p:sp>
+        <p:nvSpPr>
+          <p:cNvPr id="8" name="Rectangle 7">
+            <a:extLst xmlns:a="http://schemas.openxmlformats.org/drawingml/2006/main">
+              <a:ext uri="{FF2B5EF4-FFF2-40B4-BE49-F238E27FC236}">
+                <a16:creationId xmlns:a16="http://schemas.microsoft.com/office/drawing/2014/main" id="{EAF1B148-FFE2-427D-8976-FA62BACBF11B}"/>
+              </a:ext>
+            </a:extLst>
+          </p:cNvPr>
+          <p:cNvSpPr>
+            <a:spLocks xmlns:a="http://schemas.openxmlformats.org/drawingml/2006/main" noGrp="1"/>
+          </p:cNvSpPr>
+          <p:nvPr/>
+        </p:nvSpPr>
+        <p:spPr>
+          <a:xfrm xmlns:a="http://schemas.openxmlformats.org/drawingml/2006/main">
+            <a:off x="685800" y="4257675"/>
+            <a:ext cx="2990850" cy="323850"/>
+          </a:xfrm>
+          <a:prstGeom xmlns:a="http://schemas.openxmlformats.org/drawingml/2006/main" prst="rect">
+            <a:avLst/>
+          </a:prstGeom>
+          <a:noFill xmlns:a="http://schemas.openxmlformats.org/drawingml/2006/main"/>
+          <a:ln xmlns:a="http://schemas.openxmlformats.org/drawingml/2006/main" w="0">
+            <a:noFill/>
+            <a:prstDash val="solid"/>
+          </a:ln>
+        </p:spPr>
+        <p:txBody>
+          <a:bodyPr xmlns:a="http://schemas.openxmlformats.org/drawingml/2006/main"/>
+          <a:lstStyle xmlns:a="http://schemas.openxmlformats.org/drawingml/2006/main"/>
+          <a:p xmlns:a="http://schemas.openxmlformats.org/drawingml/2006/main">
+            <a:pPr algn="l">
+              <a:buNone/>
+              <a:defRPr sz="1800" b="1" i="0">
+                <a:solidFill>
+                  <a:srgbClr val="111827"/>
+                </a:solidFill>
+              </a:defRPr>
+            </a:pPr>
+            <a:r>
+              <a:rPr sz="1800" b="1" i="0">
+                <a:solidFill>
+                  <a:srgbClr val="111827"/>
+                </a:solidFill>
+              </a:rPr>
+              <a:t>scenarios passed</a:t>
+            </a:r>
+          </a:p>
+        </p:txBody>
+      </p:sp>
+      <p:sp>
+        <p:nvSpPr>
+          <p:cNvPr id="9" name="Rectangle 8">
+            <a:extLst xmlns:a="http://schemas.openxmlformats.org/drawingml/2006/main">
+              <a:ext uri="{FF2B5EF4-FFF2-40B4-BE49-F238E27FC236}">
+                <a16:creationId xmlns:a16="http://schemas.microsoft.com/office/drawing/2014/main" id="{034DB9BB-1ADB-4AFD-A47C-2D98F0FE8DC7}"/>
+              </a:ext>
+            </a:extLst>
+          </p:cNvPr>
+          <p:cNvSpPr>
+            <a:spLocks xmlns:a="http://schemas.openxmlformats.org/drawingml/2006/main" noGrp="1"/>
+          </p:cNvSpPr>
+          <p:nvPr/>
+        </p:nvSpPr>
+        <p:spPr>
+          <a:xfrm xmlns:a="http://schemas.openxmlformats.org/drawingml/2006/main">
+            <a:off x="685800" y="4705350"/>
+            <a:ext cx="2990850" cy="533400"/>
+          </a:xfrm>
+          <a:prstGeom xmlns:a="http://schemas.openxmlformats.org/drawingml/2006/main" prst="rect">
+            <a:avLst/>
+          </a:prstGeom>
+          <a:noFill xmlns:a="http://schemas.openxmlformats.org/drawingml/2006/main"/>
+          <a:ln xmlns:a="http://schemas.openxmlformats.org/drawingml/2006/main" w="0">
+            <a:noFill/>
+            <a:prstDash val="solid"/>
+          </a:ln>
+        </p:spPr>
+        <p:txBody>
+          <a:bodyPr xmlns:a="http://schemas.openxmlformats.org/drawingml/2006/main"/>
+          <a:lstStyle xmlns:a="http://schemas.openxmlformats.org/drawingml/2006/main"/>
+          <a:p xmlns:a="http://schemas.openxmlformats.org/drawingml/2006/main">
+            <a:pPr algn="l">
+              <a:buNone/>
+              <a:defRPr sz="1425" b="0" i="0">
+                <a:solidFill>
+                  <a:srgbClr val="556070"/>
+                </a:solidFill>
+              </a:defRPr>
+            </a:pPr>
+            <a:r>
+              <a:rPr sz="1425" b="0" i="0">
+                <a:solidFill>
+                  <a:srgbClr val="556070"/>
+                </a:solidFill>
+              </a:rPr>
+              <a:t>Normal operation, anomaly replay, isolation, cross-layer evidence and adaptation.</a:t>
+            </a:r>
+          </a:p>
+        </p:txBody>
+      </p:sp>
+      <p:sp>
+        <p:nvSpPr>
+          <p:cNvPr id="10" name="Rectangle: Rounded Corners 9">
+            <a:extLst xmlns:a="http://schemas.openxmlformats.org/drawingml/2006/main">
+              <a:ext uri="{FF2B5EF4-FFF2-40B4-BE49-F238E27FC236}">
+                <a16:creationId xmlns:a16="http://schemas.microsoft.com/office/drawing/2014/main" id="{95D2F159-90A3-43B4-94DF-E4E13CF06DD8}"/>
+              </a:ext>
+            </a:extLst>
+          </p:cNvPr>
+          <p:cNvSpPr>
+            <a:spLocks xmlns:a="http://schemas.openxmlformats.org/drawingml/2006/main" noGrp="1"/>
+          </p:cNvSpPr>
+          <p:nvPr/>
+        </p:nvSpPr>
+        <p:spPr>
+          <a:xfrm xmlns:a="http://schemas.openxmlformats.org/drawingml/2006/main">
+            <a:off x="4314825" y="3028950"/>
+            <a:ext cx="3562350" cy="2476500"/>
+          </a:xfrm>
+          <a:prstGeom xmlns:a="http://schemas.openxmlformats.org/drawingml/2006/main" prst="roundRect">
+            <a:avLst>
+              <a:gd name="adj" fmla="val 4615"/>
+            </a:avLst>
+          </a:prstGeom>
+          <a:solidFill xmlns:a="http://schemas.openxmlformats.org/drawingml/2006/main">
+            <a:srgbClr val="F2F4F7"/>
+          </a:solidFill>
+          <a:ln xmlns:a="http://schemas.openxmlformats.org/drawingml/2006/main" w="0">
+            <a:solidFill>
+              <a:srgbClr val="F2F4F7"/>
+            </a:solidFill>
+            <a:prstDash val="solid"/>
+          </a:ln>
+        </p:spPr>
+        <p:txBody>
+          <a:bodyPr xmlns:a="http://schemas.openxmlformats.org/drawingml/2006/main"/>
+          <a:lstStyle xmlns:a="http://schemas.openxmlformats.org/drawingml/2006/main"/>
+          <a:p xmlns:a="http://schemas.openxmlformats.org/drawingml/2006/main">
+            <a:endParaRPr/>
+          </a:p>
+        </p:txBody>
+      </p:sp>
+      <p:sp>
+        <p:nvSpPr>
+          <p:cNvPr id="11" name="Rectangle 10">
+            <a:extLst xmlns:a="http://schemas.openxmlformats.org/drawingml/2006/main">
+              <a:ext uri="{FF2B5EF4-FFF2-40B4-BE49-F238E27FC236}">
+                <a16:creationId xmlns:a16="http://schemas.microsoft.com/office/drawing/2014/main" id="{E10F1BDB-673B-4711-A6EC-7469A4302E01}"/>
+              </a:ext>
+            </a:extLst>
+          </p:cNvPr>
+          <p:cNvSpPr>
+            <a:spLocks xmlns:a="http://schemas.openxmlformats.org/drawingml/2006/main" noGrp="1"/>
+          </p:cNvSpPr>
+          <p:nvPr/>
+        </p:nvSpPr>
+        <p:spPr>
+          <a:xfrm xmlns:a="http://schemas.openxmlformats.org/drawingml/2006/main">
+            <a:off x="4600575" y="3333750"/>
+            <a:ext cx="2990850" cy="819150"/>
+          </a:xfrm>
+          <a:prstGeom xmlns:a="http://schemas.openxmlformats.org/drawingml/2006/main" prst="rect">
+            <a:avLst/>
+          </a:prstGeom>
+          <a:noFill xmlns:a="http://schemas.openxmlformats.org/drawingml/2006/main"/>
+          <a:ln xmlns:a="http://schemas.openxmlformats.org/drawingml/2006/main" w="0">
+            <a:noFill/>
+            <a:prstDash val="solid"/>
+          </a:ln>
+        </p:spPr>
+        <p:txBody>
+          <a:bodyPr xmlns:a="http://schemas.openxmlformats.org/drawingml/2006/main"/>
+          <a:lstStyle xmlns:a="http://schemas.openxmlformats.org/drawingml/2006/main"/>
+          <a:p xmlns:a="http://schemas.openxmlformats.org/drawingml/2006/main">
+            <a:pPr algn="l">
+              <a:buNone/>
+              <a:defRPr sz="4125" b="1" i="0">
+                <a:solidFill>
+                  <a:srgbClr val="1E62D0"/>
+                </a:solidFill>
+              </a:defRPr>
+            </a:pPr>
+            <a:r>
+              <a:rPr sz="4125" b="1" i="0">
+                <a:solidFill>
+                  <a:srgbClr val="1E62D0"/>
+                </a:solidFill>
+              </a:rPr>
+              <a:t>6/6</a:t>
+            </a:r>
+          </a:p>
+        </p:txBody>
+      </p:sp>
+      <p:sp>
+        <p:nvSpPr>
+          <p:cNvPr id="12" name="Rectangle 11">
+            <a:extLst xmlns:a="http://schemas.openxmlformats.org/drawingml/2006/main">
+              <a:ext uri="{FF2B5EF4-FFF2-40B4-BE49-F238E27FC236}">
+                <a16:creationId xmlns:a16="http://schemas.microsoft.com/office/drawing/2014/main" id="{38119460-6E68-4D77-9C69-881C10E9C251}"/>
+              </a:ext>
+            </a:extLst>
+          </p:cNvPr>
+          <p:cNvSpPr>
+            <a:spLocks xmlns:a="http://schemas.openxmlformats.org/drawingml/2006/main" noGrp="1"/>
+          </p:cNvSpPr>
+          <p:nvPr/>
+        </p:nvSpPr>
+        <p:spPr>
+          <a:xfrm xmlns:a="http://schemas.openxmlformats.org/drawingml/2006/main">
+            <a:off x="4600575" y="4257675"/>
+            <a:ext cx="2990850" cy="323850"/>
+          </a:xfrm>
+          <a:prstGeom xmlns:a="http://schemas.openxmlformats.org/drawingml/2006/main" prst="rect">
+            <a:avLst/>
+          </a:prstGeom>
+          <a:noFill xmlns:a="http://schemas.openxmlformats.org/drawingml/2006/main"/>
+          <a:ln xmlns:a="http://schemas.openxmlformats.org/drawingml/2006/main" w="0">
+            <a:noFill/>
+            <a:prstDash val="solid"/>
+          </a:ln>
+        </p:spPr>
+        <p:txBody>
+          <a:bodyPr xmlns:a="http://schemas.openxmlformats.org/drawingml/2006/main"/>
+          <a:lstStyle xmlns:a="http://schemas.openxmlformats.org/drawingml/2006/main"/>
+          <a:p xmlns:a="http://schemas.openxmlformats.org/drawingml/2006/main">
+            <a:pPr algn="l">
+              <a:buNone/>
+              <a:defRPr sz="1800" b="1" i="0">
+                <a:solidFill>
+                  <a:srgbClr val="111827"/>
+                </a:solidFill>
+              </a:defRPr>
+            </a:pPr>
+            <a:r>
+              <a:rPr sz="1800" b="1" i="0">
+                <a:solidFill>
+                  <a:srgbClr val="111827"/>
+                </a:solidFill>
+              </a:rPr>
+              <a:t>measures passed</a:t>
+            </a:r>
+          </a:p>
+        </p:txBody>
+      </p:sp>
+      <p:sp>
+        <p:nvSpPr>
+          <p:cNvPr id="13" name="Rectangle 12">
+            <a:extLst xmlns:a="http://schemas.openxmlformats.org/drawingml/2006/main">
+              <a:ext uri="{FF2B5EF4-FFF2-40B4-BE49-F238E27FC236}">
+                <a16:creationId xmlns:a16="http://schemas.microsoft.com/office/drawing/2014/main" id="{48199DA3-8AE1-4F9E-8672-EA69D5D81413}"/>
+              </a:ext>
+            </a:extLst>
+          </p:cNvPr>
+          <p:cNvSpPr>
+            <a:spLocks xmlns:a="http://schemas.openxmlformats.org/drawingml/2006/main" noGrp="1"/>
+          </p:cNvSpPr>
+          <p:nvPr/>
+        </p:nvSpPr>
+        <p:spPr>
+          <a:xfrm xmlns:a="http://schemas.openxmlformats.org/drawingml/2006/main">
+            <a:off x="4600575" y="4705350"/>
+            <a:ext cx="2990850" cy="533400"/>
+          </a:xfrm>
+          <a:prstGeom xmlns:a="http://schemas.openxmlformats.org/drawingml/2006/main" prst="rect">
+            <a:avLst/>
+          </a:prstGeom>
+          <a:noFill xmlns:a="http://schemas.openxmlformats.org/drawingml/2006/main"/>
+          <a:ln xmlns:a="http://schemas.openxmlformats.org/drawingml/2006/main" w="0">
+            <a:noFill/>
+            <a:prstDash val="solid"/>
+          </a:ln>
+        </p:spPr>
+        <p:txBody>
+          <a:bodyPr xmlns:a="http://schemas.openxmlformats.org/drawingml/2006/main"/>
+          <a:lstStyle xmlns:a="http://schemas.openxmlformats.org/drawingml/2006/main"/>
+          <a:p xmlns:a="http://schemas.openxmlformats.org/drawingml/2006/main">
+            <a:pPr algn="l">
+              <a:buNone/>
+              <a:defRPr sz="1425" b="0" i="0">
+                <a:solidFill>
+                  <a:srgbClr val="556070"/>
+                </a:solidFill>
+              </a:defRPr>
+            </a:pPr>
+            <a:r>
+              <a:rPr sz="1425" b="0" i="0">
+                <a:solidFill>
+                  <a:srgbClr val="556070"/>
+                </a:solidFill>
+              </a:rPr>
+              <a:t>Accuracy, completeness, integrity, custody, timing and observed overhead.</a:t>
+            </a:r>
+          </a:p>
+        </p:txBody>
+      </p:sp>
+      <p:sp>
+        <p:nvSpPr>
+          <p:cNvPr id="14" name="Rectangle: Rounded Corners 13">
+            <a:extLst xmlns:a="http://schemas.openxmlformats.org/drawingml/2006/main">
+              <a:ext uri="{FF2B5EF4-FFF2-40B4-BE49-F238E27FC236}">
+                <a16:creationId xmlns:a16="http://schemas.microsoft.com/office/drawing/2014/main" id="{01498B58-D6C6-41F2-BB9D-92B7BD427385}"/>
+              </a:ext>
+            </a:extLst>
+          </p:cNvPr>
+          <p:cNvSpPr>
+            <a:spLocks xmlns:a="http://schemas.openxmlformats.org/drawingml/2006/main" noGrp="1"/>
+          </p:cNvSpPr>
+          <p:nvPr/>
+        </p:nvSpPr>
+        <p:spPr>
+          <a:xfrm xmlns:a="http://schemas.openxmlformats.org/drawingml/2006/main">
+            <a:off x="8239125" y="3028950"/>
+            <a:ext cx="3562350" cy="2476500"/>
+          </a:xfrm>
+          <a:prstGeom xmlns:a="http://schemas.openxmlformats.org/drawingml/2006/main" prst="roundRect">
+            <a:avLst>
+              <a:gd name="adj" fmla="val 4615"/>
+            </a:avLst>
+          </a:prstGeom>
+          <a:solidFill xmlns:a="http://schemas.openxmlformats.org/drawingml/2006/main">
+            <a:srgbClr val="F2F4F7"/>
+          </a:solidFill>
+          <a:ln xmlns:a="http://schemas.openxmlformats.org/drawingml/2006/main" w="0">
+            <a:solidFill>
+              <a:srgbClr val="F2F4F7"/>
+            </a:solidFill>
+            <a:prstDash val="solid"/>
+          </a:ln>
+        </p:spPr>
+        <p:txBody>
+          <a:bodyPr xmlns:a="http://schemas.openxmlformats.org/drawingml/2006/main"/>
+          <a:lstStyle xmlns:a="http://schemas.openxmlformats.org/drawingml/2006/main"/>
+          <a:p xmlns:a="http://schemas.openxmlformats.org/drawingml/2006/main">
+            <a:endParaRPr/>
+          </a:p>
+        </p:txBody>
+      </p:sp>
+      <p:sp>
+        <p:nvSpPr>
+          <p:cNvPr id="15" name="Rectangle 14">
+            <a:extLst xmlns:a="http://schemas.openxmlformats.org/drawingml/2006/main">
+              <a:ext uri="{FF2B5EF4-FFF2-40B4-BE49-F238E27FC236}">
+                <a16:creationId xmlns:a16="http://schemas.microsoft.com/office/drawing/2014/main" id="{4A0098F9-8167-4529-A006-E0B9FC3492FF}"/>
+              </a:ext>
+            </a:extLst>
+          </p:cNvPr>
+          <p:cNvSpPr>
+            <a:spLocks xmlns:a="http://schemas.openxmlformats.org/drawingml/2006/main" noGrp="1"/>
+          </p:cNvSpPr>
+          <p:nvPr/>
+        </p:nvSpPr>
+        <p:spPr>
+          <a:xfrm xmlns:a="http://schemas.openxmlformats.org/drawingml/2006/main">
+            <a:off x="8524875" y="3333750"/>
+            <a:ext cx="2990850" cy="819150"/>
+          </a:xfrm>
+          <a:prstGeom xmlns:a="http://schemas.openxmlformats.org/drawingml/2006/main" prst="rect">
+            <a:avLst/>
+          </a:prstGeom>
+          <a:noFill xmlns:a="http://schemas.openxmlformats.org/drawingml/2006/main"/>
+          <a:ln xmlns:a="http://schemas.openxmlformats.org/drawingml/2006/main" w="0">
+            <a:noFill/>
+            <a:prstDash val="solid"/>
+          </a:ln>
+        </p:spPr>
+        <p:txBody>
+          <a:bodyPr xmlns:a="http://schemas.openxmlformats.org/drawingml/2006/main"/>
+          <a:lstStyle xmlns:a="http://schemas.openxmlformats.org/drawingml/2006/main"/>
+          <a:p xmlns:a="http://schemas.openxmlformats.org/drawingml/2006/main">
+            <a:pPr algn="l">
+              <a:buNone/>
+              <a:defRPr sz="4125" b="1" i="0">
+                <a:solidFill>
+                  <a:srgbClr val="1E62D0"/>
+                </a:solidFill>
+              </a:defRPr>
+            </a:pPr>
+            <a:r>
+              <a:rPr sz="4125" b="1" i="0">
+                <a:solidFill>
+                  <a:srgbClr val="1E62D0"/>
+                </a:solidFill>
+              </a:rPr>
+              <a:t>13</a:t>
+            </a:r>
+          </a:p>
+        </p:txBody>
+      </p:sp>
+      <p:sp>
+        <p:nvSpPr>
+          <p:cNvPr id="16" name="Rectangle 15">
+            <a:extLst xmlns:a="http://schemas.openxmlformats.org/drawingml/2006/main">
+              <a:ext uri="{FF2B5EF4-FFF2-40B4-BE49-F238E27FC236}">
+                <a16:creationId xmlns:a16="http://schemas.microsoft.com/office/drawing/2014/main" id="{BB9E1175-CF47-45C3-B187-A7CCBF4852F9}"/>
+              </a:ext>
+            </a:extLst>
+          </p:cNvPr>
+          <p:cNvSpPr>
+            <a:spLocks xmlns:a="http://schemas.openxmlformats.org/drawingml/2006/main" noGrp="1"/>
+          </p:cNvSpPr>
+          <p:nvPr/>
+        </p:nvSpPr>
+        <p:spPr>
+          <a:xfrm xmlns:a="http://schemas.openxmlformats.org/drawingml/2006/main">
+            <a:off x="8524875" y="4257675"/>
+            <a:ext cx="2990850" cy="323850"/>
+          </a:xfrm>
+          <a:prstGeom xmlns:a="http://schemas.openxmlformats.org/drawingml/2006/main" prst="rect">
+            <a:avLst/>
+          </a:prstGeom>
+          <a:noFill xmlns:a="http://schemas.openxmlformats.org/drawingml/2006/main"/>
+          <a:ln xmlns:a="http://schemas.openxmlformats.org/drawingml/2006/main" w="0">
+            <a:noFill/>
+            <a:prstDash val="solid"/>
+          </a:ln>
+        </p:spPr>
+        <p:txBody>
+          <a:bodyPr xmlns:a="http://schemas.openxmlformats.org/drawingml/2006/main"/>
+          <a:lstStyle xmlns:a="http://schemas.openxmlformats.org/drawingml/2006/main"/>
+          <a:p xmlns:a="http://schemas.openxmlformats.org/drawingml/2006/main">
+            <a:pPr algn="l">
+              <a:buNone/>
+              <a:defRPr sz="1800" b="1" i="0">
+                <a:solidFill>
+                  <a:srgbClr val="111827"/>
+                </a:solidFill>
+              </a:defRPr>
+            </a:pPr>
+            <a:r>
+              <a:rPr sz="1800" b="1" i="0">
+                <a:solidFill>
+                  <a:srgbClr val="111827"/>
+                </a:solidFill>
+              </a:rPr>
+              <a:t>healthy containers</a:t>
+            </a:r>
+          </a:p>
+        </p:txBody>
+      </p:sp>
+      <p:sp>
+        <p:nvSpPr>
+          <p:cNvPr id="17" name="Rectangle 16">
+            <a:extLst xmlns:a="http://schemas.openxmlformats.org/drawingml/2006/main">
+              <a:ext uri="{FF2B5EF4-FFF2-40B4-BE49-F238E27FC236}">
+                <a16:creationId xmlns:a16="http://schemas.microsoft.com/office/drawing/2014/main" id="{E5E1FF9F-0ED6-414F-9AA3-716D3AFB53FC}"/>
+              </a:ext>
+            </a:extLst>
+          </p:cNvPr>
+          <p:cNvSpPr>
+            <a:spLocks xmlns:a="http://schemas.openxmlformats.org/drawingml/2006/main" noGrp="1"/>
+          </p:cNvSpPr>
+          <p:nvPr/>
+        </p:nvSpPr>
+        <p:spPr>
+          <a:xfrm xmlns:a="http://schemas.openxmlformats.org/drawingml/2006/main">
+            <a:off x="8524875" y="4705350"/>
+            <a:ext cx="2990850" cy="533400"/>
+          </a:xfrm>
+          <a:prstGeom xmlns:a="http://schemas.openxmlformats.org/drawingml/2006/main" prst="rect">
+            <a:avLst/>
+          </a:prstGeom>
+          <a:noFill xmlns:a="http://schemas.openxmlformats.org/drawingml/2006/main"/>
+          <a:ln xmlns:a="http://schemas.openxmlformats.org/drawingml/2006/main" w="0">
+            <a:noFill/>
+            <a:prstDash val="solid"/>
+          </a:ln>
+        </p:spPr>
+        <p:txBody>
+          <a:bodyPr xmlns:a="http://schemas.openxmlformats.org/drawingml/2006/main"/>
+          <a:lstStyle xmlns:a="http://schemas.openxmlformats.org/drawingml/2006/main"/>
+          <a:p xmlns:a="http://schemas.openxmlformats.org/drawingml/2006/main">
+            <a:pPr algn="l">
+              <a:buNone/>
+              <a:defRPr sz="1425" b="0" i="0">
+                <a:solidFill>
+                  <a:srgbClr val="556070"/>
+                </a:solidFill>
+              </a:defRPr>
+            </a:pPr>
+            <a:r>
+              <a:rPr sz="1425" b="0" i="0">
+                <a:solidFill>
+                  <a:srgbClr val="556070"/>
+                </a:solidFill>
+              </a:rPr>
+              <a:t>The current controlled laboratory remained available during validation.</a:t>
+            </a:r>
+          </a:p>
+        </p:txBody>
+      </p:sp>
+      <p:sp>
+        <p:nvSpPr>
+          <p:cNvPr id="18" name="Rectangle 17">
+            <a:extLst xmlns:a="http://schemas.openxmlformats.org/drawingml/2006/main">
+              <a:ext uri="{FF2B5EF4-FFF2-40B4-BE49-F238E27FC236}">
+                <a16:creationId xmlns:a16="http://schemas.microsoft.com/office/drawing/2014/main" id="{FFAD0E28-F7CE-43F6-AC0B-16E8BE280208}"/>
+              </a:ext>
+            </a:extLst>
+          </p:cNvPr>
+          <p:cNvSpPr>
+            <a:spLocks xmlns:a="http://schemas.openxmlformats.org/drawingml/2006/main" noGrp="1"/>
+          </p:cNvSpPr>
+          <p:nvPr/>
+        </p:nvSpPr>
+        <p:spPr>
+          <a:xfrm xmlns:a="http://schemas.openxmlformats.org/drawingml/2006/main">
+            <a:off x="400050" y="5857875"/>
+            <a:ext cx="8286750" cy="304800"/>
+          </a:xfrm>
+          <a:prstGeom xmlns:a="http://schemas.openxmlformats.org/drawingml/2006/main" prst="rect">
+            <a:avLst/>
+          </a:prstGeom>
+          <a:noFill xmlns:a="http://schemas.openxmlformats.org/drawingml/2006/main"/>
+          <a:ln xmlns:a="http://schemas.openxmlformats.org/drawingml/2006/main" w="0">
+            <a:noFill/>
+            <a:prstDash val="solid"/>
+          </a:ln>
+        </p:spPr>
+        <p:txBody>
+          <a:bodyPr xmlns:a="http://schemas.openxmlformats.org/drawingml/2006/main"/>
+          <a:lstStyle xmlns:a="http://schemas.openxmlformats.org/drawingml/2006/main"/>
+          <a:p xmlns:a="http://schemas.openxmlformats.org/drawingml/2006/main">
+            <a:pPr algn="l">
+              <a:buNone/>
+              <a:defRPr sz="2100" b="1" i="0">
+                <a:solidFill>
+                  <a:srgbClr val="111827"/>
+                </a:solidFill>
+              </a:defRPr>
+            </a:pPr>
+            <a:r>
+              <a:rPr sz="2100" b="1" i="0">
+                <a:solidFill>
+                  <a:srgbClr val="111827"/>
+                </a:solidFill>
+              </a:rPr>
+              <a:t>Known inputs  -&gt;  retained evidence  -&gt;  measured result</a:t>
+            </a:r>
+          </a:p>
+        </p:txBody>
+      </p:sp>
+    </p:spTree>
+    <p:extLst>
+      <p:ext uri="{BB962C8B-B14F-4D97-AF65-F5344CB8AC3E}">
+        <p14:creationId xmlns:p14="http://schemas.microsoft.com/office/powerpoint/2010/main" val="128034828"/>
+      </p:ext>
+    </p:extLst>
+  </p:cSld>
+</p:sld>
+</file>
+
+<file path=ppt/slides/slide14.xml><?xml version="1.0" encoding="utf-8"?>
+<p:sld xmlns:p="http://schemas.openxmlformats.org/presentationml/2006/main">
+  <p:cSld>
+    <p:bg>
+      <p:bgPr>
+        <a:solidFill xmlns:a="http://schemas.openxmlformats.org/drawingml/2006/main">
+          <a:srgbClr val="FFFFFF"/>
+        </a:solidFill>
+      </p:bgPr>
+    </p:bg>
+    <p:spTree>
+      <p:nvGrpSpPr>
+        <p:cNvPr id="1" name=""/>
+        <p:cNvGrpSpPr/>
+        <p:nvPr/>
+      </p:nvGrpSpPr>
+      <p:grpSpPr>
+        <a:xfrm xmlns:a="http://schemas.openxmlformats.org/drawingml/2006/main"/>
+      </p:grpSpPr>
+      <p:sp>
+        <p:nvSpPr>
+          <p:cNvPr id="19" name="Rectangle 18">
+            <a:extLst xmlns:a="http://schemas.openxmlformats.org/drawingml/2006/main">
+              <a:ext uri="{FF2B5EF4-FFF2-40B4-BE49-F238E27FC236}">
+                <a16:creationId xmlns:a16="http://schemas.microsoft.com/office/drawing/2014/main" id="{55A5DA34-C420-49E9-A8D6-D5FE5E224B0E}"/>
+              </a:ext>
+            </a:extLst>
+          </p:cNvPr>
+          <p:cNvSpPr>
+            <a:spLocks xmlns:a="http://schemas.openxmlformats.org/drawingml/2006/main" noGrp="1"/>
+          </p:cNvSpPr>
+          <p:nvPr/>
+        </p:nvSpPr>
+        <p:spPr>
+          <a:xfrm xmlns:a="http://schemas.openxmlformats.org/drawingml/2006/main">
+            <a:off x="400050" y="323850"/>
+            <a:ext cx="2476500" cy="228600"/>
+          </a:xfrm>
+          <a:prstGeom xmlns:a="http://schemas.openxmlformats.org/drawingml/2006/main" prst="rect">
+            <a:avLst/>
+          </a:prstGeom>
+          <a:noFill xmlns:a="http://schemas.openxmlformats.org/drawingml/2006/main"/>
+          <a:ln xmlns:a="http://schemas.openxmlformats.org/drawingml/2006/main" w="0">
+            <a:noFill/>
+            <a:prstDash val="solid"/>
+          </a:ln>
+        </p:spPr>
+        <p:txBody>
+          <a:bodyPr xmlns:a="http://schemas.openxmlformats.org/drawingml/2006/main"/>
+          <a:lstStyle xmlns:a="http://schemas.openxmlformats.org/drawingml/2006/main"/>
+          <a:p xmlns:a="http://schemas.openxmlformats.org/drawingml/2006/main">
+            <a:pPr algn="l">
+              <a:buNone/>
+              <a:defRPr sz="1125" b="1" i="0">
+                <a:solidFill>
+                  <a:srgbClr val="1E62D0"/>
+                </a:solidFill>
+              </a:defRPr>
+            </a:pPr>
+            <a:r>
+              <a:rPr sz="1125" b="1" i="0">
+                <a:solidFill>
+                  <a:srgbClr val="1E62D0"/>
+                </a:solidFill>
+              </a:rPr>
+              <a:t>PHASE 6 LIVE CHECK</a:t>
+            </a:r>
+          </a:p>
+        </p:txBody>
+      </p:sp>
+      <p:sp>
+        <p:nvSpPr>
+          <p:cNvPr id="2" name="Rectangle 1">
+            <a:extLst xmlns:a="http://schemas.openxmlformats.org/drawingml/2006/main">
+              <a:ext uri="{FF2B5EF4-FFF2-40B4-BE49-F238E27FC236}">
+                <a16:creationId xmlns:a16="http://schemas.microsoft.com/office/drawing/2014/main" id="{0E27AA63-BD07-46C1-BE21-63EB556A97D6}"/>
+              </a:ext>
+            </a:extLst>
+          </p:cNvPr>
+          <p:cNvSpPr>
+            <a:spLocks xmlns:a="http://schemas.openxmlformats.org/drawingml/2006/main" noGrp="1"/>
+          </p:cNvSpPr>
+          <p:nvPr/>
+        </p:nvSpPr>
+        <p:spPr>
+          <a:xfrm xmlns:a="http://schemas.openxmlformats.org/drawingml/2006/main">
+            <a:off x="400050" y="628650"/>
+            <a:ext cx="10668000" cy="523875"/>
+          </a:xfrm>
+          <a:prstGeom xmlns:a="http://schemas.openxmlformats.org/drawingml/2006/main" prst="rect">
+            <a:avLst/>
+          </a:prstGeom>
+          <a:noFill xmlns:a="http://schemas.openxmlformats.org/drawingml/2006/main"/>
+          <a:ln xmlns:a="http://schemas.openxmlformats.org/drawingml/2006/main" w="0">
+            <a:noFill/>
+            <a:prstDash val="solid"/>
+          </a:ln>
+        </p:spPr>
+        <p:txBody>
+          <a:bodyPr xmlns:a="http://schemas.openxmlformats.org/drawingml/2006/main"/>
+          <a:lstStyle xmlns:a="http://schemas.openxmlformats.org/drawingml/2006/main"/>
+          <a:p xmlns:a="http://schemas.openxmlformats.org/drawingml/2006/main">
+            <a:pPr algn="l">
+              <a:buNone/>
+              <a:defRPr sz="2925" b="1" i="0">
+                <a:solidFill>
+                  <a:srgbClr val="111827"/>
+                </a:solidFill>
+              </a:defRPr>
+            </a:pPr>
+            <a:r>
+              <a:rPr sz="2925" b="1" i="0">
+                <a:solidFill>
+                  <a:srgbClr val="111827"/>
+                </a:solidFill>
+              </a:rPr>
+              <a:t>The two-slice laboratory is running</a:t>
+            </a:r>
+          </a:p>
+        </p:txBody>
+      </p:sp>
+      <p:sp>
+        <p:nvSpPr>
+          <p:cNvPr id="3" name="Rectangle 2">
+            <a:extLst xmlns:a="http://schemas.openxmlformats.org/drawingml/2006/main">
+              <a:ext uri="{FF2B5EF4-FFF2-40B4-BE49-F238E27FC236}">
+                <a16:creationId xmlns:a16="http://schemas.microsoft.com/office/drawing/2014/main" id="{6C5D6579-5BB8-4728-A410-81FE72EDF754}"/>
+              </a:ext>
+            </a:extLst>
+          </p:cNvPr>
+          <p:cNvSpPr>
+            <a:spLocks xmlns:a="http://schemas.openxmlformats.org/drawingml/2006/main" noGrp="1"/>
+          </p:cNvSpPr>
+          <p:nvPr/>
+        </p:nvSpPr>
+        <p:spPr>
+          <a:xfrm xmlns:a="http://schemas.openxmlformats.org/drawingml/2006/main">
+            <a:off x="400050" y="1276350"/>
+            <a:ext cx="11391900" cy="9525"/>
+          </a:xfrm>
+          <a:prstGeom xmlns:a="http://schemas.openxmlformats.org/drawingml/2006/main" prst="rect">
+            <a:avLst/>
+          </a:prstGeom>
+          <a:solidFill xmlns:a="http://schemas.openxmlformats.org/drawingml/2006/main">
+            <a:srgbClr val="C8CED6"/>
+          </a:solidFill>
+          <a:ln xmlns:a="http://schemas.openxmlformats.org/drawingml/2006/main" w="0">
+            <a:solidFill>
+              <a:srgbClr val="C8CED6"/>
+            </a:solidFill>
+            <a:prstDash val="solid"/>
+          </a:ln>
+        </p:spPr>
+        <p:txBody>
+          <a:bodyPr xmlns:a="http://schemas.openxmlformats.org/drawingml/2006/main"/>
+          <a:lstStyle xmlns:a="http://schemas.openxmlformats.org/drawingml/2006/main"/>
+          <a:p xmlns:a="http://schemas.openxmlformats.org/drawingml/2006/main">
+            <a:endParaRPr/>
+          </a:p>
+        </p:txBody>
+      </p:sp>
+      <p:sp>
+        <p:nvSpPr>
+          <p:cNvPr id="4" name="Rectangle 3">
+            <a:extLst xmlns:a="http://schemas.openxmlformats.org/drawingml/2006/main">
+              <a:ext uri="{FF2B5EF4-FFF2-40B4-BE49-F238E27FC236}">
+                <a16:creationId xmlns:a16="http://schemas.microsoft.com/office/drawing/2014/main" id="{63289BDA-C2D1-42E7-A732-82219BCE344D}"/>
+              </a:ext>
+            </a:extLst>
+          </p:cNvPr>
+          <p:cNvSpPr>
+            <a:spLocks xmlns:a="http://schemas.openxmlformats.org/drawingml/2006/main" noGrp="1"/>
+          </p:cNvSpPr>
+          <p:nvPr/>
+        </p:nvSpPr>
+        <p:spPr>
+          <a:xfrm xmlns:a="http://schemas.openxmlformats.org/drawingml/2006/main">
+            <a:off x="9715500" y="6286500"/>
+            <a:ext cx="2076450" cy="190500"/>
+          </a:xfrm>
+          <a:prstGeom xmlns:a="http://schemas.openxmlformats.org/drawingml/2006/main" prst="rect">
+            <a:avLst/>
+          </a:prstGeom>
+          <a:noFill xmlns:a="http://schemas.openxmlformats.org/drawingml/2006/main"/>
+          <a:ln xmlns:a="http://schemas.openxmlformats.org/drawingml/2006/main" w="0">
+            <a:noFill/>
+            <a:prstDash val="solid"/>
+          </a:ln>
+        </p:spPr>
+        <p:txBody>
+          <a:bodyPr xmlns:a="http://schemas.openxmlformats.org/drawingml/2006/main"/>
+          <a:lstStyle xmlns:a="http://schemas.openxmlformats.org/drawingml/2006/main"/>
+          <a:p xmlns:a="http://schemas.openxmlformats.org/drawingml/2006/main">
+            <a:pPr algn="r">
+              <a:buNone/>
+              <a:defRPr sz="975" b="0" i="0">
+                <a:solidFill>
+                  <a:srgbClr val="556070"/>
+                </a:solidFill>
+              </a:defRPr>
+            </a:pPr>
+            <a:r>
+              <a:rPr sz="975" b="0" i="0">
+                <a:solidFill>
+                  <a:srgbClr val="556070"/>
+                </a:solidFill>
+              </a:rPr>
+              <a:t>4 SEPTEMBER 2026  |  14</a:t>
+            </a:r>
+          </a:p>
+        </p:txBody>
+      </p:sp>
+      <p:sp>
+        <p:nvSpPr>
+          <p:cNvPr id="5" name="Rectangle: Rounded Corners 4">
+            <a:extLst xmlns:a="http://schemas.openxmlformats.org/drawingml/2006/main">
+              <a:ext uri="{FF2B5EF4-FFF2-40B4-BE49-F238E27FC236}">
+                <a16:creationId xmlns:a16="http://schemas.microsoft.com/office/drawing/2014/main" id="{71E6C9CD-7201-47E4-8C0A-6A868688BC76}"/>
+              </a:ext>
+            </a:extLst>
+          </p:cNvPr>
+          <p:cNvSpPr>
+            <a:spLocks xmlns:a="http://schemas.openxmlformats.org/drawingml/2006/main" noGrp="1"/>
+          </p:cNvSpPr>
+          <p:nvPr/>
+        </p:nvSpPr>
+        <p:spPr>
+          <a:xfrm xmlns:a="http://schemas.openxmlformats.org/drawingml/2006/main">
+            <a:off x="400050" y="1562100"/>
+            <a:ext cx="1524000" cy="323850"/>
+          </a:xfrm>
+          <a:prstGeom xmlns:a="http://schemas.openxmlformats.org/drawingml/2006/main" prst="roundRect">
+            <a:avLst>
+              <a:gd name="adj" fmla="val 23529"/>
+            </a:avLst>
+          </a:prstGeom>
+          <a:solidFill xmlns:a="http://schemas.openxmlformats.org/drawingml/2006/main">
+            <a:srgbClr val="EAF5FB"/>
+          </a:solidFill>
+          <a:ln xmlns:a="http://schemas.openxmlformats.org/drawingml/2006/main" w="0">
+            <a:solidFill>
+              <a:srgbClr val="EAF5FB"/>
+            </a:solidFill>
+            <a:prstDash val="solid"/>
+          </a:ln>
+        </p:spPr>
+        <p:txBody>
+          <a:bodyPr xmlns:a="http://schemas.openxmlformats.org/drawingml/2006/main"/>
+          <a:lstStyle xmlns:a="http://schemas.openxmlformats.org/drawingml/2006/main"/>
+          <a:p xmlns:a="http://schemas.openxmlformats.org/drawingml/2006/main">
+            <a:endParaRPr/>
+          </a:p>
+        </p:txBody>
+      </p:sp>
+      <p:sp>
+        <p:nvSpPr>
+          <p:cNvPr id="6" name="Rectangle 5">
+            <a:extLst xmlns:a="http://schemas.openxmlformats.org/drawingml/2006/main">
+              <a:ext uri="{FF2B5EF4-FFF2-40B4-BE49-F238E27FC236}">
+                <a16:creationId xmlns:a16="http://schemas.microsoft.com/office/drawing/2014/main" id="{A41FEFA4-FC06-4DEF-A5AD-4BE83AB6C195}"/>
+              </a:ext>
+            </a:extLst>
+          </p:cNvPr>
+          <p:cNvSpPr>
+            <a:spLocks xmlns:a="http://schemas.openxmlformats.org/drawingml/2006/main" noGrp="1"/>
+          </p:cNvSpPr>
+          <p:nvPr/>
+        </p:nvSpPr>
+        <p:spPr>
+          <a:xfrm xmlns:a="http://schemas.openxmlformats.org/drawingml/2006/main">
+            <a:off x="514350" y="1628775"/>
+            <a:ext cx="1295400" cy="190500"/>
+          </a:xfrm>
+          <a:prstGeom xmlns:a="http://schemas.openxmlformats.org/drawingml/2006/main" prst="rect">
+            <a:avLst/>
+          </a:prstGeom>
+          <a:noFill xmlns:a="http://schemas.openxmlformats.org/drawingml/2006/main"/>
+          <a:ln xmlns:a="http://schemas.openxmlformats.org/drawingml/2006/main" w="0">
+            <a:noFill/>
+            <a:prstDash val="solid"/>
+          </a:ln>
+        </p:spPr>
+        <p:txBody>
+          <a:bodyPr xmlns:a="http://schemas.openxmlformats.org/drawingml/2006/main"/>
+          <a:lstStyle xmlns:a="http://schemas.openxmlformats.org/drawingml/2006/main"/>
+          <a:p xmlns:a="http://schemas.openxmlformats.org/drawingml/2006/main">
+            <a:pPr algn="ctr">
+              <a:buNone/>
+              <a:defRPr sz="1050" b="1" i="0">
+                <a:solidFill>
+                  <a:srgbClr val="1E62D0"/>
+                </a:solidFill>
+              </a:defRPr>
+            </a:pPr>
+            <a:r>
+              <a:rPr sz="1050" b="1" i="0">
+                <a:solidFill>
+                  <a:srgbClr val="1E62D0"/>
+                </a:solidFill>
+              </a:rPr>
+              <a:t>VERIFIED</a:t>
+            </a:r>
+          </a:p>
+        </p:txBody>
+      </p:sp>
+      <p:sp>
+        <p:nvSpPr>
+          <p:cNvPr id="7" name="Rectangle 6">
+            <a:extLst xmlns:a="http://schemas.openxmlformats.org/drawingml/2006/main">
+              <a:ext uri="{FF2B5EF4-FFF2-40B4-BE49-F238E27FC236}">
+                <a16:creationId xmlns:a16="http://schemas.microsoft.com/office/drawing/2014/main" id="{A6E7A077-5FAD-432F-AE55-49C207C0D2C4}"/>
+              </a:ext>
+            </a:extLst>
+          </p:cNvPr>
+          <p:cNvSpPr>
+            <a:spLocks xmlns:a="http://schemas.openxmlformats.org/drawingml/2006/main" noGrp="1"/>
+          </p:cNvSpPr>
+          <p:nvPr/>
+        </p:nvSpPr>
+        <p:spPr>
+          <a:xfrm xmlns:a="http://schemas.openxmlformats.org/drawingml/2006/main">
+            <a:off x="400050" y="2133600"/>
+            <a:ext cx="4000500" cy="323850"/>
+          </a:xfrm>
+          <a:prstGeom xmlns:a="http://schemas.openxmlformats.org/drawingml/2006/main" prst="rect">
+            <a:avLst/>
+          </a:prstGeom>
+          <a:noFill xmlns:a="http://schemas.openxmlformats.org/drawingml/2006/main"/>
+          <a:ln xmlns:a="http://schemas.openxmlformats.org/drawingml/2006/main" w="0">
+            <a:noFill/>
+            <a:prstDash val="solid"/>
+          </a:ln>
+        </p:spPr>
+        <p:txBody>
+          <a:bodyPr xmlns:a="http://schemas.openxmlformats.org/drawingml/2006/main"/>
+          <a:lstStyle xmlns:a="http://schemas.openxmlformats.org/drawingml/2006/main"/>
+          <a:p xmlns:a="http://schemas.openxmlformats.org/drawingml/2006/main">
+            <a:pPr algn="l">
+              <a:buNone/>
+              <a:defRPr sz="2025" b="1" i="0">
+                <a:solidFill>
+                  <a:srgbClr val="111827"/>
+                </a:solidFill>
+              </a:defRPr>
+            </a:pPr>
+            <a:r>
+              <a:rPr sz="2025" b="1" i="0">
+                <a:solidFill>
+                  <a:srgbClr val="111827"/>
+                </a:solidFill>
+              </a:rPr>
+              <a:t>What I checked</a:t>
+            </a:r>
+          </a:p>
+        </p:txBody>
+      </p:sp>
+      <p:sp>
+        <p:nvSpPr>
+          <p:cNvPr id="8" name="Oval 7">
+            <a:extLst xmlns:a="http://schemas.openxmlformats.org/drawingml/2006/main">
+              <a:ext uri="{FF2B5EF4-FFF2-40B4-BE49-F238E27FC236}">
+                <a16:creationId xmlns:a16="http://schemas.microsoft.com/office/drawing/2014/main" id="{466E0E89-9993-4342-8EE6-3E89BC026C25}"/>
+              </a:ext>
+            </a:extLst>
+          </p:cNvPr>
+          <p:cNvSpPr>
+            <a:spLocks xmlns:a="http://schemas.openxmlformats.org/drawingml/2006/main" noGrp="1"/>
+          </p:cNvSpPr>
+          <p:nvPr/>
+        </p:nvSpPr>
+        <p:spPr>
+          <a:xfrm xmlns:a="http://schemas.openxmlformats.org/drawingml/2006/main">
+            <a:off x="400050" y="2771775"/>
+            <a:ext cx="95250" cy="95250"/>
+          </a:xfrm>
+          <a:prstGeom xmlns:a="http://schemas.openxmlformats.org/drawingml/2006/main" prst="ellipse">
+            <a:avLst/>
+          </a:prstGeom>
+          <a:solidFill xmlns:a="http://schemas.openxmlformats.org/drawingml/2006/main">
+            <a:srgbClr val="1E62D0"/>
+          </a:solidFill>
+          <a:ln xmlns:a="http://schemas.openxmlformats.org/drawingml/2006/main" w="0">
+            <a:solidFill>
+              <a:srgbClr val="1E62D0"/>
+            </a:solidFill>
+            <a:prstDash val="solid"/>
+          </a:ln>
+        </p:spPr>
+        <p:txBody>
+          <a:bodyPr xmlns:a="http://schemas.openxmlformats.org/drawingml/2006/main"/>
+          <a:lstStyle xmlns:a="http://schemas.openxmlformats.org/drawingml/2006/main"/>
+          <a:p xmlns:a="http://schemas.openxmlformats.org/drawingml/2006/main">
+            <a:endParaRPr/>
+          </a:p>
+        </p:txBody>
+      </p:sp>
+      <p:sp>
+        <p:nvSpPr>
+          <p:cNvPr id="9" name="Rectangle 8">
+            <a:extLst xmlns:a="http://schemas.openxmlformats.org/drawingml/2006/main">
+              <a:ext uri="{FF2B5EF4-FFF2-40B4-BE49-F238E27FC236}">
+                <a16:creationId xmlns:a16="http://schemas.microsoft.com/office/drawing/2014/main" id="{BEA36EFB-F764-4AB5-BCAF-8D612568DF00}"/>
+              </a:ext>
+            </a:extLst>
+          </p:cNvPr>
+          <p:cNvSpPr>
+            <a:spLocks xmlns:a="http://schemas.openxmlformats.org/drawingml/2006/main" noGrp="1"/>
+          </p:cNvSpPr>
+          <p:nvPr/>
+        </p:nvSpPr>
+        <p:spPr>
+          <a:xfrm xmlns:a="http://schemas.openxmlformats.org/drawingml/2006/main">
+            <a:off x="647700" y="2686050"/>
+            <a:ext cx="4895850" cy="628650"/>
+          </a:xfrm>
+          <a:prstGeom xmlns:a="http://schemas.openxmlformats.org/drawingml/2006/main" prst="rect">
+            <a:avLst/>
+          </a:prstGeom>
+          <a:noFill xmlns:a="http://schemas.openxmlformats.org/drawingml/2006/main"/>
+          <a:ln xmlns:a="http://schemas.openxmlformats.org/drawingml/2006/main" w="0">
+            <a:noFill/>
+            <a:prstDash val="solid"/>
+          </a:ln>
+        </p:spPr>
+        <p:txBody>
+          <a:bodyPr xmlns:a="http://schemas.openxmlformats.org/drawingml/2006/main"/>
+          <a:lstStyle xmlns:a="http://schemas.openxmlformats.org/drawingml/2006/main"/>
+          <a:p xmlns:a="http://schemas.openxmlformats.org/drawingml/2006/main">
+            <a:pPr algn="l">
+              <a:buNone/>
+              <a:defRPr sz="1800" b="0" i="0">
+                <a:solidFill>
+                  <a:srgbClr val="111827"/>
+                </a:solidFill>
+              </a:defRPr>
+            </a:pPr>
+            <a:r>
+              <a:rPr sz="1800" b="0" i="0">
+                <a:solidFill>
+                  <a:srgbClr val="111827"/>
+                </a:solidFill>
+              </a:rPr>
+              <a:t>Confirmed 13 core and radio containers are healthy.</a:t>
+            </a:r>
+          </a:p>
+        </p:txBody>
+      </p:sp>
+      <p:sp>
+        <p:nvSpPr>
+          <p:cNvPr id="10" name="Oval 9">
+            <a:extLst xmlns:a="http://schemas.openxmlformats.org/drawingml/2006/main">
+              <a:ext uri="{FF2B5EF4-FFF2-40B4-BE49-F238E27FC236}">
+                <a16:creationId xmlns:a16="http://schemas.microsoft.com/office/drawing/2014/main" id="{52D4D63B-8258-449A-AE5C-7F3200BA652B}"/>
+              </a:ext>
+            </a:extLst>
+          </p:cNvPr>
+          <p:cNvSpPr>
+            <a:spLocks xmlns:a="http://schemas.openxmlformats.org/drawingml/2006/main" noGrp="1"/>
+          </p:cNvSpPr>
+          <p:nvPr/>
+        </p:nvSpPr>
+        <p:spPr>
+          <a:xfrm xmlns:a="http://schemas.openxmlformats.org/drawingml/2006/main">
+            <a:off x="400050" y="3438525"/>
+            <a:ext cx="95250" cy="95250"/>
+          </a:xfrm>
+          <a:prstGeom xmlns:a="http://schemas.openxmlformats.org/drawingml/2006/main" prst="ellipse">
+            <a:avLst/>
+          </a:prstGeom>
+          <a:solidFill xmlns:a="http://schemas.openxmlformats.org/drawingml/2006/main">
+            <a:srgbClr val="1E62D0"/>
+          </a:solidFill>
+          <a:ln xmlns:a="http://schemas.openxmlformats.org/drawingml/2006/main" w="0">
+            <a:solidFill>
+              <a:srgbClr val="1E62D0"/>
+            </a:solidFill>
+            <a:prstDash val="solid"/>
+          </a:ln>
+        </p:spPr>
+        <p:txBody>
+          <a:bodyPr xmlns:a="http://schemas.openxmlformats.org/drawingml/2006/main"/>
+          <a:lstStyle xmlns:a="http://schemas.openxmlformats.org/drawingml/2006/main"/>
+          <a:p xmlns:a="http://schemas.openxmlformats.org/drawingml/2006/main">
+            <a:endParaRPr/>
+          </a:p>
+        </p:txBody>
+      </p:sp>
+      <p:sp>
+        <p:nvSpPr>
+          <p:cNvPr id="11" name="Rectangle 10">
+            <a:extLst xmlns:a="http://schemas.openxmlformats.org/drawingml/2006/main">
+              <a:ext uri="{FF2B5EF4-FFF2-40B4-BE49-F238E27FC236}">
+                <a16:creationId xmlns:a16="http://schemas.microsoft.com/office/drawing/2014/main" id="{2E327876-F121-426E-9133-2F0DFE8DA563}"/>
+              </a:ext>
+            </a:extLst>
+          </p:cNvPr>
+          <p:cNvSpPr>
+            <a:spLocks xmlns:a="http://schemas.openxmlformats.org/drawingml/2006/main" noGrp="1"/>
+          </p:cNvSpPr>
+          <p:nvPr/>
+        </p:nvSpPr>
+        <p:spPr>
+          <a:xfrm xmlns:a="http://schemas.openxmlformats.org/drawingml/2006/main">
+            <a:off x="647700" y="3352800"/>
+            <a:ext cx="4895850" cy="628650"/>
+          </a:xfrm>
+          <a:prstGeom xmlns:a="http://schemas.openxmlformats.org/drawingml/2006/main" prst="rect">
+            <a:avLst/>
+          </a:prstGeom>
+          <a:noFill xmlns:a="http://schemas.openxmlformats.org/drawingml/2006/main"/>
+          <a:ln xmlns:a="http://schemas.openxmlformats.org/drawingml/2006/main" w="0">
+            <a:noFill/>
+            <a:prstDash val="solid"/>
+          </a:ln>
+        </p:spPr>
+        <p:txBody>
+          <a:bodyPr xmlns:a="http://schemas.openxmlformats.org/drawingml/2006/main"/>
+          <a:lstStyle xmlns:a="http://schemas.openxmlformats.org/drawingml/2006/main"/>
+          <a:p xmlns:a="http://schemas.openxmlformats.org/drawingml/2006/main">
+            <a:pPr algn="l">
+              <a:buNone/>
+              <a:defRPr sz="1800" b="0" i="0">
+                <a:solidFill>
+                  <a:srgbClr val="111827"/>
+                </a:solidFill>
+              </a:defRPr>
+            </a:pPr>
+            <a:r>
+              <a:rPr sz="1800" b="0" i="0">
+                <a:solidFill>
+                  <a:srgbClr val="111827"/>
+                </a:solidFill>
+              </a:rPr>
+              <a:t>Re-ran the evidence chain from Phase 1 through Phase 6.</a:t>
+            </a:r>
+          </a:p>
+        </p:txBody>
+      </p:sp>
+      <p:sp>
+        <p:nvSpPr>
+          <p:cNvPr id="12" name="Oval 11">
+            <a:extLst xmlns:a="http://schemas.openxmlformats.org/drawingml/2006/main">
+              <a:ext uri="{FF2B5EF4-FFF2-40B4-BE49-F238E27FC236}">
+                <a16:creationId xmlns:a16="http://schemas.microsoft.com/office/drawing/2014/main" id="{D1B5487E-30CB-412D-BA03-01BFF0590EDB}"/>
+              </a:ext>
+            </a:extLst>
+          </p:cNvPr>
+          <p:cNvSpPr>
+            <a:spLocks xmlns:a="http://schemas.openxmlformats.org/drawingml/2006/main" noGrp="1"/>
+          </p:cNvSpPr>
+          <p:nvPr/>
+        </p:nvSpPr>
+        <p:spPr>
+          <a:xfrm xmlns:a="http://schemas.openxmlformats.org/drawingml/2006/main">
+            <a:off x="400050" y="4105275"/>
+            <a:ext cx="95250" cy="95250"/>
+          </a:xfrm>
+          <a:prstGeom xmlns:a="http://schemas.openxmlformats.org/drawingml/2006/main" prst="ellipse">
+            <a:avLst/>
+          </a:prstGeom>
+          <a:solidFill xmlns:a="http://schemas.openxmlformats.org/drawingml/2006/main">
+            <a:srgbClr val="1E62D0"/>
+          </a:solidFill>
+          <a:ln xmlns:a="http://schemas.openxmlformats.org/drawingml/2006/main" w="0">
+            <a:solidFill>
+              <a:srgbClr val="1E62D0"/>
+            </a:solidFill>
+            <a:prstDash val="solid"/>
+          </a:ln>
+        </p:spPr>
+        <p:txBody>
+          <a:bodyPr xmlns:a="http://schemas.openxmlformats.org/drawingml/2006/main"/>
+          <a:lstStyle xmlns:a="http://schemas.openxmlformats.org/drawingml/2006/main"/>
+          <a:p xmlns:a="http://schemas.openxmlformats.org/drawingml/2006/main">
+            <a:endParaRPr/>
+          </a:p>
+        </p:txBody>
+      </p:sp>
+      <p:sp>
+        <p:nvSpPr>
+          <p:cNvPr id="13" name="Rectangle 12">
+            <a:extLst xmlns:a="http://schemas.openxmlformats.org/drawingml/2006/main">
+              <a:ext uri="{FF2B5EF4-FFF2-40B4-BE49-F238E27FC236}">
+                <a16:creationId xmlns:a16="http://schemas.microsoft.com/office/drawing/2014/main" id="{1A628F30-08B2-4C7D-9D8E-E5DF94B2A117}"/>
+              </a:ext>
+            </a:extLst>
+          </p:cNvPr>
+          <p:cNvSpPr>
+            <a:spLocks xmlns:a="http://schemas.openxmlformats.org/drawingml/2006/main" noGrp="1"/>
+          </p:cNvSpPr>
+          <p:nvPr/>
+        </p:nvSpPr>
+        <p:spPr>
+          <a:xfrm xmlns:a="http://schemas.openxmlformats.org/drawingml/2006/main">
+            <a:off x="647700" y="4019550"/>
+            <a:ext cx="4895850" cy="628650"/>
+          </a:xfrm>
+          <a:prstGeom xmlns:a="http://schemas.openxmlformats.org/drawingml/2006/main" prst="rect">
+            <a:avLst/>
+          </a:prstGeom>
+          <a:noFill xmlns:a="http://schemas.openxmlformats.org/drawingml/2006/main"/>
+          <a:ln xmlns:a="http://schemas.openxmlformats.org/drawingml/2006/main" w="0">
+            <a:noFill/>
+            <a:prstDash val="solid"/>
+          </a:ln>
+        </p:spPr>
+        <p:txBody>
+          <a:bodyPr xmlns:a="http://schemas.openxmlformats.org/drawingml/2006/main"/>
+          <a:lstStyle xmlns:a="http://schemas.openxmlformats.org/drawingml/2006/main"/>
+          <a:p xmlns:a="http://schemas.openxmlformats.org/drawingml/2006/main">
+            <a:pPr algn="l">
+              <a:buNone/>
+              <a:defRPr sz="1800" b="0" i="0">
+                <a:solidFill>
+                  <a:srgbClr val="111827"/>
+                </a:solidFill>
+              </a:defRPr>
+            </a:pPr>
+            <a:r>
+              <a:rPr sz="1800" b="0" i="0">
+                <a:solidFill>
+                  <a:srgbClr val="111827"/>
+                </a:solidFill>
+              </a:rPr>
+              <a:t>Retained before and after resource snapshots for the evaluation.</a:t>
+            </a:r>
+          </a:p>
+        </p:txBody>
+      </p:sp>
+      <p:sp>
+        <p:nvSpPr>
+          <p:cNvPr id="14" name="Rectangle 13">
+            <a:extLst xmlns:a="http://schemas.openxmlformats.org/drawingml/2006/main">
+              <a:ext uri="{FF2B5EF4-FFF2-40B4-BE49-F238E27FC236}">
+                <a16:creationId xmlns:a16="http://schemas.microsoft.com/office/drawing/2014/main" id="{CFFEA85E-D9F1-44A1-B35E-720016D4257C}"/>
+              </a:ext>
+            </a:extLst>
+          </p:cNvPr>
+          <p:cNvSpPr>
+            <a:spLocks xmlns:a="http://schemas.openxmlformats.org/drawingml/2006/main" noGrp="1"/>
+          </p:cNvSpPr>
+          <p:nvPr/>
+        </p:nvSpPr>
+        <p:spPr>
+          <a:xfrm xmlns:a="http://schemas.openxmlformats.org/drawingml/2006/main">
+            <a:off x="400050" y="4933950"/>
+            <a:ext cx="4095750" cy="285750"/>
+          </a:xfrm>
+          <a:prstGeom xmlns:a="http://schemas.openxmlformats.org/drawingml/2006/main" prst="rect">
+            <a:avLst/>
+          </a:prstGeom>
+          <a:noFill xmlns:a="http://schemas.openxmlformats.org/drawingml/2006/main"/>
+          <a:ln xmlns:a="http://schemas.openxmlformats.org/drawingml/2006/main" w="0">
+            <a:noFill/>
+            <a:prstDash val="solid"/>
+          </a:ln>
+        </p:spPr>
+        <p:txBody>
+          <a:bodyPr xmlns:a="http://schemas.openxmlformats.org/drawingml/2006/main"/>
+          <a:lstStyle xmlns:a="http://schemas.openxmlformats.org/drawingml/2006/main"/>
+          <a:p xmlns:a="http://schemas.openxmlformats.org/drawingml/2006/main">
+            <a:pPr algn="l">
+              <a:buNone/>
+              <a:defRPr sz="1875" b="1" i="0">
+                <a:solidFill>
+                  <a:srgbClr val="1E62D0"/>
+                </a:solidFill>
+              </a:defRPr>
+            </a:pPr>
+            <a:r>
+              <a:rPr sz="1875" b="1" i="0">
+                <a:solidFill>
+                  <a:srgbClr val="1E62D0"/>
+                </a:solidFill>
+              </a:rPr>
+              <a:t>Why it matters</a:t>
+            </a:r>
+          </a:p>
+        </p:txBody>
+      </p:sp>
+      <p:sp>
+        <p:nvSpPr>
+          <p:cNvPr id="15" name="Rectangle 14">
+            <a:extLst xmlns:a="http://schemas.openxmlformats.org/drawingml/2006/main">
+              <a:ext uri="{FF2B5EF4-FFF2-40B4-BE49-F238E27FC236}">
+                <a16:creationId xmlns:a16="http://schemas.microsoft.com/office/drawing/2014/main" id="{21B2D4F7-FA7A-4CF3-BE08-50698B6DEEB5}"/>
+              </a:ext>
+            </a:extLst>
+          </p:cNvPr>
+          <p:cNvSpPr>
+            <a:spLocks xmlns:a="http://schemas.openxmlformats.org/drawingml/2006/main" noGrp="1"/>
+          </p:cNvSpPr>
+          <p:nvPr/>
+        </p:nvSpPr>
+        <p:spPr>
+          <a:xfrm xmlns:a="http://schemas.openxmlformats.org/drawingml/2006/main">
+            <a:off x="400050" y="5305425"/>
+            <a:ext cx="5162550" cy="666750"/>
+          </a:xfrm>
+          <a:prstGeom xmlns:a="http://schemas.openxmlformats.org/drawingml/2006/main" prst="rect">
+            <a:avLst/>
+          </a:prstGeom>
+          <a:noFill xmlns:a="http://schemas.openxmlformats.org/drawingml/2006/main"/>
+          <a:ln xmlns:a="http://schemas.openxmlformats.org/drawingml/2006/main" w="0">
+            <a:noFill/>
+            <a:prstDash val="solid"/>
+          </a:ln>
+        </p:spPr>
+        <p:txBody>
+          <a:bodyPr xmlns:a="http://schemas.openxmlformats.org/drawingml/2006/main"/>
+          <a:lstStyle xmlns:a="http://schemas.openxmlformats.org/drawingml/2006/main"/>
+          <a:p xmlns:a="http://schemas.openxmlformats.org/drawingml/2006/main">
+            <a:pPr algn="l">
+              <a:buNone/>
+              <a:defRPr sz="1650" b="0" i="0">
+                <a:solidFill>
+                  <a:srgbClr val="556070"/>
+                </a:solidFill>
+              </a:defRPr>
+            </a:pPr>
+            <a:r>
+              <a:rPr sz="1650" b="0" i="0">
+                <a:solidFill>
+                  <a:srgbClr val="556070"/>
+                </a:solidFill>
+              </a:rPr>
+              <a:t>The final evaluation uses a live controlled laboratory, not a paper-only example.</a:t>
+            </a:r>
+          </a:p>
+        </p:txBody>
+      </p:sp>
+      <p:sp>
+        <p:nvSpPr>
+          <p:cNvPr id="16" name="Rectangle: Rounded Corners 15">
+            <a:extLst xmlns:a="http://schemas.openxmlformats.org/drawingml/2006/main">
+              <a:ext uri="{FF2B5EF4-FFF2-40B4-BE49-F238E27FC236}">
+                <a16:creationId xmlns:a16="http://schemas.microsoft.com/office/drawing/2014/main" id="{12BE1093-9EF3-401A-BAFC-D00776662E00}"/>
+              </a:ext>
+            </a:extLst>
+          </p:cNvPr>
+          <p:cNvSpPr>
+            <a:spLocks xmlns:a="http://schemas.openxmlformats.org/drawingml/2006/main" noGrp="1"/>
+          </p:cNvSpPr>
+          <p:nvPr/>
+        </p:nvSpPr>
+        <p:spPr>
+          <a:xfrm xmlns:a="http://schemas.openxmlformats.org/drawingml/2006/main">
+            <a:off x="6191250" y="1571625"/>
+            <a:ext cx="5600700" cy="3762375"/>
+          </a:xfrm>
+          <a:prstGeom xmlns:a="http://schemas.openxmlformats.org/drawingml/2006/main" prst="roundRect">
+            <a:avLst>
+              <a:gd name="adj" fmla="val 3038"/>
+            </a:avLst>
+          </a:prstGeom>
+          <a:solidFill xmlns:a="http://schemas.openxmlformats.org/drawingml/2006/main">
+            <a:srgbClr val="EAF5FB"/>
+          </a:solidFill>
+          <a:ln xmlns:a="http://schemas.openxmlformats.org/drawingml/2006/main" w="9525">
+            <a:solidFill>
+              <a:srgbClr val="C8CED6"/>
+            </a:solidFill>
+            <a:prstDash val="solid"/>
+          </a:ln>
+        </p:spPr>
+        <p:txBody>
+          <a:bodyPr xmlns:a="http://schemas.openxmlformats.org/drawingml/2006/main"/>
+          <a:lstStyle xmlns:a="http://schemas.openxmlformats.org/drawingml/2006/main"/>
+          <a:p xmlns:a="http://schemas.openxmlformats.org/drawingml/2006/main">
+            <a:endParaRPr/>
+          </a:p>
+        </p:txBody>
+      </p:sp>
+      <p:pic>
+        <p:nvPicPr>
+          <p:cNvPr id="37" name="Picture 34"/>
+          <p:cNvPicPr>
+            <a:picLocks xmlns:a="http://schemas.openxmlformats.org/drawingml/2006/main" noChangeAspect="1"/>
+          </p:cNvPicPr>
+          <p:nvPr/>
+        </p:nvPicPr>
+        <p:blipFill>
+          <a:blip xmlns:r="http://schemas.openxmlformats.org/officeDocument/2006/relationships" xmlns:a="http://schemas.openxmlformats.org/drawingml/2006/main" r:embed="Rcb4e410130134de7"/>
+          <a:stretch xmlns:a="http://schemas.openxmlformats.org/drawingml/2006/main"/>
+        </p:blipFill>
+        <p:spPr>
+          <a:xfrm xmlns:a="http://schemas.openxmlformats.org/drawingml/2006/main">
+            <a:off x="6741478" y="2010116"/>
+            <a:ext cx="4500243" cy="2885393"/>
+          </a:xfrm>
+          <a:prstGeom xmlns:a="http://schemas.openxmlformats.org/drawingml/2006/main" prst="roundRect">
+            <a:avLst/>
+          </a:prstGeom>
+        </p:spPr>
+      </p:pic>
+      <p:sp>
+        <p:nvSpPr>
+          <p:cNvPr id="18" name="Rectangle 17">
+            <a:extLst xmlns:a="http://schemas.openxmlformats.org/drawingml/2006/main">
+              <a:ext uri="{FF2B5EF4-FFF2-40B4-BE49-F238E27FC236}">
+                <a16:creationId xmlns:a16="http://schemas.microsoft.com/office/drawing/2014/main" id="{89D765B5-4DD8-4FC5-B79F-392E395B4A25}"/>
+              </a:ext>
+            </a:extLst>
+          </p:cNvPr>
+          <p:cNvSpPr>
+            <a:spLocks xmlns:a="http://schemas.openxmlformats.org/drawingml/2006/main" noGrp="1"/>
+          </p:cNvSpPr>
+          <p:nvPr/>
+        </p:nvSpPr>
+        <p:spPr>
+          <a:xfrm xmlns:a="http://schemas.openxmlformats.org/drawingml/2006/main">
+            <a:off x="6191250" y="5524500"/>
+            <a:ext cx="5524500" cy="400050"/>
+          </a:xfrm>
+          <a:prstGeom xmlns:a="http://schemas.openxmlformats.org/drawingml/2006/main" prst="rect">
+            <a:avLst/>
+          </a:prstGeom>
+          <a:noFill xmlns:a="http://schemas.openxmlformats.org/drawingml/2006/main"/>
+          <a:ln xmlns:a="http://schemas.openxmlformats.org/drawingml/2006/main" w="0">
+            <a:noFill/>
+            <a:prstDash val="solid"/>
+          </a:ln>
+        </p:spPr>
+        <p:txBody>
+          <a:bodyPr xmlns:a="http://schemas.openxmlformats.org/drawingml/2006/main"/>
+          <a:lstStyle xmlns:a="http://schemas.openxmlformats.org/drawingml/2006/main"/>
+          <a:p xmlns:a="http://schemas.openxmlformats.org/drawingml/2006/main">
+            <a:pPr algn="l">
+              <a:buNone/>
+              <a:defRPr sz="1350" b="0" i="0">
+                <a:solidFill>
+                  <a:srgbClr val="556070"/>
+                </a:solidFill>
+              </a:defRPr>
+            </a:pPr>
+            <a:r>
+              <a:rPr sz="1350" b="0" i="0">
+                <a:solidFill>
+                  <a:srgbClr val="556070"/>
+                </a:solidFill>
+              </a:rPr>
+              <a:t>Docker Desktop: current controlled laboratory view. All 13 required containers report healthy on 4 September 2026.</a:t>
+            </a:r>
+          </a:p>
+        </p:txBody>
+      </p:sp>
+    </p:spTree>
+    <p:extLst>
+      <p:ext uri="{BB962C8B-B14F-4D97-AF65-F5344CB8AC3E}">
+        <p14:creationId xmlns:p14="http://schemas.microsoft.com/office/powerpoint/2010/main" val="1676337558"/>
+      </p:ext>
+    </p:extLst>
+  </p:cSld>
+</p:sld>
+</file>
+
+<file path=ppt/slides/slide15.xml><?xml version="1.0" encoding="utf-8"?>
+<p:sld xmlns:p="http://schemas.openxmlformats.org/presentationml/2006/main">
+  <p:cSld>
+    <p:bg>
+      <p:bgPr>
+        <a:solidFill xmlns:a="http://schemas.openxmlformats.org/drawingml/2006/main">
+          <a:srgbClr val="FFFFFF"/>
+        </a:solidFill>
+      </p:bgPr>
+    </p:bg>
+    <p:spTree>
+      <p:nvGrpSpPr>
+        <p:cNvPr id="1" name=""/>
+        <p:cNvGrpSpPr/>
+        <p:nvPr/>
+      </p:nvGrpSpPr>
+      <p:grpSpPr>
+        <a:xfrm xmlns:a="http://schemas.openxmlformats.org/drawingml/2006/main"/>
+      </p:grpSpPr>
+      <p:sp>
+        <p:nvSpPr>
+          <p:cNvPr id="21" name="Rectangle 20">
+            <a:extLst xmlns:a="http://schemas.openxmlformats.org/drawingml/2006/main">
+              <a:ext uri="{FF2B5EF4-FFF2-40B4-BE49-F238E27FC236}">
+                <a16:creationId xmlns:a16="http://schemas.microsoft.com/office/drawing/2014/main" id="{A7608A95-C851-4988-A2A4-6E102600DA72}"/>
+              </a:ext>
+            </a:extLst>
+          </p:cNvPr>
+          <p:cNvSpPr>
+            <a:spLocks xmlns:a="http://schemas.openxmlformats.org/drawingml/2006/main" noGrp="1"/>
+          </p:cNvSpPr>
+          <p:nvPr/>
+        </p:nvSpPr>
+        <p:spPr>
+          <a:xfrm xmlns:a="http://schemas.openxmlformats.org/drawingml/2006/main">
+            <a:off x="400050" y="323850"/>
+            <a:ext cx="2476500" cy="228600"/>
+          </a:xfrm>
+          <a:prstGeom xmlns:a="http://schemas.openxmlformats.org/drawingml/2006/main" prst="rect">
+            <a:avLst/>
+          </a:prstGeom>
+          <a:noFill xmlns:a="http://schemas.openxmlformats.org/drawingml/2006/main"/>
+          <a:ln xmlns:a="http://schemas.openxmlformats.org/drawingml/2006/main" w="0">
+            <a:noFill/>
+            <a:prstDash val="solid"/>
+          </a:ln>
+        </p:spPr>
+        <p:txBody>
+          <a:bodyPr xmlns:a="http://schemas.openxmlformats.org/drawingml/2006/main"/>
+          <a:lstStyle xmlns:a="http://schemas.openxmlformats.org/drawingml/2006/main"/>
+          <a:p xmlns:a="http://schemas.openxmlformats.org/drawingml/2006/main">
+            <a:pPr algn="l">
+              <a:buNone/>
+              <a:defRPr sz="1125" b="1" i="0">
+                <a:solidFill>
+                  <a:srgbClr val="1E62D0"/>
+                </a:solidFill>
+              </a:defRPr>
+            </a:pPr>
+            <a:r>
+              <a:rPr sz="1125" b="1" i="0">
+                <a:solidFill>
+                  <a:srgbClr val="1E62D0"/>
+                </a:solidFill>
+              </a:rPr>
+              <a:t>PHASE 6 PROGRAM</a:t>
+            </a:r>
+          </a:p>
+        </p:txBody>
+      </p:sp>
+      <p:sp>
+        <p:nvSpPr>
+          <p:cNvPr id="2" name="Rectangle 1">
+            <a:extLst xmlns:a="http://schemas.openxmlformats.org/drawingml/2006/main">
+              <a:ext uri="{FF2B5EF4-FFF2-40B4-BE49-F238E27FC236}">
+                <a16:creationId xmlns:a16="http://schemas.microsoft.com/office/drawing/2014/main" id="{80BED32D-CD00-40A0-B011-893AF4C0AC88}"/>
+              </a:ext>
+            </a:extLst>
+          </p:cNvPr>
+          <p:cNvSpPr>
+            <a:spLocks xmlns:a="http://schemas.openxmlformats.org/drawingml/2006/main" noGrp="1"/>
+          </p:cNvSpPr>
+          <p:nvPr/>
+        </p:nvSpPr>
+        <p:spPr>
+          <a:xfrm xmlns:a="http://schemas.openxmlformats.org/drawingml/2006/main">
+            <a:off x="400050" y="628650"/>
+            <a:ext cx="10668000" cy="523875"/>
+          </a:xfrm>
+          <a:prstGeom xmlns:a="http://schemas.openxmlformats.org/drawingml/2006/main" prst="rect">
+            <a:avLst/>
+          </a:prstGeom>
+          <a:noFill xmlns:a="http://schemas.openxmlformats.org/drawingml/2006/main"/>
+          <a:ln xmlns:a="http://schemas.openxmlformats.org/drawingml/2006/main" w="0">
+            <a:noFill/>
+            <a:prstDash val="solid"/>
+          </a:ln>
+        </p:spPr>
+        <p:txBody>
+          <a:bodyPr xmlns:a="http://schemas.openxmlformats.org/drawingml/2006/main"/>
+          <a:lstStyle xmlns:a="http://schemas.openxmlformats.org/drawingml/2006/main"/>
+          <a:p xmlns:a="http://schemas.openxmlformats.org/drawingml/2006/main">
+            <a:pPr algn="l">
+              <a:buNone/>
+              <a:defRPr sz="2925" b="1" i="0">
+                <a:solidFill>
+                  <a:srgbClr val="111827"/>
+                </a:solidFill>
+              </a:defRPr>
+            </a:pPr>
+            <a:r>
+              <a:rPr sz="2925" b="1" i="0">
+                <a:solidFill>
+                  <a:srgbClr val="111827"/>
+                </a:solidFill>
+              </a:rPr>
+              <a:t>The program produces a repeatable evaluation report</a:t>
+            </a:r>
+          </a:p>
+        </p:txBody>
+      </p:sp>
+      <p:sp>
+        <p:nvSpPr>
+          <p:cNvPr id="3" name="Rectangle 2">
+            <a:extLst xmlns:a="http://schemas.openxmlformats.org/drawingml/2006/main">
+              <a:ext uri="{FF2B5EF4-FFF2-40B4-BE49-F238E27FC236}">
+                <a16:creationId xmlns:a16="http://schemas.microsoft.com/office/drawing/2014/main" id="{55C69A76-3798-4AC1-B2B9-1CA18CE0818C}"/>
+              </a:ext>
+            </a:extLst>
+          </p:cNvPr>
+          <p:cNvSpPr>
+            <a:spLocks xmlns:a="http://schemas.openxmlformats.org/drawingml/2006/main" noGrp="1"/>
+          </p:cNvSpPr>
+          <p:nvPr/>
+        </p:nvSpPr>
+        <p:spPr>
+          <a:xfrm xmlns:a="http://schemas.openxmlformats.org/drawingml/2006/main">
+            <a:off x="400050" y="1276350"/>
+            <a:ext cx="11391900" cy="9525"/>
+          </a:xfrm>
+          <a:prstGeom xmlns:a="http://schemas.openxmlformats.org/drawingml/2006/main" prst="rect">
+            <a:avLst/>
+          </a:prstGeom>
+          <a:solidFill xmlns:a="http://schemas.openxmlformats.org/drawingml/2006/main">
+            <a:srgbClr val="C8CED6"/>
+          </a:solidFill>
+          <a:ln xmlns:a="http://schemas.openxmlformats.org/drawingml/2006/main" w="0">
+            <a:solidFill>
+              <a:srgbClr val="C8CED6"/>
+            </a:solidFill>
+            <a:prstDash val="solid"/>
+          </a:ln>
+        </p:spPr>
+        <p:txBody>
+          <a:bodyPr xmlns:a="http://schemas.openxmlformats.org/drawingml/2006/main"/>
+          <a:lstStyle xmlns:a="http://schemas.openxmlformats.org/drawingml/2006/main"/>
+          <a:p xmlns:a="http://schemas.openxmlformats.org/drawingml/2006/main">
+            <a:endParaRPr/>
+          </a:p>
+        </p:txBody>
+      </p:sp>
+      <p:sp>
+        <p:nvSpPr>
+          <p:cNvPr id="4" name="Rectangle 3">
+            <a:extLst xmlns:a="http://schemas.openxmlformats.org/drawingml/2006/main">
+              <a:ext uri="{FF2B5EF4-FFF2-40B4-BE49-F238E27FC236}">
+                <a16:creationId xmlns:a16="http://schemas.microsoft.com/office/drawing/2014/main" id="{EB0F46E6-4920-402F-B8E7-5BE77539F646}"/>
+              </a:ext>
+            </a:extLst>
+          </p:cNvPr>
+          <p:cNvSpPr>
+            <a:spLocks xmlns:a="http://schemas.openxmlformats.org/drawingml/2006/main" noGrp="1"/>
+          </p:cNvSpPr>
+          <p:nvPr/>
+        </p:nvSpPr>
+        <p:spPr>
+          <a:xfrm xmlns:a="http://schemas.openxmlformats.org/drawingml/2006/main">
+            <a:off x="9715500" y="6286500"/>
+            <a:ext cx="2076450" cy="190500"/>
+          </a:xfrm>
+          <a:prstGeom xmlns:a="http://schemas.openxmlformats.org/drawingml/2006/main" prst="rect">
+            <a:avLst/>
+          </a:prstGeom>
+          <a:noFill xmlns:a="http://schemas.openxmlformats.org/drawingml/2006/main"/>
+          <a:ln xmlns:a="http://schemas.openxmlformats.org/drawingml/2006/main" w="0">
+            <a:noFill/>
+            <a:prstDash val="solid"/>
+          </a:ln>
+        </p:spPr>
+        <p:txBody>
+          <a:bodyPr xmlns:a="http://schemas.openxmlformats.org/drawingml/2006/main"/>
+          <a:lstStyle xmlns:a="http://schemas.openxmlformats.org/drawingml/2006/main"/>
+          <a:p xmlns:a="http://schemas.openxmlformats.org/drawingml/2006/main">
+            <a:pPr algn="r">
+              <a:buNone/>
+              <a:defRPr sz="975" b="0" i="0">
+                <a:solidFill>
+                  <a:srgbClr val="556070"/>
+                </a:solidFill>
+              </a:defRPr>
+            </a:pPr>
+            <a:r>
+              <a:rPr sz="975" b="0" i="0">
+                <a:solidFill>
+                  <a:srgbClr val="556070"/>
+                </a:solidFill>
+              </a:rPr>
+              <a:t>4 SEPTEMBER 2026  |  15</a:t>
+            </a:r>
+          </a:p>
+        </p:txBody>
+      </p:sp>
+      <p:sp>
+        <p:nvSpPr>
+          <p:cNvPr id="5" name="Rectangle 4">
+            <a:extLst xmlns:a="http://schemas.openxmlformats.org/drawingml/2006/main">
+              <a:ext uri="{FF2B5EF4-FFF2-40B4-BE49-F238E27FC236}">
+                <a16:creationId xmlns:a16="http://schemas.microsoft.com/office/drawing/2014/main" id="{4074F0AF-8C79-4B63-9259-2B4E5B257137}"/>
+              </a:ext>
+            </a:extLst>
+          </p:cNvPr>
+          <p:cNvSpPr>
+            <a:spLocks xmlns:a="http://schemas.openxmlformats.org/drawingml/2006/main" noGrp="1"/>
+          </p:cNvSpPr>
+          <p:nvPr/>
+        </p:nvSpPr>
+        <p:spPr>
+          <a:xfrm xmlns:a="http://schemas.openxmlformats.org/drawingml/2006/main">
+            <a:off x="400050" y="1504950"/>
+            <a:ext cx="10858500" cy="552450"/>
+          </a:xfrm>
+          <a:prstGeom xmlns:a="http://schemas.openxmlformats.org/drawingml/2006/main" prst="rect">
+            <a:avLst/>
+          </a:prstGeom>
+          <a:noFill xmlns:a="http://schemas.openxmlformats.org/drawingml/2006/main"/>
+          <a:ln xmlns:a="http://schemas.openxmlformats.org/drawingml/2006/main" w="0">
+            <a:noFill/>
+            <a:prstDash val="solid"/>
+          </a:ln>
+        </p:spPr>
+        <p:txBody>
+          <a:bodyPr xmlns:a="http://schemas.openxmlformats.org/drawingml/2006/main"/>
+          <a:lstStyle xmlns:a="http://schemas.openxmlformats.org/drawingml/2006/main"/>
+          <a:p xmlns:a="http://schemas.openxmlformats.org/drawingml/2006/main">
+            <a:pPr algn="l">
+              <a:buNone/>
+              <a:defRPr sz="1875" b="0" i="0">
+                <a:solidFill>
+                  <a:srgbClr val="556070"/>
+                </a:solidFill>
+              </a:defRPr>
+            </a:pPr>
+            <a:r>
+              <a:rPr sz="1875" b="0" i="0">
+                <a:solidFill>
+                  <a:srgbClr val="556070"/>
+                </a:solidFill>
+              </a:rPr>
+              <a:t>The final command checks the complete evidence chain and writes the result into a time-stamped folder.</a:t>
+            </a:r>
+          </a:p>
+        </p:txBody>
+      </p:sp>
+      <p:sp>
+        <p:nvSpPr>
+          <p:cNvPr id="6" name="Rectangle: Rounded Corners 5">
+            <a:extLst xmlns:a="http://schemas.openxmlformats.org/drawingml/2006/main">
+              <a:ext uri="{FF2B5EF4-FFF2-40B4-BE49-F238E27FC236}">
+                <a16:creationId xmlns:a16="http://schemas.microsoft.com/office/drawing/2014/main" id="{801A2984-2B57-4553-BAC6-A718BFB79F6E}"/>
+              </a:ext>
+            </a:extLst>
+          </p:cNvPr>
+          <p:cNvSpPr>
+            <a:spLocks xmlns:a="http://schemas.openxmlformats.org/drawingml/2006/main" noGrp="1"/>
+          </p:cNvSpPr>
+          <p:nvPr/>
+        </p:nvSpPr>
+        <p:spPr>
+          <a:xfrm xmlns:a="http://schemas.openxmlformats.org/drawingml/2006/main">
+            <a:off x="400050" y="2305050"/>
+            <a:ext cx="6838950" cy="3733800"/>
+          </a:xfrm>
+          <a:prstGeom xmlns:a="http://schemas.openxmlformats.org/drawingml/2006/main" prst="roundRect">
+            <a:avLst>
+              <a:gd name="adj" fmla="val 3061"/>
+            </a:avLst>
+          </a:prstGeom>
+          <a:solidFill xmlns:a="http://schemas.openxmlformats.org/drawingml/2006/main">
+            <a:srgbClr val="EAF5FB"/>
+          </a:solidFill>
+          <a:ln xmlns:a="http://schemas.openxmlformats.org/drawingml/2006/main" w="9525">
+            <a:solidFill>
+              <a:srgbClr val="C8CED6"/>
+            </a:solidFill>
+            <a:prstDash val="solid"/>
+          </a:ln>
+        </p:spPr>
+        <p:txBody>
+          <a:bodyPr xmlns:a="http://schemas.openxmlformats.org/drawingml/2006/main"/>
+          <a:lstStyle xmlns:a="http://schemas.openxmlformats.org/drawingml/2006/main"/>
+          <a:p xmlns:a="http://schemas.openxmlformats.org/drawingml/2006/main">
+            <a:endParaRPr/>
+          </a:p>
+        </p:txBody>
+      </p:sp>
+      <p:pic>
+        <p:nvPicPr>
+          <p:cNvPr id="29" name="Picture 26"/>
+          <p:cNvPicPr>
+            <a:picLocks xmlns:a="http://schemas.openxmlformats.org/drawingml/2006/main" noChangeAspect="1"/>
+          </p:cNvPicPr>
+          <p:nvPr/>
+        </p:nvPicPr>
+        <p:blipFill>
+          <a:blip xmlns:r="http://schemas.openxmlformats.org/officeDocument/2006/relationships" xmlns:a="http://schemas.openxmlformats.org/drawingml/2006/main" r:embed="Rc55660302f014d7e"/>
+          <a:stretch xmlns:a="http://schemas.openxmlformats.org/drawingml/2006/main"/>
+        </p:blipFill>
+        <p:spPr>
+          <a:xfrm xmlns:a="http://schemas.openxmlformats.org/drawingml/2006/main">
+            <a:off x="511514" y="2393894"/>
+            <a:ext cx="6616021" cy="3556111"/>
+          </a:xfrm>
+          <a:prstGeom xmlns:a="http://schemas.openxmlformats.org/drawingml/2006/main" prst="roundRect">
+            <a:avLst/>
+          </a:prstGeom>
+        </p:spPr>
+      </p:pic>
+      <p:sp>
+        <p:nvSpPr>
+          <p:cNvPr id="8" name="Rectangle 7">
+            <a:extLst xmlns:a="http://schemas.openxmlformats.org/drawingml/2006/main">
+              <a:ext uri="{FF2B5EF4-FFF2-40B4-BE49-F238E27FC236}">
+                <a16:creationId xmlns:a16="http://schemas.microsoft.com/office/drawing/2014/main" id="{BE05CA84-732F-46AE-9CA6-B08B28C8887F}"/>
+              </a:ext>
+            </a:extLst>
+          </p:cNvPr>
+          <p:cNvSpPr>
+            <a:spLocks xmlns:a="http://schemas.openxmlformats.org/drawingml/2006/main" noGrp="1"/>
+          </p:cNvSpPr>
+          <p:nvPr/>
+        </p:nvSpPr>
+        <p:spPr>
+          <a:xfrm xmlns:a="http://schemas.openxmlformats.org/drawingml/2006/main">
+            <a:off x="7715250" y="2362200"/>
+            <a:ext cx="3429000" cy="285750"/>
+          </a:xfrm>
+          <a:prstGeom xmlns:a="http://schemas.openxmlformats.org/drawingml/2006/main" prst="rect">
+            <a:avLst/>
+          </a:prstGeom>
+          <a:noFill xmlns:a="http://schemas.openxmlformats.org/drawingml/2006/main"/>
+          <a:ln xmlns:a="http://schemas.openxmlformats.org/drawingml/2006/main" w="0">
+            <a:noFill/>
+            <a:prstDash val="solid"/>
+          </a:ln>
+        </p:spPr>
+        <p:txBody>
+          <a:bodyPr xmlns:a="http://schemas.openxmlformats.org/drawingml/2006/main"/>
+          <a:lstStyle xmlns:a="http://schemas.openxmlformats.org/drawingml/2006/main"/>
+          <a:p xmlns:a="http://schemas.openxmlformats.org/drawingml/2006/main">
+            <a:pPr algn="l">
+              <a:buNone/>
+              <a:defRPr sz="2025" b="1" i="0">
+                <a:solidFill>
+                  <a:srgbClr val="111827"/>
+                </a:solidFill>
+              </a:defRPr>
+            </a:pPr>
+            <a:r>
+              <a:rPr sz="2025" b="1" i="0">
+                <a:solidFill>
+                  <a:srgbClr val="111827"/>
+                </a:solidFill>
+              </a:rPr>
+              <a:t>The report confirms</a:t>
+            </a:r>
+          </a:p>
+        </p:txBody>
+      </p:sp>
+      <p:sp>
+        <p:nvSpPr>
+          <p:cNvPr id="9" name="Oval 8">
+            <a:extLst xmlns:a="http://schemas.openxmlformats.org/drawingml/2006/main">
+              <a:ext uri="{FF2B5EF4-FFF2-40B4-BE49-F238E27FC236}">
+                <a16:creationId xmlns:a16="http://schemas.microsoft.com/office/drawing/2014/main" id="{F57A33BB-AEFF-4063-8FC7-E6EDC3BDA3B2}"/>
+              </a:ext>
+            </a:extLst>
+          </p:cNvPr>
+          <p:cNvSpPr>
+            <a:spLocks xmlns:a="http://schemas.openxmlformats.org/drawingml/2006/main" noGrp="1"/>
+          </p:cNvSpPr>
+          <p:nvPr/>
+        </p:nvSpPr>
+        <p:spPr>
+          <a:xfrm xmlns:a="http://schemas.openxmlformats.org/drawingml/2006/main">
+            <a:off x="7715250" y="2943225"/>
+            <a:ext cx="95250" cy="95250"/>
+          </a:xfrm>
+          <a:prstGeom xmlns:a="http://schemas.openxmlformats.org/drawingml/2006/main" prst="ellipse">
+            <a:avLst/>
+          </a:prstGeom>
+          <a:solidFill xmlns:a="http://schemas.openxmlformats.org/drawingml/2006/main">
+            <a:srgbClr val="1E62D0"/>
+          </a:solidFill>
+          <a:ln xmlns:a="http://schemas.openxmlformats.org/drawingml/2006/main" w="0">
+            <a:solidFill>
+              <a:srgbClr val="1E62D0"/>
+            </a:solidFill>
+            <a:prstDash val="solid"/>
+          </a:ln>
+        </p:spPr>
+        <p:txBody>
+          <a:bodyPr xmlns:a="http://schemas.openxmlformats.org/drawingml/2006/main"/>
+          <a:lstStyle xmlns:a="http://schemas.openxmlformats.org/drawingml/2006/main"/>
+          <a:p xmlns:a="http://schemas.openxmlformats.org/drawingml/2006/main">
+            <a:endParaRPr/>
+          </a:p>
+        </p:txBody>
+      </p:sp>
+      <p:sp>
+        <p:nvSpPr>
+          <p:cNvPr id="10" name="Rectangle 9">
+            <a:extLst xmlns:a="http://schemas.openxmlformats.org/drawingml/2006/main">
+              <a:ext uri="{FF2B5EF4-FFF2-40B4-BE49-F238E27FC236}">
+                <a16:creationId xmlns:a16="http://schemas.microsoft.com/office/drawing/2014/main" id="{9918A51D-B2BC-4DCE-8F86-32297C6C44EC}"/>
+              </a:ext>
+            </a:extLst>
+          </p:cNvPr>
+          <p:cNvSpPr>
+            <a:spLocks xmlns:a="http://schemas.openxmlformats.org/drawingml/2006/main" noGrp="1"/>
+          </p:cNvSpPr>
+          <p:nvPr/>
+        </p:nvSpPr>
+        <p:spPr>
+          <a:xfrm xmlns:a="http://schemas.openxmlformats.org/drawingml/2006/main">
+            <a:off x="7962900" y="2857500"/>
+            <a:ext cx="3295650" cy="485775"/>
+          </a:xfrm>
+          <a:prstGeom xmlns:a="http://schemas.openxmlformats.org/drawingml/2006/main" prst="rect">
+            <a:avLst/>
+          </a:prstGeom>
+          <a:noFill xmlns:a="http://schemas.openxmlformats.org/drawingml/2006/main"/>
+          <a:ln xmlns:a="http://schemas.openxmlformats.org/drawingml/2006/main" w="0">
+            <a:noFill/>
+            <a:prstDash val="solid"/>
+          </a:ln>
+        </p:spPr>
+        <p:txBody>
+          <a:bodyPr xmlns:a="http://schemas.openxmlformats.org/drawingml/2006/main"/>
+          <a:lstStyle xmlns:a="http://schemas.openxmlformats.org/drawingml/2006/main"/>
+          <a:p xmlns:a="http://schemas.openxmlformats.org/drawingml/2006/main">
+            <a:pPr algn="l">
+              <a:buNone/>
+              <a:defRPr sz="1650" b="0" i="0">
+                <a:solidFill>
+                  <a:srgbClr val="111827"/>
+                </a:solidFill>
+              </a:defRPr>
+            </a:pPr>
+            <a:r>
+              <a:rPr sz="1650" b="0" i="0">
+                <a:solidFill>
+                  <a:srgbClr val="111827"/>
+                </a:solidFill>
+              </a:rPr>
+              <a:t>the input runs are complete</a:t>
+            </a:r>
+          </a:p>
+        </p:txBody>
+      </p:sp>
+      <p:sp>
+        <p:nvSpPr>
+          <p:cNvPr id="11" name="Oval 10">
+            <a:extLst xmlns:a="http://schemas.openxmlformats.org/drawingml/2006/main">
+              <a:ext uri="{FF2B5EF4-FFF2-40B4-BE49-F238E27FC236}">
+                <a16:creationId xmlns:a16="http://schemas.microsoft.com/office/drawing/2014/main" id="{4754A631-8934-4493-ACD7-684941461772}"/>
+              </a:ext>
+            </a:extLst>
+          </p:cNvPr>
+          <p:cNvSpPr>
+            <a:spLocks xmlns:a="http://schemas.openxmlformats.org/drawingml/2006/main" noGrp="1"/>
+          </p:cNvSpPr>
+          <p:nvPr/>
+        </p:nvSpPr>
+        <p:spPr>
+          <a:xfrm xmlns:a="http://schemas.openxmlformats.org/drawingml/2006/main">
+            <a:off x="7715250" y="3467100"/>
+            <a:ext cx="95250" cy="95250"/>
+          </a:xfrm>
+          <a:prstGeom xmlns:a="http://schemas.openxmlformats.org/drawingml/2006/main" prst="ellipse">
+            <a:avLst/>
+          </a:prstGeom>
+          <a:solidFill xmlns:a="http://schemas.openxmlformats.org/drawingml/2006/main">
+            <a:srgbClr val="1E62D0"/>
+          </a:solidFill>
+          <a:ln xmlns:a="http://schemas.openxmlformats.org/drawingml/2006/main" w="0">
+            <a:solidFill>
+              <a:srgbClr val="1E62D0"/>
+            </a:solidFill>
+            <a:prstDash val="solid"/>
+          </a:ln>
+        </p:spPr>
+        <p:txBody>
+          <a:bodyPr xmlns:a="http://schemas.openxmlformats.org/drawingml/2006/main"/>
+          <a:lstStyle xmlns:a="http://schemas.openxmlformats.org/drawingml/2006/main"/>
+          <a:p xmlns:a="http://schemas.openxmlformats.org/drawingml/2006/main">
+            <a:endParaRPr/>
+          </a:p>
+        </p:txBody>
+      </p:sp>
+      <p:sp>
+        <p:nvSpPr>
+          <p:cNvPr id="12" name="Rectangle 11">
+            <a:extLst xmlns:a="http://schemas.openxmlformats.org/drawingml/2006/main">
+              <a:ext uri="{FF2B5EF4-FFF2-40B4-BE49-F238E27FC236}">
+                <a16:creationId xmlns:a16="http://schemas.microsoft.com/office/drawing/2014/main" id="{D83D7FA7-CB34-47EF-B909-7F5FAA851A11}"/>
+              </a:ext>
+            </a:extLst>
+          </p:cNvPr>
+          <p:cNvSpPr>
+            <a:spLocks xmlns:a="http://schemas.openxmlformats.org/drawingml/2006/main" noGrp="1"/>
+          </p:cNvSpPr>
+          <p:nvPr/>
+        </p:nvSpPr>
+        <p:spPr>
+          <a:xfrm xmlns:a="http://schemas.openxmlformats.org/drawingml/2006/main">
+            <a:off x="7962900" y="3381375"/>
+            <a:ext cx="3295650" cy="485775"/>
+          </a:xfrm>
+          <a:prstGeom xmlns:a="http://schemas.openxmlformats.org/drawingml/2006/main" prst="rect">
+            <a:avLst/>
+          </a:prstGeom>
+          <a:noFill xmlns:a="http://schemas.openxmlformats.org/drawingml/2006/main"/>
+          <a:ln xmlns:a="http://schemas.openxmlformats.org/drawingml/2006/main" w="0">
+            <a:noFill/>
+            <a:prstDash val="solid"/>
+          </a:ln>
+        </p:spPr>
+        <p:txBody>
+          <a:bodyPr xmlns:a="http://schemas.openxmlformats.org/drawingml/2006/main"/>
+          <a:lstStyle xmlns:a="http://schemas.openxmlformats.org/drawingml/2006/main"/>
+          <a:p xmlns:a="http://schemas.openxmlformats.org/drawingml/2006/main">
+            <a:pPr algn="l">
+              <a:buNone/>
+              <a:defRPr sz="1650" b="0" i="0">
+                <a:solidFill>
+                  <a:srgbClr val="111827"/>
+                </a:solidFill>
+              </a:defRPr>
+            </a:pPr>
+            <a:r>
+              <a:rPr sz="1650" b="0" i="0">
+                <a:solidFill>
+                  <a:srgbClr val="111827"/>
+                </a:solidFill>
+              </a:rPr>
+              <a:t>five scenarios passed</a:t>
+            </a:r>
+          </a:p>
+        </p:txBody>
+      </p:sp>
+      <p:sp>
+        <p:nvSpPr>
+          <p:cNvPr id="13" name="Oval 12">
+            <a:extLst xmlns:a="http://schemas.openxmlformats.org/drawingml/2006/main">
+              <a:ext uri="{FF2B5EF4-FFF2-40B4-BE49-F238E27FC236}">
+                <a16:creationId xmlns:a16="http://schemas.microsoft.com/office/drawing/2014/main" id="{6989D667-7DF8-409B-9ABA-4F9DDDD574BD}"/>
+              </a:ext>
+            </a:extLst>
+          </p:cNvPr>
+          <p:cNvSpPr>
+            <a:spLocks xmlns:a="http://schemas.openxmlformats.org/drawingml/2006/main" noGrp="1"/>
+          </p:cNvSpPr>
+          <p:nvPr/>
+        </p:nvSpPr>
+        <p:spPr>
+          <a:xfrm xmlns:a="http://schemas.openxmlformats.org/drawingml/2006/main">
+            <a:off x="7715250" y="3990975"/>
+            <a:ext cx="95250" cy="95250"/>
+          </a:xfrm>
+          <a:prstGeom xmlns:a="http://schemas.openxmlformats.org/drawingml/2006/main" prst="ellipse">
+            <a:avLst/>
+          </a:prstGeom>
+          <a:solidFill xmlns:a="http://schemas.openxmlformats.org/drawingml/2006/main">
+            <a:srgbClr val="1E62D0"/>
+          </a:solidFill>
+          <a:ln xmlns:a="http://schemas.openxmlformats.org/drawingml/2006/main" w="0">
+            <a:solidFill>
+              <a:srgbClr val="1E62D0"/>
+            </a:solidFill>
+            <a:prstDash val="solid"/>
+          </a:ln>
+        </p:spPr>
+        <p:txBody>
+          <a:bodyPr xmlns:a="http://schemas.openxmlformats.org/drawingml/2006/main"/>
+          <a:lstStyle xmlns:a="http://schemas.openxmlformats.org/drawingml/2006/main"/>
+          <a:p xmlns:a="http://schemas.openxmlformats.org/drawingml/2006/main">
+            <a:endParaRPr/>
+          </a:p>
+        </p:txBody>
+      </p:sp>
+      <p:sp>
+        <p:nvSpPr>
+          <p:cNvPr id="14" name="Rectangle 13">
+            <a:extLst xmlns:a="http://schemas.openxmlformats.org/drawingml/2006/main">
+              <a:ext uri="{FF2B5EF4-FFF2-40B4-BE49-F238E27FC236}">
+                <a16:creationId xmlns:a16="http://schemas.microsoft.com/office/drawing/2014/main" id="{FB16FF66-8CE6-4CA4-9450-48AE936734D1}"/>
+              </a:ext>
+            </a:extLst>
+          </p:cNvPr>
+          <p:cNvSpPr>
+            <a:spLocks xmlns:a="http://schemas.openxmlformats.org/drawingml/2006/main" noGrp="1"/>
+          </p:cNvSpPr>
+          <p:nvPr/>
+        </p:nvSpPr>
+        <p:spPr>
+          <a:xfrm xmlns:a="http://schemas.openxmlformats.org/drawingml/2006/main">
+            <a:off x="7962900" y="3905250"/>
+            <a:ext cx="3295650" cy="485775"/>
+          </a:xfrm>
+          <a:prstGeom xmlns:a="http://schemas.openxmlformats.org/drawingml/2006/main" prst="rect">
+            <a:avLst/>
+          </a:prstGeom>
+          <a:noFill xmlns:a="http://schemas.openxmlformats.org/drawingml/2006/main"/>
+          <a:ln xmlns:a="http://schemas.openxmlformats.org/drawingml/2006/main" w="0">
+            <a:noFill/>
+            <a:prstDash val="solid"/>
+          </a:ln>
+        </p:spPr>
+        <p:txBody>
+          <a:bodyPr xmlns:a="http://schemas.openxmlformats.org/drawingml/2006/main"/>
+          <a:lstStyle xmlns:a="http://schemas.openxmlformats.org/drawingml/2006/main"/>
+          <a:p xmlns:a="http://schemas.openxmlformats.org/drawingml/2006/main">
+            <a:pPr algn="l">
+              <a:buNone/>
+              <a:defRPr sz="1650" b="0" i="0">
+                <a:solidFill>
+                  <a:srgbClr val="111827"/>
+                </a:solidFill>
+              </a:defRPr>
+            </a:pPr>
+            <a:r>
+              <a:rPr sz="1650" b="0" i="0">
+                <a:solidFill>
+                  <a:srgbClr val="111827"/>
+                </a:solidFill>
+              </a:rPr>
+              <a:t>six measures passed</a:t>
+            </a:r>
+          </a:p>
+        </p:txBody>
+      </p:sp>
+      <p:sp>
+        <p:nvSpPr>
+          <p:cNvPr id="15" name="Oval 14">
+            <a:extLst xmlns:a="http://schemas.openxmlformats.org/drawingml/2006/main">
+              <a:ext uri="{FF2B5EF4-FFF2-40B4-BE49-F238E27FC236}">
+                <a16:creationId xmlns:a16="http://schemas.microsoft.com/office/drawing/2014/main" id="{9B61EC65-726A-42E5-8A14-F88873DDADC8}"/>
+              </a:ext>
+            </a:extLst>
+          </p:cNvPr>
+          <p:cNvSpPr>
+            <a:spLocks xmlns:a="http://schemas.openxmlformats.org/drawingml/2006/main" noGrp="1"/>
+          </p:cNvSpPr>
+          <p:nvPr/>
+        </p:nvSpPr>
+        <p:spPr>
+          <a:xfrm xmlns:a="http://schemas.openxmlformats.org/drawingml/2006/main">
+            <a:off x="7715250" y="4514850"/>
+            <a:ext cx="95250" cy="95250"/>
+          </a:xfrm>
+          <a:prstGeom xmlns:a="http://schemas.openxmlformats.org/drawingml/2006/main" prst="ellipse">
+            <a:avLst/>
+          </a:prstGeom>
+          <a:solidFill xmlns:a="http://schemas.openxmlformats.org/drawingml/2006/main">
+            <a:srgbClr val="1E62D0"/>
+          </a:solidFill>
+          <a:ln xmlns:a="http://schemas.openxmlformats.org/drawingml/2006/main" w="0">
+            <a:solidFill>
+              <a:srgbClr val="1E62D0"/>
+            </a:solidFill>
+            <a:prstDash val="solid"/>
+          </a:ln>
+        </p:spPr>
+        <p:txBody>
+          <a:bodyPr xmlns:a="http://schemas.openxmlformats.org/drawingml/2006/main"/>
+          <a:lstStyle xmlns:a="http://schemas.openxmlformats.org/drawingml/2006/main"/>
+          <a:p xmlns:a="http://schemas.openxmlformats.org/drawingml/2006/main">
+            <a:endParaRPr/>
+          </a:p>
+        </p:txBody>
+      </p:sp>
+      <p:sp>
+        <p:nvSpPr>
+          <p:cNvPr id="16" name="Rectangle 15">
+            <a:extLst xmlns:a="http://schemas.openxmlformats.org/drawingml/2006/main">
+              <a:ext uri="{FF2B5EF4-FFF2-40B4-BE49-F238E27FC236}">
+                <a16:creationId xmlns:a16="http://schemas.microsoft.com/office/drawing/2014/main" id="{E2FAF044-EC66-4706-B637-C6D60EBB3C5D}"/>
+              </a:ext>
+            </a:extLst>
+          </p:cNvPr>
+          <p:cNvSpPr>
+            <a:spLocks xmlns:a="http://schemas.openxmlformats.org/drawingml/2006/main" noGrp="1"/>
+          </p:cNvSpPr>
+          <p:nvPr/>
+        </p:nvSpPr>
+        <p:spPr>
+          <a:xfrm xmlns:a="http://schemas.openxmlformats.org/drawingml/2006/main">
+            <a:off x="7962900" y="4429125"/>
+            <a:ext cx="3295650" cy="485775"/>
+          </a:xfrm>
+          <a:prstGeom xmlns:a="http://schemas.openxmlformats.org/drawingml/2006/main" prst="rect">
+            <a:avLst/>
+          </a:prstGeom>
+          <a:noFill xmlns:a="http://schemas.openxmlformats.org/drawingml/2006/main"/>
+          <a:ln xmlns:a="http://schemas.openxmlformats.org/drawingml/2006/main" w="0">
+            <a:noFill/>
+            <a:prstDash val="solid"/>
+          </a:ln>
+        </p:spPr>
+        <p:txBody>
+          <a:bodyPr xmlns:a="http://schemas.openxmlformats.org/drawingml/2006/main"/>
+          <a:lstStyle xmlns:a="http://schemas.openxmlformats.org/drawingml/2006/main"/>
+          <a:p xmlns:a="http://schemas.openxmlformats.org/drawingml/2006/main">
+            <a:pPr algn="l">
+              <a:buNone/>
+              <a:defRPr sz="1650" b="0" i="0">
+                <a:solidFill>
+                  <a:srgbClr val="111827"/>
+                </a:solidFill>
+              </a:defRPr>
+            </a:pPr>
+            <a:r>
+              <a:rPr sz="1650" b="0" i="0">
+                <a:solidFill>
+                  <a:srgbClr val="111827"/>
+                </a:solidFill>
+              </a:rPr>
+              <a:t>the stored hashes still match</a:t>
+            </a:r>
+          </a:p>
+        </p:txBody>
+      </p:sp>
+      <p:sp>
+        <p:nvSpPr>
+          <p:cNvPr id="17" name="Oval 16">
+            <a:extLst xmlns:a="http://schemas.openxmlformats.org/drawingml/2006/main">
+              <a:ext uri="{FF2B5EF4-FFF2-40B4-BE49-F238E27FC236}">
+                <a16:creationId xmlns:a16="http://schemas.microsoft.com/office/drawing/2014/main" id="{968BD3E6-738E-48C7-9E19-224A5B1EC64E}"/>
+              </a:ext>
+            </a:extLst>
+          </p:cNvPr>
+          <p:cNvSpPr>
+            <a:spLocks xmlns:a="http://schemas.openxmlformats.org/drawingml/2006/main" noGrp="1"/>
+          </p:cNvSpPr>
+          <p:nvPr/>
+        </p:nvSpPr>
+        <p:spPr>
+          <a:xfrm xmlns:a="http://schemas.openxmlformats.org/drawingml/2006/main">
+            <a:off x="7715250" y="5038725"/>
+            <a:ext cx="95250" cy="95250"/>
+          </a:xfrm>
+          <a:prstGeom xmlns:a="http://schemas.openxmlformats.org/drawingml/2006/main" prst="ellipse">
+            <a:avLst/>
+          </a:prstGeom>
+          <a:solidFill xmlns:a="http://schemas.openxmlformats.org/drawingml/2006/main">
+            <a:srgbClr val="1E62D0"/>
+          </a:solidFill>
+          <a:ln xmlns:a="http://schemas.openxmlformats.org/drawingml/2006/main" w="0">
+            <a:solidFill>
+              <a:srgbClr val="1E62D0"/>
+            </a:solidFill>
+            <a:prstDash val="solid"/>
+          </a:ln>
+        </p:spPr>
+        <p:txBody>
+          <a:bodyPr xmlns:a="http://schemas.openxmlformats.org/drawingml/2006/main"/>
+          <a:lstStyle xmlns:a="http://schemas.openxmlformats.org/drawingml/2006/main"/>
+          <a:p xmlns:a="http://schemas.openxmlformats.org/drawingml/2006/main">
+            <a:endParaRPr/>
+          </a:p>
+        </p:txBody>
+      </p:sp>
+      <p:sp>
+        <p:nvSpPr>
+          <p:cNvPr id="18" name="Rectangle 17">
+            <a:extLst xmlns:a="http://schemas.openxmlformats.org/drawingml/2006/main">
+              <a:ext uri="{FF2B5EF4-FFF2-40B4-BE49-F238E27FC236}">
+                <a16:creationId xmlns:a16="http://schemas.microsoft.com/office/drawing/2014/main" id="{2EE3A2A8-7EED-41BA-AFB2-67B275860726}"/>
+              </a:ext>
+            </a:extLst>
+          </p:cNvPr>
+          <p:cNvSpPr>
+            <a:spLocks xmlns:a="http://schemas.openxmlformats.org/drawingml/2006/main" noGrp="1"/>
+          </p:cNvSpPr>
+          <p:nvPr/>
+        </p:nvSpPr>
+        <p:spPr>
+          <a:xfrm xmlns:a="http://schemas.openxmlformats.org/drawingml/2006/main">
+            <a:off x="7962900" y="4953000"/>
+            <a:ext cx="3295650" cy="485775"/>
+          </a:xfrm>
+          <a:prstGeom xmlns:a="http://schemas.openxmlformats.org/drawingml/2006/main" prst="rect">
+            <a:avLst/>
+          </a:prstGeom>
+          <a:noFill xmlns:a="http://schemas.openxmlformats.org/drawingml/2006/main"/>
+          <a:ln xmlns:a="http://schemas.openxmlformats.org/drawingml/2006/main" w="0">
+            <a:noFill/>
+            <a:prstDash val="solid"/>
+          </a:ln>
+        </p:spPr>
+        <p:txBody>
+          <a:bodyPr xmlns:a="http://schemas.openxmlformats.org/drawingml/2006/main"/>
+          <a:lstStyle xmlns:a="http://schemas.openxmlformats.org/drawingml/2006/main"/>
+          <a:p xmlns:a="http://schemas.openxmlformats.org/drawingml/2006/main">
+            <a:pPr algn="l">
+              <a:buNone/>
+              <a:defRPr sz="1650" b="0" i="0">
+                <a:solidFill>
+                  <a:srgbClr val="111827"/>
+                </a:solidFill>
+              </a:defRPr>
+            </a:pPr>
+            <a:r>
+              <a:rPr sz="1650" b="0" i="0">
+                <a:solidFill>
+                  <a:srgbClr val="111827"/>
+                </a:solidFill>
+              </a:rPr>
+              <a:t>the limits of the laboratory</a:t>
+            </a:r>
+          </a:p>
+        </p:txBody>
+      </p:sp>
+      <p:sp>
+        <p:nvSpPr>
+          <p:cNvPr id="19" name="Rectangle: Rounded Corners 18">
+            <a:extLst xmlns:a="http://schemas.openxmlformats.org/drawingml/2006/main">
+              <a:ext uri="{FF2B5EF4-FFF2-40B4-BE49-F238E27FC236}">
+                <a16:creationId xmlns:a16="http://schemas.microsoft.com/office/drawing/2014/main" id="{94EAA160-BA7C-4581-A092-2929D4E7AB97}"/>
+              </a:ext>
+            </a:extLst>
+          </p:cNvPr>
+          <p:cNvSpPr>
+            <a:spLocks xmlns:a="http://schemas.openxmlformats.org/drawingml/2006/main" noGrp="1"/>
+          </p:cNvSpPr>
+          <p:nvPr/>
+        </p:nvSpPr>
+        <p:spPr>
+          <a:xfrm xmlns:a="http://schemas.openxmlformats.org/drawingml/2006/main">
+            <a:off x="7715250" y="5581650"/>
+            <a:ext cx="3600450" cy="457200"/>
+          </a:xfrm>
+          <a:prstGeom xmlns:a="http://schemas.openxmlformats.org/drawingml/2006/main" prst="roundRect">
+            <a:avLst>
+              <a:gd name="adj" fmla="val 16667"/>
+            </a:avLst>
+          </a:prstGeom>
+          <a:solidFill xmlns:a="http://schemas.openxmlformats.org/drawingml/2006/main">
+            <a:srgbClr val="EAF5FB"/>
+          </a:solidFill>
+          <a:ln xmlns:a="http://schemas.openxmlformats.org/drawingml/2006/main" w="0">
+            <a:solidFill>
+              <a:srgbClr val="EAF5FB"/>
+            </a:solidFill>
+            <a:prstDash val="solid"/>
+          </a:ln>
+        </p:spPr>
+        <p:txBody>
+          <a:bodyPr xmlns:a="http://schemas.openxmlformats.org/drawingml/2006/main"/>
+          <a:lstStyle xmlns:a="http://schemas.openxmlformats.org/drawingml/2006/main"/>
+          <a:p xmlns:a="http://schemas.openxmlformats.org/drawingml/2006/main">
+            <a:endParaRPr/>
+          </a:p>
+        </p:txBody>
+      </p:sp>
+      <p:sp>
+        <p:nvSpPr>
+          <p:cNvPr id="20" name="Rectangle 19">
+            <a:extLst xmlns:a="http://schemas.openxmlformats.org/drawingml/2006/main">
+              <a:ext uri="{FF2B5EF4-FFF2-40B4-BE49-F238E27FC236}">
+                <a16:creationId xmlns:a16="http://schemas.microsoft.com/office/drawing/2014/main" id="{A2B81BFC-5F19-4C29-9553-F58BBE71F10A}"/>
+              </a:ext>
+            </a:extLst>
+          </p:cNvPr>
+          <p:cNvSpPr>
+            <a:spLocks xmlns:a="http://schemas.openxmlformats.org/drawingml/2006/main" noGrp="1"/>
+          </p:cNvSpPr>
+          <p:nvPr/>
+        </p:nvSpPr>
+        <p:spPr>
+          <a:xfrm xmlns:a="http://schemas.openxmlformats.org/drawingml/2006/main">
+            <a:off x="7886700" y="5695950"/>
+            <a:ext cx="3238500" cy="228600"/>
+          </a:xfrm>
+          <a:prstGeom xmlns:a="http://schemas.openxmlformats.org/drawingml/2006/main" prst="rect">
+            <a:avLst/>
+          </a:prstGeom>
+          <a:noFill xmlns:a="http://schemas.openxmlformats.org/drawingml/2006/main"/>
+          <a:ln xmlns:a="http://schemas.openxmlformats.org/drawingml/2006/main" w="0">
+            <a:noFill/>
+            <a:prstDash val="solid"/>
+          </a:ln>
+        </p:spPr>
+        <p:txBody>
+          <a:bodyPr xmlns:a="http://schemas.openxmlformats.org/drawingml/2006/main"/>
+          <a:lstStyle xmlns:a="http://schemas.openxmlformats.org/drawingml/2006/main"/>
+          <a:p xmlns:a="http://schemas.openxmlformats.org/drawingml/2006/main">
+            <a:pPr algn="ctr">
+              <a:buNone/>
+              <a:defRPr sz="1500" b="1" i="0">
+                <a:solidFill>
+                  <a:srgbClr val="1E62D0"/>
+                </a:solidFill>
+              </a:defRPr>
+            </a:pPr>
+            <a:r>
+              <a:rPr sz="1500" b="1" i="0">
+                <a:solidFill>
+                  <a:srgbClr val="1E62D0"/>
+                </a:solidFill>
+              </a:rPr>
+              <a:t>phase6-summary.json + metrics.json</a:t>
+            </a:r>
+          </a:p>
+        </p:txBody>
+      </p:sp>
+    </p:spTree>
+    <p:extLst>
+      <p:ext uri="{BB962C8B-B14F-4D97-AF65-F5344CB8AC3E}">
+        <p14:creationId xmlns:p14="http://schemas.microsoft.com/office/powerpoint/2010/main" val="538578883"/>
+      </p:ext>
+    </p:extLst>
+  </p:cSld>
+</p:sld>
+</file>
+
+<file path=ppt/slides/slide16.xml><?xml version="1.0" encoding="utf-8"?>
+<p:sld xmlns:p="http://schemas.openxmlformats.org/presentationml/2006/main">
+  <p:cSld>
+    <p:bg>
+      <p:bgPr>
+        <a:solidFill xmlns:a="http://schemas.openxmlformats.org/drawingml/2006/main">
+          <a:srgbClr val="FFFFFF"/>
+        </a:solidFill>
+      </p:bgPr>
+    </p:bg>
+    <p:spTree>
+      <p:nvGrpSpPr>
+        <p:cNvPr id="1" name=""/>
+        <p:cNvGrpSpPr/>
+        <p:nvPr/>
+      </p:nvGrpSpPr>
+      <p:grpSpPr>
+        <a:xfrm xmlns:a="http://schemas.openxmlformats.org/drawingml/2006/main"/>
+      </p:grpSpPr>
+      <p:sp>
+        <p:nvSpPr>
+          <p:cNvPr id="25" name="Rectangle 24">
+            <a:extLst xmlns:a="http://schemas.openxmlformats.org/drawingml/2006/main">
+              <a:ext uri="{FF2B5EF4-FFF2-40B4-BE49-F238E27FC236}">
+                <a16:creationId xmlns:a16="http://schemas.microsoft.com/office/drawing/2014/main" id="{94CBAD6B-DAAB-412F-8321-9F69087B22AB}"/>
+              </a:ext>
+            </a:extLst>
+          </p:cNvPr>
+          <p:cNvSpPr>
+            <a:spLocks xmlns:a="http://schemas.openxmlformats.org/drawingml/2006/main" noGrp="1"/>
+          </p:cNvSpPr>
+          <p:nvPr/>
+        </p:nvSpPr>
+        <p:spPr>
+          <a:xfrm xmlns:a="http://schemas.openxmlformats.org/drawingml/2006/main">
+            <a:off x="400050" y="323850"/>
+            <a:ext cx="2476500" cy="228600"/>
+          </a:xfrm>
+          <a:prstGeom xmlns:a="http://schemas.openxmlformats.org/drawingml/2006/main" prst="rect">
+            <a:avLst/>
+          </a:prstGeom>
+          <a:noFill xmlns:a="http://schemas.openxmlformats.org/drawingml/2006/main"/>
+          <a:ln xmlns:a="http://schemas.openxmlformats.org/drawingml/2006/main" w="0">
+            <a:noFill/>
+            <a:prstDash val="solid"/>
+          </a:ln>
+        </p:spPr>
+        <p:txBody>
+          <a:bodyPr xmlns:a="http://schemas.openxmlformats.org/drawingml/2006/main"/>
+          <a:lstStyle xmlns:a="http://schemas.openxmlformats.org/drawingml/2006/main"/>
+          <a:p xmlns:a="http://schemas.openxmlformats.org/drawingml/2006/main">
+            <a:pPr algn="l">
+              <a:buNone/>
+              <a:defRPr sz="1125" b="1" i="0">
+                <a:solidFill>
+                  <a:srgbClr val="1E62D0"/>
+                </a:solidFill>
+              </a:defRPr>
+            </a:pPr>
+            <a:r>
+              <a:rPr sz="1125" b="1" i="0">
+                <a:solidFill>
+                  <a:srgbClr val="1E62D0"/>
+                </a:solidFill>
+              </a:rPr>
+              <a:t>COMPLETED PATH</a:t>
+            </a:r>
+          </a:p>
+        </p:txBody>
+      </p:sp>
+      <p:sp>
+        <p:nvSpPr>
+          <p:cNvPr id="2" name="Rectangle 1">
+            <a:extLst xmlns:a="http://schemas.openxmlformats.org/drawingml/2006/main">
+              <a:ext uri="{FF2B5EF4-FFF2-40B4-BE49-F238E27FC236}">
+                <a16:creationId xmlns:a16="http://schemas.microsoft.com/office/drawing/2014/main" id="{7520C832-1D35-4A25-8BFB-0D1C0A6A294B}"/>
+              </a:ext>
+            </a:extLst>
+          </p:cNvPr>
+          <p:cNvSpPr>
+            <a:spLocks xmlns:a="http://schemas.openxmlformats.org/drawingml/2006/main" noGrp="1"/>
+          </p:cNvSpPr>
+          <p:nvPr/>
+        </p:nvSpPr>
+        <p:spPr>
+          <a:xfrm xmlns:a="http://schemas.openxmlformats.org/drawingml/2006/main">
+            <a:off x="400050" y="628650"/>
+            <a:ext cx="10668000" cy="523875"/>
+          </a:xfrm>
+          <a:prstGeom xmlns:a="http://schemas.openxmlformats.org/drawingml/2006/main" prst="rect">
+            <a:avLst/>
+          </a:prstGeom>
+          <a:noFill xmlns:a="http://schemas.openxmlformats.org/drawingml/2006/main"/>
+          <a:ln xmlns:a="http://schemas.openxmlformats.org/drawingml/2006/main" w="0">
+            <a:noFill/>
+            <a:prstDash val="solid"/>
+          </a:ln>
+        </p:spPr>
+        <p:txBody>
+          <a:bodyPr xmlns:a="http://schemas.openxmlformats.org/drawingml/2006/main"/>
+          <a:lstStyle xmlns:a="http://schemas.openxmlformats.org/drawingml/2006/main"/>
+          <a:p xmlns:a="http://schemas.openxmlformats.org/drawingml/2006/main">
+            <a:pPr algn="l">
+              <a:buNone/>
+              <a:defRPr sz="2925" b="1" i="0">
+                <a:solidFill>
+                  <a:srgbClr val="111827"/>
+                </a:solidFill>
+              </a:defRPr>
+            </a:pPr>
+            <a:r>
+              <a:rPr sz="2925" b="1" i="0">
+                <a:solidFill>
+                  <a:srgbClr val="111827"/>
+                </a:solidFill>
+              </a:rPr>
+              <a:t>The final three planned steps are complete</a:t>
+            </a:r>
+          </a:p>
+        </p:txBody>
+      </p:sp>
+      <p:sp>
+        <p:nvSpPr>
+          <p:cNvPr id="3" name="Rectangle 2">
+            <a:extLst xmlns:a="http://schemas.openxmlformats.org/drawingml/2006/main">
+              <a:ext uri="{FF2B5EF4-FFF2-40B4-BE49-F238E27FC236}">
+                <a16:creationId xmlns:a16="http://schemas.microsoft.com/office/drawing/2014/main" id="{BDFF7E09-8A6D-4FE0-A55B-CDC9EF13479E}"/>
+              </a:ext>
+            </a:extLst>
+          </p:cNvPr>
+          <p:cNvSpPr>
+            <a:spLocks xmlns:a="http://schemas.openxmlformats.org/drawingml/2006/main" noGrp="1"/>
+          </p:cNvSpPr>
+          <p:nvPr/>
+        </p:nvSpPr>
+        <p:spPr>
+          <a:xfrm xmlns:a="http://schemas.openxmlformats.org/drawingml/2006/main">
+            <a:off x="400050" y="1276350"/>
+            <a:ext cx="11391900" cy="9525"/>
+          </a:xfrm>
+          <a:prstGeom xmlns:a="http://schemas.openxmlformats.org/drawingml/2006/main" prst="rect">
+            <a:avLst/>
+          </a:prstGeom>
+          <a:solidFill xmlns:a="http://schemas.openxmlformats.org/drawingml/2006/main">
+            <a:srgbClr val="C8CED6"/>
+          </a:solidFill>
+          <a:ln xmlns:a="http://schemas.openxmlformats.org/drawingml/2006/main" w="0">
+            <a:solidFill>
+              <a:srgbClr val="C8CED6"/>
+            </a:solidFill>
+            <a:prstDash val="solid"/>
+          </a:ln>
+        </p:spPr>
+        <p:txBody>
+          <a:bodyPr xmlns:a="http://schemas.openxmlformats.org/drawingml/2006/main"/>
+          <a:lstStyle xmlns:a="http://schemas.openxmlformats.org/drawingml/2006/main"/>
+          <a:p xmlns:a="http://schemas.openxmlformats.org/drawingml/2006/main">
+            <a:endParaRPr/>
+          </a:p>
+        </p:txBody>
+      </p:sp>
+      <p:sp>
+        <p:nvSpPr>
+          <p:cNvPr id="4" name="Rectangle 3">
+            <a:extLst xmlns:a="http://schemas.openxmlformats.org/drawingml/2006/main">
+              <a:ext uri="{FF2B5EF4-FFF2-40B4-BE49-F238E27FC236}">
+                <a16:creationId xmlns:a16="http://schemas.microsoft.com/office/drawing/2014/main" id="{305EF95C-9829-4E4C-804C-6290ACCF34C3}"/>
+              </a:ext>
+            </a:extLst>
+          </p:cNvPr>
+          <p:cNvSpPr>
+            <a:spLocks xmlns:a="http://schemas.openxmlformats.org/drawingml/2006/main" noGrp="1"/>
+          </p:cNvSpPr>
+          <p:nvPr/>
+        </p:nvSpPr>
+        <p:spPr>
+          <a:xfrm xmlns:a="http://schemas.openxmlformats.org/drawingml/2006/main">
+            <a:off x="9715500" y="6286500"/>
+            <a:ext cx="2076450" cy="190500"/>
+          </a:xfrm>
+          <a:prstGeom xmlns:a="http://schemas.openxmlformats.org/drawingml/2006/main" prst="rect">
+            <a:avLst/>
+          </a:prstGeom>
+          <a:noFill xmlns:a="http://schemas.openxmlformats.org/drawingml/2006/main"/>
+          <a:ln xmlns:a="http://schemas.openxmlformats.org/drawingml/2006/main" w="0">
+            <a:noFill/>
+            <a:prstDash val="solid"/>
+          </a:ln>
+        </p:spPr>
+        <p:txBody>
+          <a:bodyPr xmlns:a="http://schemas.openxmlformats.org/drawingml/2006/main"/>
+          <a:lstStyle xmlns:a="http://schemas.openxmlformats.org/drawingml/2006/main"/>
+          <a:p xmlns:a="http://schemas.openxmlformats.org/drawingml/2006/main">
+            <a:pPr algn="r">
+              <a:buNone/>
+              <a:defRPr sz="975" b="0" i="0">
+                <a:solidFill>
+                  <a:srgbClr val="556070"/>
+                </a:solidFill>
+              </a:defRPr>
+            </a:pPr>
+            <a:r>
+              <a:rPr sz="975" b="0" i="0">
+                <a:solidFill>
+                  <a:srgbClr val="556070"/>
+                </a:solidFill>
+              </a:rPr>
+              <a:t>4 SEPTEMBER 2026  |  16</a:t>
+            </a:r>
+          </a:p>
+        </p:txBody>
+      </p:sp>
+      <p:sp>
+        <p:nvSpPr>
+          <p:cNvPr id="5" name="Rectangle 4">
+            <a:extLst xmlns:a="http://schemas.openxmlformats.org/drawingml/2006/main">
+              <a:ext uri="{FF2B5EF4-FFF2-40B4-BE49-F238E27FC236}">
+                <a16:creationId xmlns:a16="http://schemas.microsoft.com/office/drawing/2014/main" id="{848C6AE5-E49F-4FC1-89D8-0455A89E770A}"/>
+              </a:ext>
+            </a:extLst>
+          </p:cNvPr>
+          <p:cNvSpPr>
+            <a:spLocks xmlns:a="http://schemas.openxmlformats.org/drawingml/2006/main" noGrp="1"/>
+          </p:cNvSpPr>
+          <p:nvPr/>
+        </p:nvSpPr>
+        <p:spPr>
+          <a:xfrm xmlns:a="http://schemas.openxmlformats.org/drawingml/2006/main">
+            <a:off x="400050" y="1524000"/>
+            <a:ext cx="9048750" cy="342900"/>
+          </a:xfrm>
+          <a:prstGeom xmlns:a="http://schemas.openxmlformats.org/drawingml/2006/main" prst="rect">
+            <a:avLst/>
+          </a:prstGeom>
+          <a:noFill xmlns:a="http://schemas.openxmlformats.org/drawingml/2006/main"/>
+          <a:ln xmlns:a="http://schemas.openxmlformats.org/drawingml/2006/main" w="0">
+            <a:noFill/>
+            <a:prstDash val="solid"/>
+          </a:ln>
+        </p:spPr>
+        <p:txBody>
+          <a:bodyPr xmlns:a="http://schemas.openxmlformats.org/drawingml/2006/main"/>
+          <a:lstStyle xmlns:a="http://schemas.openxmlformats.org/drawingml/2006/main"/>
+          <a:p xmlns:a="http://schemas.openxmlformats.org/drawingml/2006/main">
+            <a:pPr algn="l">
+              <a:buNone/>
+              <a:defRPr sz="1800" b="0" i="0">
+                <a:solidFill>
+                  <a:srgbClr val="556070"/>
+                </a:solidFill>
+              </a:defRPr>
+            </a:pPr>
+            <a:r>
+              <a:rPr sz="1800" b="0" i="0">
+                <a:solidFill>
+                  <a:srgbClr val="556070"/>
+                </a:solidFill>
+              </a:rPr>
+              <a:t>These steps complete the evidence path from the running laboratory to a measured result.</a:t>
+            </a:r>
+          </a:p>
+        </p:txBody>
+      </p:sp>
+      <p:sp>
+        <p:nvSpPr>
+          <p:cNvPr id="6" name="Rectangle 5">
+            <a:extLst xmlns:a="http://schemas.openxmlformats.org/drawingml/2006/main">
+              <a:ext uri="{FF2B5EF4-FFF2-40B4-BE49-F238E27FC236}">
+                <a16:creationId xmlns:a16="http://schemas.microsoft.com/office/drawing/2014/main" id="{FAFC58AF-D44E-4494-B720-3AB43449A44E}"/>
+              </a:ext>
+            </a:extLst>
+          </p:cNvPr>
+          <p:cNvSpPr>
+            <a:spLocks xmlns:a="http://schemas.openxmlformats.org/drawingml/2006/main" noGrp="1"/>
+          </p:cNvSpPr>
+          <p:nvPr/>
+        </p:nvSpPr>
+        <p:spPr>
+          <a:xfrm xmlns:a="http://schemas.openxmlformats.org/drawingml/2006/main">
+            <a:off x="857250" y="3295650"/>
+            <a:ext cx="10458450" cy="19050"/>
+          </a:xfrm>
+          <a:prstGeom xmlns:a="http://schemas.openxmlformats.org/drawingml/2006/main" prst="rect">
+            <a:avLst/>
+          </a:prstGeom>
+          <a:solidFill xmlns:a="http://schemas.openxmlformats.org/drawingml/2006/main">
+            <a:srgbClr val="111827"/>
+          </a:solidFill>
+          <a:ln xmlns:a="http://schemas.openxmlformats.org/drawingml/2006/main" w="0">
+            <a:solidFill>
+              <a:srgbClr val="111827"/>
+            </a:solidFill>
+            <a:prstDash val="solid"/>
+          </a:ln>
+        </p:spPr>
+        <p:txBody>
+          <a:bodyPr xmlns:a="http://schemas.openxmlformats.org/drawingml/2006/main"/>
+          <a:lstStyle xmlns:a="http://schemas.openxmlformats.org/drawingml/2006/main"/>
+          <a:p xmlns:a="http://schemas.openxmlformats.org/drawingml/2006/main">
+            <a:endParaRPr/>
+          </a:p>
+        </p:txBody>
+      </p:sp>
+      <p:sp>
+        <p:nvSpPr>
+          <p:cNvPr id="7" name="Oval 6">
+            <a:extLst xmlns:a="http://schemas.openxmlformats.org/drawingml/2006/main">
+              <a:ext uri="{FF2B5EF4-FFF2-40B4-BE49-F238E27FC236}">
+                <a16:creationId xmlns:a16="http://schemas.microsoft.com/office/drawing/2014/main" id="{934F3F4F-1A15-4F4F-B98A-3B59DE2893D2}"/>
+              </a:ext>
+            </a:extLst>
+          </p:cNvPr>
+          <p:cNvSpPr>
+            <a:spLocks xmlns:a="http://schemas.openxmlformats.org/drawingml/2006/main" noGrp="1"/>
+          </p:cNvSpPr>
+          <p:nvPr/>
+        </p:nvSpPr>
+        <p:spPr>
+          <a:xfrm xmlns:a="http://schemas.openxmlformats.org/drawingml/2006/main">
+            <a:off x="876300" y="3143250"/>
+            <a:ext cx="304800" cy="304800"/>
+          </a:xfrm>
+          <a:prstGeom xmlns:a="http://schemas.openxmlformats.org/drawingml/2006/main" prst="ellipse">
+            <a:avLst/>
+          </a:prstGeom>
+          <a:solidFill xmlns:a="http://schemas.openxmlformats.org/drawingml/2006/main">
+            <a:srgbClr val="1E62D0"/>
+          </a:solidFill>
+          <a:ln xmlns:a="http://schemas.openxmlformats.org/drawingml/2006/main" w="0">
+            <a:solidFill>
+              <a:srgbClr val="1E62D0"/>
+            </a:solidFill>
+            <a:prstDash val="solid"/>
+          </a:ln>
+        </p:spPr>
+        <p:txBody>
+          <a:bodyPr xmlns:a="http://schemas.openxmlformats.org/drawingml/2006/main"/>
+          <a:lstStyle xmlns:a="http://schemas.openxmlformats.org/drawingml/2006/main"/>
+          <a:p xmlns:a="http://schemas.openxmlformats.org/drawingml/2006/main">
+            <a:endParaRPr/>
+          </a:p>
+        </p:txBody>
+      </p:sp>
+      <p:sp>
+        <p:nvSpPr>
+          <p:cNvPr id="8" name="Rectangle 7">
+            <a:extLst xmlns:a="http://schemas.openxmlformats.org/drawingml/2006/main">
+              <a:ext uri="{FF2B5EF4-FFF2-40B4-BE49-F238E27FC236}">
+                <a16:creationId xmlns:a16="http://schemas.microsoft.com/office/drawing/2014/main" id="{F1D08456-764B-4770-BC60-854AE8962175}"/>
+              </a:ext>
+            </a:extLst>
+          </p:cNvPr>
+          <p:cNvSpPr>
+            <a:spLocks xmlns:a="http://schemas.openxmlformats.org/drawingml/2006/main" noGrp="1"/>
+          </p:cNvSpPr>
+          <p:nvPr/>
+        </p:nvSpPr>
+        <p:spPr>
+          <a:xfrm xmlns:a="http://schemas.openxmlformats.org/drawingml/2006/main">
+            <a:off x="876300" y="3190875"/>
+            <a:ext cx="304800" cy="190500"/>
+          </a:xfrm>
+          <a:prstGeom xmlns:a="http://schemas.openxmlformats.org/drawingml/2006/main" prst="rect">
+            <a:avLst/>
+          </a:prstGeom>
+          <a:noFill xmlns:a="http://schemas.openxmlformats.org/drawingml/2006/main"/>
+          <a:ln xmlns:a="http://schemas.openxmlformats.org/drawingml/2006/main" w="0">
+            <a:noFill/>
+            <a:prstDash val="solid"/>
+          </a:ln>
+        </p:spPr>
+        <p:txBody>
+          <a:bodyPr xmlns:a="http://schemas.openxmlformats.org/drawingml/2006/main"/>
+          <a:lstStyle xmlns:a="http://schemas.openxmlformats.org/drawingml/2006/main"/>
+          <a:p xmlns:a="http://schemas.openxmlformats.org/drawingml/2006/main">
+            <a:pPr algn="ctr">
+              <a:buNone/>
+              <a:defRPr sz="1125" b="1" i="0">
+                <a:solidFill>
+                  <a:srgbClr val="FFFFFF"/>
+                </a:solidFill>
+              </a:defRPr>
+            </a:pPr>
+            <a:r>
+              <a:rPr sz="1125" b="1" i="0">
+                <a:solidFill>
+                  <a:srgbClr val="FFFFFF"/>
+                </a:solidFill>
+              </a:rPr>
+              <a:t>4</a:t>
+            </a:r>
+          </a:p>
+        </p:txBody>
+      </p:sp>
+      <p:sp>
+        <p:nvSpPr>
+          <p:cNvPr id="9" name="Rectangle 8">
+            <a:extLst xmlns:a="http://schemas.openxmlformats.org/drawingml/2006/main">
+              <a:ext uri="{FF2B5EF4-FFF2-40B4-BE49-F238E27FC236}">
+                <a16:creationId xmlns:a16="http://schemas.microsoft.com/office/drawing/2014/main" id="{9FDD871E-2155-47B4-9387-6F5503366B56}"/>
+              </a:ext>
+            </a:extLst>
+          </p:cNvPr>
+          <p:cNvSpPr>
+            <a:spLocks xmlns:a="http://schemas.openxmlformats.org/drawingml/2006/main" noGrp="1"/>
+          </p:cNvSpPr>
+          <p:nvPr/>
+        </p:nvSpPr>
+        <p:spPr>
+          <a:xfrm xmlns:a="http://schemas.openxmlformats.org/drawingml/2006/main">
+            <a:off x="876300" y="2400300"/>
+            <a:ext cx="2952750" cy="514350"/>
+          </a:xfrm>
+          <a:prstGeom xmlns:a="http://schemas.openxmlformats.org/drawingml/2006/main" prst="rect">
+            <a:avLst/>
+          </a:prstGeom>
+          <a:noFill xmlns:a="http://schemas.openxmlformats.org/drawingml/2006/main"/>
+          <a:ln xmlns:a="http://schemas.openxmlformats.org/drawingml/2006/main" w="0">
+            <a:noFill/>
+            <a:prstDash val="solid"/>
+          </a:ln>
+        </p:spPr>
+        <p:txBody>
+          <a:bodyPr xmlns:a="http://schemas.openxmlformats.org/drawingml/2006/main"/>
+          <a:lstStyle xmlns:a="http://schemas.openxmlformats.org/drawingml/2006/main"/>
+          <a:p xmlns:a="http://schemas.openxmlformats.org/drawingml/2006/main">
+            <a:pPr algn="l">
+              <a:buNone/>
+              <a:defRPr sz="2025" b="1" i="0">
+                <a:solidFill>
+                  <a:srgbClr val="111827"/>
+                </a:solidFill>
+              </a:defRPr>
+            </a:pPr>
+            <a:r>
+              <a:rPr sz="2025" b="1" i="0">
+                <a:solidFill>
+                  <a:srgbClr val="111827"/>
+                </a:solidFill>
+              </a:rPr>
+              <a:t>Explain slice decisions</a:t>
+            </a:r>
+          </a:p>
+        </p:txBody>
+      </p:sp>
+      <p:sp>
+        <p:nvSpPr>
+          <p:cNvPr id="10" name="Rectangle 9">
+            <a:extLst xmlns:a="http://schemas.openxmlformats.org/drawingml/2006/main">
+              <a:ext uri="{FF2B5EF4-FFF2-40B4-BE49-F238E27FC236}">
+                <a16:creationId xmlns:a16="http://schemas.microsoft.com/office/drawing/2014/main" id="{4401141E-FE2D-45EF-B3A1-4B84D1277FDC}"/>
+              </a:ext>
+            </a:extLst>
+          </p:cNvPr>
+          <p:cNvSpPr>
+            <a:spLocks xmlns:a="http://schemas.openxmlformats.org/drawingml/2006/main" noGrp="1"/>
+          </p:cNvSpPr>
+          <p:nvPr/>
+        </p:nvSpPr>
+        <p:spPr>
+          <a:xfrm xmlns:a="http://schemas.openxmlformats.org/drawingml/2006/main">
+            <a:off x="876300" y="3762375"/>
+            <a:ext cx="2895600" cy="1104900"/>
+          </a:xfrm>
+          <a:prstGeom xmlns:a="http://schemas.openxmlformats.org/drawingml/2006/main" prst="rect">
+            <a:avLst/>
+          </a:prstGeom>
+          <a:noFill xmlns:a="http://schemas.openxmlformats.org/drawingml/2006/main"/>
+          <a:ln xmlns:a="http://schemas.openxmlformats.org/drawingml/2006/main" w="0">
+            <a:noFill/>
+            <a:prstDash val="solid"/>
+          </a:ln>
+        </p:spPr>
+        <p:txBody>
+          <a:bodyPr xmlns:a="http://schemas.openxmlformats.org/drawingml/2006/main"/>
+          <a:lstStyle xmlns:a="http://schemas.openxmlformats.org/drawingml/2006/main"/>
+          <a:p xmlns:a="http://schemas.openxmlformats.org/drawingml/2006/main">
+            <a:pPr algn="l">
+              <a:buNone/>
+              <a:defRPr sz="1725" b="0" i="0">
+                <a:solidFill>
+                  <a:srgbClr val="556070"/>
+                </a:solidFill>
+              </a:defRPr>
+            </a:pPr>
+            <a:r>
+              <a:rPr sz="1725" b="0" i="0">
+                <a:solidFill>
+                  <a:srgbClr val="556070"/>
+                </a:solidFill>
+              </a:rPr>
+              <a:t>Use clear rules and retain the reason for every slice decision.</a:t>
+            </a:r>
+          </a:p>
+        </p:txBody>
+      </p:sp>
+      <p:sp>
+        <p:nvSpPr>
+          <p:cNvPr id="11" name="Rectangle: Rounded Corners 10">
+            <a:extLst xmlns:a="http://schemas.openxmlformats.org/drawingml/2006/main">
+              <a:ext uri="{FF2B5EF4-FFF2-40B4-BE49-F238E27FC236}">
+                <a16:creationId xmlns:a16="http://schemas.microsoft.com/office/drawing/2014/main" id="{036597CA-D27F-45A4-BD5C-C8A015927BE0}"/>
+              </a:ext>
+            </a:extLst>
+          </p:cNvPr>
+          <p:cNvSpPr>
+            <a:spLocks xmlns:a="http://schemas.openxmlformats.org/drawingml/2006/main" noGrp="1"/>
+          </p:cNvSpPr>
+          <p:nvPr/>
+        </p:nvSpPr>
+        <p:spPr>
+          <a:xfrm xmlns:a="http://schemas.openxmlformats.org/drawingml/2006/main">
+            <a:off x="876300" y="5181600"/>
+            <a:ext cx="1390650" cy="323850"/>
+          </a:xfrm>
+          <a:prstGeom xmlns:a="http://schemas.openxmlformats.org/drawingml/2006/main" prst="roundRect">
+            <a:avLst>
+              <a:gd name="adj" fmla="val 23529"/>
+            </a:avLst>
+          </a:prstGeom>
+          <a:solidFill xmlns:a="http://schemas.openxmlformats.org/drawingml/2006/main">
+            <a:srgbClr val="EAF5FB"/>
+          </a:solidFill>
+          <a:ln xmlns:a="http://schemas.openxmlformats.org/drawingml/2006/main" w="0">
+            <a:solidFill>
+              <a:srgbClr val="EAF5FB"/>
+            </a:solidFill>
+            <a:prstDash val="solid"/>
+          </a:ln>
+        </p:spPr>
+        <p:txBody>
+          <a:bodyPr xmlns:a="http://schemas.openxmlformats.org/drawingml/2006/main"/>
+          <a:lstStyle xmlns:a="http://schemas.openxmlformats.org/drawingml/2006/main"/>
+          <a:p xmlns:a="http://schemas.openxmlformats.org/drawingml/2006/main">
+            <a:endParaRPr/>
+          </a:p>
+        </p:txBody>
+      </p:sp>
+      <p:sp>
+        <p:nvSpPr>
+          <p:cNvPr id="12" name="Rectangle 11">
+            <a:extLst xmlns:a="http://schemas.openxmlformats.org/drawingml/2006/main">
+              <a:ext uri="{FF2B5EF4-FFF2-40B4-BE49-F238E27FC236}">
+                <a16:creationId xmlns:a16="http://schemas.microsoft.com/office/drawing/2014/main" id="{BD3C4AEA-2920-4036-9E6E-7423F6F154C0}"/>
+              </a:ext>
+            </a:extLst>
+          </p:cNvPr>
+          <p:cNvSpPr>
+            <a:spLocks xmlns:a="http://schemas.openxmlformats.org/drawingml/2006/main" noGrp="1"/>
+          </p:cNvSpPr>
+          <p:nvPr/>
+        </p:nvSpPr>
+        <p:spPr>
+          <a:xfrm xmlns:a="http://schemas.openxmlformats.org/drawingml/2006/main">
+            <a:off x="990600" y="5248275"/>
+            <a:ext cx="1162050" cy="190500"/>
+          </a:xfrm>
+          <a:prstGeom xmlns:a="http://schemas.openxmlformats.org/drawingml/2006/main" prst="rect">
+            <a:avLst/>
+          </a:prstGeom>
+          <a:noFill xmlns:a="http://schemas.openxmlformats.org/drawingml/2006/main"/>
+          <a:ln xmlns:a="http://schemas.openxmlformats.org/drawingml/2006/main" w="0">
+            <a:noFill/>
+            <a:prstDash val="solid"/>
+          </a:ln>
+        </p:spPr>
+        <p:txBody>
+          <a:bodyPr xmlns:a="http://schemas.openxmlformats.org/drawingml/2006/main"/>
+          <a:lstStyle xmlns:a="http://schemas.openxmlformats.org/drawingml/2006/main"/>
+          <a:p xmlns:a="http://schemas.openxmlformats.org/drawingml/2006/main">
+            <a:pPr algn="ctr">
+              <a:buNone/>
+              <a:defRPr sz="1050" b="1" i="0">
+                <a:solidFill>
+                  <a:srgbClr val="1E62D0"/>
+                </a:solidFill>
+              </a:defRPr>
+            </a:pPr>
+            <a:r>
+              <a:rPr sz="1050" b="1" i="0">
+                <a:solidFill>
+                  <a:srgbClr val="1E62D0"/>
+                </a:solidFill>
+              </a:rPr>
+              <a:t>COMPLETED</a:t>
+            </a:r>
+          </a:p>
+        </p:txBody>
+      </p:sp>
+      <p:sp>
+        <p:nvSpPr>
+          <p:cNvPr id="13" name="Oval 12">
+            <a:extLst xmlns:a="http://schemas.openxmlformats.org/drawingml/2006/main">
+              <a:ext uri="{FF2B5EF4-FFF2-40B4-BE49-F238E27FC236}">
+                <a16:creationId xmlns:a16="http://schemas.microsoft.com/office/drawing/2014/main" id="{32B6A1A2-1D23-4119-B147-36EFA5823651}"/>
+              </a:ext>
+            </a:extLst>
+          </p:cNvPr>
+          <p:cNvSpPr>
+            <a:spLocks xmlns:a="http://schemas.openxmlformats.org/drawingml/2006/main" noGrp="1"/>
+          </p:cNvSpPr>
+          <p:nvPr/>
+        </p:nvSpPr>
+        <p:spPr>
+          <a:xfrm xmlns:a="http://schemas.openxmlformats.org/drawingml/2006/main">
+            <a:off x="4343400" y="3143250"/>
+            <a:ext cx="304800" cy="304800"/>
+          </a:xfrm>
+          <a:prstGeom xmlns:a="http://schemas.openxmlformats.org/drawingml/2006/main" prst="ellipse">
+            <a:avLst/>
+          </a:prstGeom>
+          <a:solidFill xmlns:a="http://schemas.openxmlformats.org/drawingml/2006/main">
+            <a:srgbClr val="1E62D0"/>
+          </a:solidFill>
+          <a:ln xmlns:a="http://schemas.openxmlformats.org/drawingml/2006/main" w="0">
+            <a:solidFill>
+              <a:srgbClr val="1E62D0"/>
+            </a:solidFill>
+            <a:prstDash val="solid"/>
+          </a:ln>
+        </p:spPr>
+        <p:txBody>
+          <a:bodyPr xmlns:a="http://schemas.openxmlformats.org/drawingml/2006/main"/>
+          <a:lstStyle xmlns:a="http://schemas.openxmlformats.org/drawingml/2006/main"/>
+          <a:p xmlns:a="http://schemas.openxmlformats.org/drawingml/2006/main">
+            <a:endParaRPr/>
+          </a:p>
+        </p:txBody>
+      </p:sp>
+      <p:sp>
+        <p:nvSpPr>
+          <p:cNvPr id="14" name="Rectangle 13">
+            <a:extLst xmlns:a="http://schemas.openxmlformats.org/drawingml/2006/main">
+              <a:ext uri="{FF2B5EF4-FFF2-40B4-BE49-F238E27FC236}">
+                <a16:creationId xmlns:a16="http://schemas.microsoft.com/office/drawing/2014/main" id="{0A98F61E-F044-4F79-AA01-69764E6AA36E}"/>
+              </a:ext>
+            </a:extLst>
+          </p:cNvPr>
+          <p:cNvSpPr>
+            <a:spLocks xmlns:a="http://schemas.openxmlformats.org/drawingml/2006/main" noGrp="1"/>
+          </p:cNvSpPr>
+          <p:nvPr/>
+        </p:nvSpPr>
+        <p:spPr>
+          <a:xfrm xmlns:a="http://schemas.openxmlformats.org/drawingml/2006/main">
+            <a:off x="4343400" y="3190875"/>
+            <a:ext cx="304800" cy="190500"/>
+          </a:xfrm>
+          <a:prstGeom xmlns:a="http://schemas.openxmlformats.org/drawingml/2006/main" prst="rect">
+            <a:avLst/>
+          </a:prstGeom>
+          <a:noFill xmlns:a="http://schemas.openxmlformats.org/drawingml/2006/main"/>
+          <a:ln xmlns:a="http://schemas.openxmlformats.org/drawingml/2006/main" w="0">
+            <a:noFill/>
+            <a:prstDash val="solid"/>
+          </a:ln>
+        </p:spPr>
+        <p:txBody>
+          <a:bodyPr xmlns:a="http://schemas.openxmlformats.org/drawingml/2006/main"/>
+          <a:lstStyle xmlns:a="http://schemas.openxmlformats.org/drawingml/2006/main"/>
+          <a:p xmlns:a="http://schemas.openxmlformats.org/drawingml/2006/main">
+            <a:pPr algn="ctr">
+              <a:buNone/>
+              <a:defRPr sz="1125" b="1" i="0">
+                <a:solidFill>
+                  <a:srgbClr val="FFFFFF"/>
+                </a:solidFill>
+              </a:defRPr>
+            </a:pPr>
+            <a:r>
+              <a:rPr sz="1125" b="1" i="0">
+                <a:solidFill>
+                  <a:srgbClr val="FFFFFF"/>
+                </a:solidFill>
+              </a:rPr>
+              <a:t>5</a:t>
+            </a:r>
+          </a:p>
+        </p:txBody>
+      </p:sp>
+      <p:sp>
+        <p:nvSpPr>
+          <p:cNvPr id="15" name="Rectangle 14">
+            <a:extLst xmlns:a="http://schemas.openxmlformats.org/drawingml/2006/main">
+              <a:ext uri="{FF2B5EF4-FFF2-40B4-BE49-F238E27FC236}">
+                <a16:creationId xmlns:a16="http://schemas.microsoft.com/office/drawing/2014/main" id="{822F5938-F071-4161-B975-02E5CE714D41}"/>
+              </a:ext>
+            </a:extLst>
+          </p:cNvPr>
+          <p:cNvSpPr>
+            <a:spLocks xmlns:a="http://schemas.openxmlformats.org/drawingml/2006/main" noGrp="1"/>
+          </p:cNvSpPr>
+          <p:nvPr/>
+        </p:nvSpPr>
+        <p:spPr>
+          <a:xfrm xmlns:a="http://schemas.openxmlformats.org/drawingml/2006/main">
+            <a:off x="4343400" y="2400300"/>
+            <a:ext cx="2952750" cy="514350"/>
+          </a:xfrm>
+          <a:prstGeom xmlns:a="http://schemas.openxmlformats.org/drawingml/2006/main" prst="rect">
+            <a:avLst/>
+          </a:prstGeom>
+          <a:noFill xmlns:a="http://schemas.openxmlformats.org/drawingml/2006/main"/>
+          <a:ln xmlns:a="http://schemas.openxmlformats.org/drawingml/2006/main" w="0">
+            <a:noFill/>
+            <a:prstDash val="solid"/>
+          </a:ln>
+        </p:spPr>
+        <p:txBody>
+          <a:bodyPr xmlns:a="http://schemas.openxmlformats.org/drawingml/2006/main"/>
+          <a:lstStyle xmlns:a="http://schemas.openxmlformats.org/drawingml/2006/main"/>
+          <a:p xmlns:a="http://schemas.openxmlformats.org/drawingml/2006/main">
+            <a:pPr algn="l">
+              <a:buNone/>
+              <a:defRPr sz="2025" b="1" i="0">
+                <a:solidFill>
+                  <a:srgbClr val="111827"/>
+                </a:solidFill>
+              </a:defRPr>
+            </a:pPr>
+            <a:r>
+              <a:rPr sz="2025" b="1" i="0">
+                <a:solidFill>
+                  <a:srgbClr val="111827"/>
+                </a:solidFill>
+              </a:rPr>
+              <a:t>Protect and adapt evidence</a:t>
+            </a:r>
+          </a:p>
+        </p:txBody>
+      </p:sp>
+      <p:sp>
+        <p:nvSpPr>
+          <p:cNvPr id="16" name="Rectangle 15">
+            <a:extLst xmlns:a="http://schemas.openxmlformats.org/drawingml/2006/main">
+              <a:ext uri="{FF2B5EF4-FFF2-40B4-BE49-F238E27FC236}">
+                <a16:creationId xmlns:a16="http://schemas.microsoft.com/office/drawing/2014/main" id="{20E4E05B-CBA4-4128-AC25-17457B6738DE}"/>
+              </a:ext>
+            </a:extLst>
+          </p:cNvPr>
+          <p:cNvSpPr>
+            <a:spLocks xmlns:a="http://schemas.openxmlformats.org/drawingml/2006/main" noGrp="1"/>
+          </p:cNvSpPr>
+          <p:nvPr/>
+        </p:nvSpPr>
+        <p:spPr>
+          <a:xfrm xmlns:a="http://schemas.openxmlformats.org/drawingml/2006/main">
+            <a:off x="4343400" y="3762375"/>
+            <a:ext cx="2895600" cy="1104900"/>
+          </a:xfrm>
+          <a:prstGeom xmlns:a="http://schemas.openxmlformats.org/drawingml/2006/main" prst="rect">
+            <a:avLst/>
+          </a:prstGeom>
+          <a:noFill xmlns:a="http://schemas.openxmlformats.org/drawingml/2006/main"/>
+          <a:ln xmlns:a="http://schemas.openxmlformats.org/drawingml/2006/main" w="0">
+            <a:noFill/>
+            <a:prstDash val="solid"/>
+          </a:ln>
+        </p:spPr>
+        <p:txBody>
+          <a:bodyPr xmlns:a="http://schemas.openxmlformats.org/drawingml/2006/main"/>
+          <a:lstStyle xmlns:a="http://schemas.openxmlformats.org/drawingml/2006/main"/>
+          <a:p xmlns:a="http://schemas.openxmlformats.org/drawingml/2006/main">
+            <a:pPr algn="l">
+              <a:buNone/>
+              <a:defRPr sz="1725" b="0" i="0">
+                <a:solidFill>
+                  <a:srgbClr val="556070"/>
+                </a:solidFill>
+              </a:defRPr>
+            </a:pPr>
+            <a:r>
+              <a:rPr sz="1725" b="0" i="0">
+                <a:solidFill>
+                  <a:srgbClr val="556070"/>
+                </a:solidFill>
+              </a:rPr>
+              <a:t>Apply approved priority changes, record custody details and verify hashes.</a:t>
+            </a:r>
+          </a:p>
+        </p:txBody>
+      </p:sp>
+      <p:sp>
+        <p:nvSpPr>
+          <p:cNvPr id="17" name="Rectangle: Rounded Corners 16">
+            <a:extLst xmlns:a="http://schemas.openxmlformats.org/drawingml/2006/main">
+              <a:ext uri="{FF2B5EF4-FFF2-40B4-BE49-F238E27FC236}">
+                <a16:creationId xmlns:a16="http://schemas.microsoft.com/office/drawing/2014/main" id="{09A2C90D-0583-4782-BA29-6A072F0DC17B}"/>
+              </a:ext>
+            </a:extLst>
+          </p:cNvPr>
+          <p:cNvSpPr>
+            <a:spLocks xmlns:a="http://schemas.openxmlformats.org/drawingml/2006/main" noGrp="1"/>
+          </p:cNvSpPr>
+          <p:nvPr/>
+        </p:nvSpPr>
+        <p:spPr>
+          <a:xfrm xmlns:a="http://schemas.openxmlformats.org/drawingml/2006/main">
+            <a:off x="4343400" y="5181600"/>
+            <a:ext cx="1390650" cy="323850"/>
+          </a:xfrm>
+          <a:prstGeom xmlns:a="http://schemas.openxmlformats.org/drawingml/2006/main" prst="roundRect">
+            <a:avLst>
+              <a:gd name="adj" fmla="val 23529"/>
+            </a:avLst>
+          </a:prstGeom>
+          <a:solidFill xmlns:a="http://schemas.openxmlformats.org/drawingml/2006/main">
+            <a:srgbClr val="EAF5FB"/>
+          </a:solidFill>
+          <a:ln xmlns:a="http://schemas.openxmlformats.org/drawingml/2006/main" w="0">
+            <a:solidFill>
+              <a:srgbClr val="EAF5FB"/>
+            </a:solidFill>
+            <a:prstDash val="solid"/>
+          </a:ln>
+        </p:spPr>
+        <p:txBody>
+          <a:bodyPr xmlns:a="http://schemas.openxmlformats.org/drawingml/2006/main"/>
+          <a:lstStyle xmlns:a="http://schemas.openxmlformats.org/drawingml/2006/main"/>
+          <a:p xmlns:a="http://schemas.openxmlformats.org/drawingml/2006/main">
+            <a:endParaRPr/>
+          </a:p>
+        </p:txBody>
+      </p:sp>
+      <p:sp>
+        <p:nvSpPr>
+          <p:cNvPr id="18" name="Rectangle 17">
+            <a:extLst xmlns:a="http://schemas.openxmlformats.org/drawingml/2006/main">
+              <a:ext uri="{FF2B5EF4-FFF2-40B4-BE49-F238E27FC236}">
+                <a16:creationId xmlns:a16="http://schemas.microsoft.com/office/drawing/2014/main" id="{ED1C71E3-5D01-4C56-8FB9-5B809597B876}"/>
+              </a:ext>
+            </a:extLst>
+          </p:cNvPr>
+          <p:cNvSpPr>
+            <a:spLocks xmlns:a="http://schemas.openxmlformats.org/drawingml/2006/main" noGrp="1"/>
+          </p:cNvSpPr>
+          <p:nvPr/>
+        </p:nvSpPr>
+        <p:spPr>
+          <a:xfrm xmlns:a="http://schemas.openxmlformats.org/drawingml/2006/main">
+            <a:off x="4457700" y="5248275"/>
+            <a:ext cx="1162050" cy="190500"/>
+          </a:xfrm>
+          <a:prstGeom xmlns:a="http://schemas.openxmlformats.org/drawingml/2006/main" prst="rect">
+            <a:avLst/>
+          </a:prstGeom>
+          <a:noFill xmlns:a="http://schemas.openxmlformats.org/drawingml/2006/main"/>
+          <a:ln xmlns:a="http://schemas.openxmlformats.org/drawingml/2006/main" w="0">
+            <a:noFill/>
+            <a:prstDash val="solid"/>
+          </a:ln>
+        </p:spPr>
+        <p:txBody>
+          <a:bodyPr xmlns:a="http://schemas.openxmlformats.org/drawingml/2006/main"/>
+          <a:lstStyle xmlns:a="http://schemas.openxmlformats.org/drawingml/2006/main"/>
+          <a:p xmlns:a="http://schemas.openxmlformats.org/drawingml/2006/main">
+            <a:pPr algn="ctr">
+              <a:buNone/>
+              <a:defRPr sz="1050" b="1" i="0">
+                <a:solidFill>
+                  <a:srgbClr val="1E62D0"/>
+                </a:solidFill>
+              </a:defRPr>
+            </a:pPr>
+            <a:r>
+              <a:rPr sz="1050" b="1" i="0">
+                <a:solidFill>
+                  <a:srgbClr val="1E62D0"/>
+                </a:solidFill>
+              </a:rPr>
+              <a:t>COMPLETED</a:t>
+            </a:r>
+          </a:p>
+        </p:txBody>
+      </p:sp>
+      <p:sp>
+        <p:nvSpPr>
+          <p:cNvPr id="19" name="Oval 18">
+            <a:extLst xmlns:a="http://schemas.openxmlformats.org/drawingml/2006/main">
+              <a:ext uri="{FF2B5EF4-FFF2-40B4-BE49-F238E27FC236}">
+                <a16:creationId xmlns:a16="http://schemas.microsoft.com/office/drawing/2014/main" id="{5BDFD525-6EF4-400B-9DC7-8C61AECAAA3D}"/>
+              </a:ext>
+            </a:extLst>
+          </p:cNvPr>
+          <p:cNvSpPr>
+            <a:spLocks xmlns:a="http://schemas.openxmlformats.org/drawingml/2006/main" noGrp="1"/>
+          </p:cNvSpPr>
+          <p:nvPr/>
+        </p:nvSpPr>
+        <p:spPr>
+          <a:xfrm xmlns:a="http://schemas.openxmlformats.org/drawingml/2006/main">
+            <a:off x="7810500" y="3143250"/>
+            <a:ext cx="304800" cy="304800"/>
+          </a:xfrm>
+          <a:prstGeom xmlns:a="http://schemas.openxmlformats.org/drawingml/2006/main" prst="ellipse">
+            <a:avLst/>
+          </a:prstGeom>
+          <a:solidFill xmlns:a="http://schemas.openxmlformats.org/drawingml/2006/main">
+            <a:srgbClr val="1E62D0"/>
+          </a:solidFill>
+          <a:ln xmlns:a="http://schemas.openxmlformats.org/drawingml/2006/main" w="0">
+            <a:solidFill>
+              <a:srgbClr val="1E62D0"/>
+            </a:solidFill>
+            <a:prstDash val="solid"/>
+          </a:ln>
+        </p:spPr>
+        <p:txBody>
+          <a:bodyPr xmlns:a="http://schemas.openxmlformats.org/drawingml/2006/main"/>
+          <a:lstStyle xmlns:a="http://schemas.openxmlformats.org/drawingml/2006/main"/>
+          <a:p xmlns:a="http://schemas.openxmlformats.org/drawingml/2006/main">
+            <a:endParaRPr/>
+          </a:p>
+        </p:txBody>
+      </p:sp>
+      <p:sp>
+        <p:nvSpPr>
+          <p:cNvPr id="20" name="Rectangle 19">
+            <a:extLst xmlns:a="http://schemas.openxmlformats.org/drawingml/2006/main">
+              <a:ext uri="{FF2B5EF4-FFF2-40B4-BE49-F238E27FC236}">
+                <a16:creationId xmlns:a16="http://schemas.microsoft.com/office/drawing/2014/main" id="{AF1F9C33-919B-4DD4-A806-3B3773CC4117}"/>
+              </a:ext>
+            </a:extLst>
+          </p:cNvPr>
+          <p:cNvSpPr>
+            <a:spLocks xmlns:a="http://schemas.openxmlformats.org/drawingml/2006/main" noGrp="1"/>
+          </p:cNvSpPr>
+          <p:nvPr/>
+        </p:nvSpPr>
+        <p:spPr>
+          <a:xfrm xmlns:a="http://schemas.openxmlformats.org/drawingml/2006/main">
+            <a:off x="7810500" y="3190875"/>
+            <a:ext cx="304800" cy="190500"/>
+          </a:xfrm>
+          <a:prstGeom xmlns:a="http://schemas.openxmlformats.org/drawingml/2006/main" prst="rect">
+            <a:avLst/>
+          </a:prstGeom>
+          <a:noFill xmlns:a="http://schemas.openxmlformats.org/drawingml/2006/main"/>
+          <a:ln xmlns:a="http://schemas.openxmlformats.org/drawingml/2006/main" w="0">
+            <a:noFill/>
+            <a:prstDash val="solid"/>
+          </a:ln>
+        </p:spPr>
+        <p:txBody>
+          <a:bodyPr xmlns:a="http://schemas.openxmlformats.org/drawingml/2006/main"/>
+          <a:lstStyle xmlns:a="http://schemas.openxmlformats.org/drawingml/2006/main"/>
+          <a:p xmlns:a="http://schemas.openxmlformats.org/drawingml/2006/main">
+            <a:pPr algn="ctr">
+              <a:buNone/>
+              <a:defRPr sz="1125" b="1" i="0">
+                <a:solidFill>
+                  <a:srgbClr val="FFFFFF"/>
+                </a:solidFill>
+              </a:defRPr>
+            </a:pPr>
+            <a:r>
+              <a:rPr sz="1125" b="1" i="0">
+                <a:solidFill>
+                  <a:srgbClr val="FFFFFF"/>
+                </a:solidFill>
+              </a:rPr>
+              <a:t>6</a:t>
+            </a:r>
+          </a:p>
+        </p:txBody>
+      </p:sp>
+      <p:sp>
+        <p:nvSpPr>
+          <p:cNvPr id="21" name="Rectangle 20">
+            <a:extLst xmlns:a="http://schemas.openxmlformats.org/drawingml/2006/main">
+              <a:ext uri="{FF2B5EF4-FFF2-40B4-BE49-F238E27FC236}">
+                <a16:creationId xmlns:a16="http://schemas.microsoft.com/office/drawing/2014/main" id="{78A10911-82C2-4C4E-B2AC-C3236D25544C}"/>
+              </a:ext>
+            </a:extLst>
+          </p:cNvPr>
+          <p:cNvSpPr>
+            <a:spLocks xmlns:a="http://schemas.openxmlformats.org/drawingml/2006/main" noGrp="1"/>
+          </p:cNvSpPr>
+          <p:nvPr/>
+        </p:nvSpPr>
+        <p:spPr>
+          <a:xfrm xmlns:a="http://schemas.openxmlformats.org/drawingml/2006/main">
+            <a:off x="7810500" y="2400300"/>
+            <a:ext cx="2952750" cy="514350"/>
+          </a:xfrm>
+          <a:prstGeom xmlns:a="http://schemas.openxmlformats.org/drawingml/2006/main" prst="rect">
+            <a:avLst/>
+          </a:prstGeom>
+          <a:noFill xmlns:a="http://schemas.openxmlformats.org/drawingml/2006/main"/>
+          <a:ln xmlns:a="http://schemas.openxmlformats.org/drawingml/2006/main" w="0">
+            <a:noFill/>
+            <a:prstDash val="solid"/>
+          </a:ln>
+        </p:spPr>
+        <p:txBody>
+          <a:bodyPr xmlns:a="http://schemas.openxmlformats.org/drawingml/2006/main"/>
+          <a:lstStyle xmlns:a="http://schemas.openxmlformats.org/drawingml/2006/main"/>
+          <a:p xmlns:a="http://schemas.openxmlformats.org/drawingml/2006/main">
+            <a:pPr algn="l">
+              <a:buNone/>
+              <a:defRPr sz="2025" b="1" i="0">
+                <a:solidFill>
+                  <a:srgbClr val="111827"/>
+                </a:solidFill>
+              </a:defRPr>
+            </a:pPr>
+            <a:r>
+              <a:rPr sz="2025" b="1" i="0">
+                <a:solidFill>
+                  <a:srgbClr val="111827"/>
+                </a:solidFill>
+              </a:rPr>
+              <a:t>Evaluate the prototype</a:t>
+            </a:r>
+          </a:p>
+        </p:txBody>
+      </p:sp>
+      <p:sp>
+        <p:nvSpPr>
+          <p:cNvPr id="22" name="Rectangle 21">
+            <a:extLst xmlns:a="http://schemas.openxmlformats.org/drawingml/2006/main">
+              <a:ext uri="{FF2B5EF4-FFF2-40B4-BE49-F238E27FC236}">
+                <a16:creationId xmlns:a16="http://schemas.microsoft.com/office/drawing/2014/main" id="{FFE6E3FF-8D7A-4722-87DA-26B71FE18237}"/>
+              </a:ext>
+            </a:extLst>
+          </p:cNvPr>
+          <p:cNvSpPr>
+            <a:spLocks xmlns:a="http://schemas.openxmlformats.org/drawingml/2006/main" noGrp="1"/>
+          </p:cNvSpPr>
+          <p:nvPr/>
+        </p:nvSpPr>
+        <p:spPr>
+          <a:xfrm xmlns:a="http://schemas.openxmlformats.org/drawingml/2006/main">
+            <a:off x="7810500" y="3762375"/>
+            <a:ext cx="2895600" cy="1104900"/>
+          </a:xfrm>
+          <a:prstGeom xmlns:a="http://schemas.openxmlformats.org/drawingml/2006/main" prst="rect">
+            <a:avLst/>
+          </a:prstGeom>
+          <a:noFill xmlns:a="http://schemas.openxmlformats.org/drawingml/2006/main"/>
+          <a:ln xmlns:a="http://schemas.openxmlformats.org/drawingml/2006/main" w="0">
+            <a:noFill/>
+            <a:prstDash val="solid"/>
+          </a:ln>
+        </p:spPr>
+        <p:txBody>
+          <a:bodyPr xmlns:a="http://schemas.openxmlformats.org/drawingml/2006/main"/>
+          <a:lstStyle xmlns:a="http://schemas.openxmlformats.org/drawingml/2006/main"/>
+          <a:p xmlns:a="http://schemas.openxmlformats.org/drawingml/2006/main">
+            <a:pPr algn="l">
+              <a:buNone/>
+              <a:defRPr sz="1725" b="0" i="0">
+                <a:solidFill>
+                  <a:srgbClr val="556070"/>
+                </a:solidFill>
+              </a:defRPr>
+            </a:pPr>
+            <a:r>
+              <a:rPr sz="1725" b="0" i="0">
+                <a:solidFill>
+                  <a:srgbClr val="556070"/>
+                </a:solidFill>
+              </a:rPr>
+              <a:t>Compare all five scenarios with ground truth and record the measures.</a:t>
+            </a:r>
+          </a:p>
+        </p:txBody>
+      </p:sp>
+      <p:sp>
+        <p:nvSpPr>
+          <p:cNvPr id="23" name="Rectangle: Rounded Corners 22">
+            <a:extLst xmlns:a="http://schemas.openxmlformats.org/drawingml/2006/main">
+              <a:ext uri="{FF2B5EF4-FFF2-40B4-BE49-F238E27FC236}">
+                <a16:creationId xmlns:a16="http://schemas.microsoft.com/office/drawing/2014/main" id="{324EC9D9-D9BC-4162-A1DA-C02D86D45429}"/>
+              </a:ext>
+            </a:extLst>
+          </p:cNvPr>
+          <p:cNvSpPr>
+            <a:spLocks xmlns:a="http://schemas.openxmlformats.org/drawingml/2006/main" noGrp="1"/>
+          </p:cNvSpPr>
+          <p:nvPr/>
+        </p:nvSpPr>
+        <p:spPr>
+          <a:xfrm xmlns:a="http://schemas.openxmlformats.org/drawingml/2006/main">
+            <a:off x="7810500" y="5181600"/>
+            <a:ext cx="1390650" cy="323850"/>
+          </a:xfrm>
+          <a:prstGeom xmlns:a="http://schemas.openxmlformats.org/drawingml/2006/main" prst="roundRect">
+            <a:avLst>
+              <a:gd name="adj" fmla="val 23529"/>
+            </a:avLst>
+          </a:prstGeom>
+          <a:solidFill xmlns:a="http://schemas.openxmlformats.org/drawingml/2006/main">
+            <a:srgbClr val="EAF5FB"/>
+          </a:solidFill>
+          <a:ln xmlns:a="http://schemas.openxmlformats.org/drawingml/2006/main" w="0">
+            <a:solidFill>
+              <a:srgbClr val="EAF5FB"/>
+            </a:solidFill>
+            <a:prstDash val="solid"/>
+          </a:ln>
+        </p:spPr>
+        <p:txBody>
+          <a:bodyPr xmlns:a="http://schemas.openxmlformats.org/drawingml/2006/main"/>
+          <a:lstStyle xmlns:a="http://schemas.openxmlformats.org/drawingml/2006/main"/>
+          <a:p xmlns:a="http://schemas.openxmlformats.org/drawingml/2006/main">
+            <a:endParaRPr/>
+          </a:p>
+        </p:txBody>
+      </p:sp>
+      <p:sp>
+        <p:nvSpPr>
+          <p:cNvPr id="24" name="Rectangle 23">
+            <a:extLst xmlns:a="http://schemas.openxmlformats.org/drawingml/2006/main">
+              <a:ext uri="{FF2B5EF4-FFF2-40B4-BE49-F238E27FC236}">
+                <a16:creationId xmlns:a16="http://schemas.microsoft.com/office/drawing/2014/main" id="{1D78163A-92B6-421E-94EF-17B7D5F33A8C}"/>
+              </a:ext>
+            </a:extLst>
+          </p:cNvPr>
+          <p:cNvSpPr>
+            <a:spLocks xmlns:a="http://schemas.openxmlformats.org/drawingml/2006/main" noGrp="1"/>
+          </p:cNvSpPr>
+          <p:nvPr/>
+        </p:nvSpPr>
+        <p:spPr>
+          <a:xfrm xmlns:a="http://schemas.openxmlformats.org/drawingml/2006/main">
+            <a:off x="7924800" y="5248275"/>
+            <a:ext cx="1162050" cy="190500"/>
+          </a:xfrm>
+          <a:prstGeom xmlns:a="http://schemas.openxmlformats.org/drawingml/2006/main" prst="rect">
+            <a:avLst/>
+          </a:prstGeom>
+          <a:noFill xmlns:a="http://schemas.openxmlformats.org/drawingml/2006/main"/>
+          <a:ln xmlns:a="http://schemas.openxmlformats.org/drawingml/2006/main" w="0">
+            <a:noFill/>
+            <a:prstDash val="solid"/>
+          </a:ln>
+        </p:spPr>
+        <p:txBody>
+          <a:bodyPr xmlns:a="http://schemas.openxmlformats.org/drawingml/2006/main"/>
+          <a:lstStyle xmlns:a="http://schemas.openxmlformats.org/drawingml/2006/main"/>
+          <a:p xmlns:a="http://schemas.openxmlformats.org/drawingml/2006/main">
+            <a:pPr algn="ctr">
+              <a:buNone/>
+              <a:defRPr sz="1050" b="1" i="0">
+                <a:solidFill>
+                  <a:srgbClr val="1E62D0"/>
+                </a:solidFill>
+              </a:defRPr>
+            </a:pPr>
+            <a:r>
+              <a:rPr sz="1050" b="1" i="0">
+                <a:solidFill>
+                  <a:srgbClr val="1E62D0"/>
+                </a:solidFill>
+              </a:rPr>
+              <a:t>COMPLETED</a:t>
+            </a:r>
+          </a:p>
+        </p:txBody>
+      </p:sp>
+    </p:spTree>
+    <p:extLst>
+      <p:ext uri="{BB962C8B-B14F-4D97-AF65-F5344CB8AC3E}">
+        <p14:creationId xmlns:p14="http://schemas.microsoft.com/office/powerpoint/2010/main" val="1394614163"/>
       </p:ext>
     </p:extLst>
   </p:cSld>
@@ -7434,7 +11648,7 @@
           <p:nvPr/>
         </p:nvPicPr>
         <p:blipFill>
-          <a:blip xmlns:r="http://schemas.openxmlformats.org/officeDocument/2006/relationships" xmlns:a="http://schemas.openxmlformats.org/drawingml/2006/main" r:embed="R543ea0948ccf4e95"/>
+          <a:blip xmlns:r="http://schemas.openxmlformats.org/officeDocument/2006/relationships" xmlns:a="http://schemas.openxmlformats.org/drawingml/2006/main" r:embed="R0a21dc15ff37414e"/>
           <a:stretch xmlns:a="http://schemas.openxmlformats.org/drawingml/2006/main"/>
         </p:blipFill>
         <p:spPr>
@@ -7773,7 +11987,7 @@
           <p:nvPr/>
         </p:nvPicPr>
         <p:blipFill>
-          <a:blip xmlns:r="http://schemas.openxmlformats.org/officeDocument/2006/relationships" xmlns:a="http://schemas.openxmlformats.org/drawingml/2006/main" r:embed="Rdf80284841e245d7"/>
+          <a:blip xmlns:r="http://schemas.openxmlformats.org/officeDocument/2006/relationships" xmlns:a="http://schemas.openxmlformats.org/drawingml/2006/main" r:embed="Rd0aa724620e2436b"/>
           <a:stretch xmlns:a="http://schemas.openxmlformats.org/drawingml/2006/main"/>
         </p:blipFill>
         <p:spPr>
@@ -8682,8 +12896,11 @@
           <p:nvPr/>
         </p:nvPicPr>
         <p:blipFill>
-          <a:blip xmlns:r="http://schemas.openxmlformats.org/officeDocument/2006/relationships" xmlns:a="http://schemas.openxmlformats.org/drawingml/2006/main" r:embed="Rb1781ebac90f4255"/>
-          <a:stretch xmlns:a="http://schemas.openxmlformats.org/drawingml/2006/main"/>
+          <a:blip xmlns:r="http://schemas.openxmlformats.org/officeDocument/2006/relationships" xmlns:a="http://schemas.openxmlformats.org/drawingml/2006/main" r:embed="R0233be98ca9341b4"/>
+          <a:srcRect xmlns:a="http://schemas.openxmlformats.org/drawingml/2006/main" l="353" t="0" r="353" b="0"/>
+          <a:stretch xmlns:a="http://schemas.openxmlformats.org/drawingml/2006/main">
+            <a:fillRect l="0" t="0" r="0" b="0"/>
+          </a:stretch>
         </p:blipFill>
         <p:spPr>
           <a:xfrm xmlns:a="http://schemas.openxmlformats.org/drawingml/2006/main">
@@ -11387,7 +15604,7 @@
           <p:nvPr/>
         </p:nvPicPr>
         <p:blipFill>
-          <a:blip xmlns:r="http://schemas.openxmlformats.org/officeDocument/2006/relationships" xmlns:a="http://schemas.openxmlformats.org/drawingml/2006/main" r:embed="R855899d590eb48a4"/>
+          <a:blip xmlns:r="http://schemas.openxmlformats.org/officeDocument/2006/relationships" xmlns:a="http://schemas.openxmlformats.org/drawingml/2006/main" r:embed="R4780f8e632c840cc"/>
           <a:stretch xmlns:a="http://schemas.openxmlformats.org/drawingml/2006/main"/>
         </p:blipFill>
         <p:spPr>

</xml_diff>